<commit_message>
Workshop 1: final review edits
- Report: wording kept to course terms, force split spelled out, new GUI screenshot
- Slides: clearer small-example slide, speaker notes with timing (about 10 minutes)
- GUI: label overlaps fixed, storm log names regions
</commit_message>
<xml_diff>
--- a/deliverables/02-workshop1-slides.pptx
+++ b/deliverables/02-workshop1-slides.pptx
@@ -118,20 +118,20 @@
   <p:extLst>
     <p:ext uri="{521415D9-36F7-43E2-AB2F-B90AF26B5E84}">
       <p14:sectionLst xmlns:p14="http://schemas.microsoft.com/office/powerpoint/2010/main">
-        <p14:section name="Introduction" id="{b3c30ed8-a324-04e5-1373-d447df83b2f2}">
+        <p14:section name="Introduction" id="{dda799a5-67a0-4af2-a0fa-d0581d00b8b3}">
           <p14:sldIdLst>
             <p14:sldId id="256"/>
             <p14:sldId id="257"/>
             <p14:sldId id="258"/>
           </p14:sldIdLst>
         </p14:section>
-        <p14:section name="Model" id="{b8cc2719-3056-5444-bd12-b84543ae073e}">
+        <p14:section name="Model" id="{2bb7dabf-79f3-0a5b-5a61-a8269a8bcffe}">
           <p14:sldIdLst>
             <p14:sldId id="259"/>
             <p14:sldId id="260"/>
           </p14:sldIdLst>
         </p14:section>
-        <p14:section name="Results" id="{609d7283-0c25-4d75-ec84-e01a7bfb4fe8}">
+        <p14:section name="Results" id="{65bec3ae-7f8b-a9fe-5d9f-d3cdc5148e70}">
           <p14:sldIdLst>
             <p14:sldId id="261"/>
             <p14:sldId id="262"/>
@@ -141,7 +141,7 @@
             <p14:sldId id="266"/>
           </p14:sldIdLst>
         </p14:section>
-        <p14:section name="Next steps" id="{44240eb0-bac6-37ab-e7e1-02a835a15681}">
+        <p14:section name="Next steps" id="{2ce56c99-754a-7463-d5af-25e00e80683c}">
           <p14:sldIdLst>
             <p14:sldId id="267"/>
           </p14:sldIdLst>
@@ -1288,7 +1288,7 @@
           <a:p>
             <a:r>
               <a:rPr lang="en-US" dirty="0"/>
-              <a:t>We model day-to-day U.S.-China competition for control of waters inside the First Island Chain, below the threshold of war, as a game on a network. Today: the model, the prototype, and first results on our three research questions.</a:t>
+              <a:t>(~30 s) We study day-to-day U.S.-China competition for control of the waters inside the First Island Chain, below the threshold of war. We built it as a game on a network. Today: the model, the prototype, and first results on three research questions.</a:t>
             </a:r>
             <a:endParaRPr lang="en-US" dirty="0"/>
           </a:p>
@@ -1376,7 +1376,7 @@
           <a:p>
             <a:r>
               <a:rPr lang="en-US" dirty="0"/>
-              <a:t>Robustness in the Lecture 1 sense: expected payoff over the weather scenarios and worst-case payoff. The hotline also raises Red's payoff, because fewer wars help both sides: it is a joint gain, not a Blue advantage.</a:t>
+              <a:t>(~70 s) Robustness in the Lecture 1 sense: expected payoff over the four weather scenarios, and worst case. Left: the policy ranking does not change across weather; the top two plans stay on top. Bad weather slightly helps Blue here, because rough seas weaken Red's coast-guard hulls. Right: of the three redesigns, the crisis hotline is best on average and in the worst case, and cuts war about four times. Caveat: we gave it no cost yet, and it also helps Red, so it is a joint gain.</a:t>
             </a:r>
             <a:endParaRPr lang="en-US" dirty="0"/>
           </a:p>
@@ -1464,7 +1464,7 @@
           <a:p>
             <a:r>
               <a:rPr lang="en-US" dirty="0"/>
-              <a:t>Be direct about limits. The war rate depends strongly on the hazard, de-escalation and war-penalty values; a sensitivity sweep is planned.</a:t>
+              <a:t>(~45 s) Be direct about limits. Left is what the runs support. Right is what they do not: values are assumptions, policies look one turn ahead, the war rate depends heavily on a few parameters, and the hotline result is partly built in. A sensitivity sweep is the first item for Workshop 2.</a:t>
             </a:r>
             <a:endParaRPr lang="en-US" dirty="0"/>
           </a:p>
@@ -1552,7 +1552,7 @@
           <a:p>
             <a:r>
               <a:rPr lang="en-US" dirty="0"/>
-              <a:t>About 40 configurations of 200 games each. Every new piece is evaluated against the Workshop 1 policies.</a:t>
+              <a:t>(~45 s) Workshop 2 follows the remaining course modules. First, Bayesian beliefs and the three Red attacks already coded. Then learning agents, once taught: does a learning Red exploit predictable Blue play? Then redesigns under attack and long typhoons, with a cost for the hotline. Final report December 8. Thank you; happy to take questions.</a:t>
             </a:r>
             <a:endParaRPr lang="en-US" dirty="0"/>
           </a:p>
@@ -1640,7 +1640,7 @@
           <a:p>
             <a:r>
               <a:rPr lang="en-US" dirty="0"/>
-              <a:t>Squares are home ports, circles are contested zones. The three features that make this a game rather than an optimization: control is relative, escalation risk is shared, and neither side sees everything.</a:t>
+              <a:t>(~60 s) Squares are home ports, circles are the eight contested zones, grouped North, Center, South. Dashed lines are the extra Philippine port, one of our redesigns. Three things make this a game rather than a single optimization: control is relative, so my best move depends on yours; escalation risk is shared, because incidents need both sides present and war costs both; and neither side sees everything.</a:t>
             </a:r>
             <a:endParaRPr lang="en-US" dirty="0"/>
           </a:p>
@@ -1728,7 +1728,7 @@
           <a:p>
             <a:r>
               <a:rPr lang="en-US" dirty="0"/>
-              <a:t>Each line of instructor feedback maps to a concrete change. The biggest: the model is now fully formal, and the strategy types from the proposal are now values of a risk budget inside a MIP.</a:t>
+              <a:t>(~60 s) Three questions. RQ1: what does accepting more escalation risk buy, and what risk levels do both sides choose? RQ2: does game-theoretic play beat simple rules? RQ3, from Prof. Sapsis's comment: does the best strategy stay best when weather turns bad? The table maps each piece of Deliverable 1 feedback to what we changed. The main one: the model is now fully formal, and the proposal's strategy types are a single risk-budget number inside a MIP.</a:t>
             </a:r>
             <a:endParaRPr lang="en-US" dirty="0"/>
           </a:p>
@@ -1816,7 +1816,7 @@
           <a:p>
             <a:r>
               <a:rPr lang="en-US" dirty="0"/>
-              <a:t>The timeline is the sequence of play. The three formulas are all the dynamics: control follows the force ratio with smoothing, incidents need contact and grow with assertion and with escalation, and the war penalty is shared.</a:t>
+              <a:t>(~70 s) Walk the timeline top to bottom: this is one two-day turn. Nature moves first with the weather, then both sides move at the same time without seeing each other's full fleet. The box holds all the dynamics. Control moves 30% of the way toward the local force ratio each turn. Incidents need both sides present, and are likelier when someone asserts and when tensions are already high. Payoff is value of zones held minus costs; war costs both sides 200, so the game is not zero-sum. If asked: every number is our assumption, listed in Table 1 of the report.</a:t>
             </a:r>
             <a:endParaRPr lang="en-US" dirty="0"/>
           </a:p>
@@ -1904,7 +1904,7 @@
           <a:p>
             <a:r>
               <a:rPr lang="en-US" dirty="0"/>
-              <a:t>The MIP answers the instructor's comment that Q1 is a feasible region. The template game is small enough to solve exactly with the Lecture 3-4 tools.</a:t>
+              <a:t>(~60 s) Two ways to decide. Left: each turn a player solves a MIP, the Lecture 2 tool, to pick moves, with a cap on expected incidents, epsilon. This answers the feedback that Q1 is a feasible region. Middle: for equilibrium analysis we shrink each side to 14 templates and solve the 14-by-14 game exactly with the Lecture 3-4 tools. Right: the six policies we compare. All of them see the same random draws.</a:t>
             </a:r>
             <a:endParaRPr lang="en-US" dirty="0"/>
           </a:p>
@@ -1992,7 +1992,7 @@
           <a:p>
             <a:r>
               <a:rPr lang="en-US" dirty="0"/>
-              <a:t>Numbers come from the template game with the dominance-surviving force splits. Lectures 3-6: chicken, correlated equilibrium LP, grim trigger with the one-stage deviation principle.</a:t>
+              <a:t>(~70 s) A small example from our own game. Fix where ships go; each side only chooses patrol or assert. Read the table: asserting against a patroller pays a little, but if both assert, both lose more than 11. So the best reply is to do the opposite of the other side, like the shared-compute example in Lecture 3. Two fixes: a correlated equilibrium, which is what a mediator or hotline can implement, never recommends both asserting; and in the repeated game, grim trigger makes mutual patrolling a subgame perfect equilibrium whenever the discount factor is above 0.18. Ours is 0.98.</a:t>
             </a:r>
             <a:endParaRPr lang="en-US" dirty="0"/>
           </a:p>
@@ -2080,7 +2080,7 @@
           <a:p>
             <a:r>
               <a:rPr lang="en-US" dirty="0"/>
-              <a:t>One Python file runs the GUI, batch runs and a per-period trace. A second script regenerates every number in the report. Rule of thumb (Blue) vs quick best response (Red), normal season, turn 12, a storm over the North.</a:t>
+              <a:t>(~60 s, or a 60 s live demo) This is the prototype. Pick a plan for each side, a design and the weather, then Step or Play. Zone color is who controls it. Letters count ships. Thick outlines mean asserting, an orange ring is an incident, shading is bad weather. Bottom left is the escalation ladder; level 5 is war. 'Run many games' gives averages. The screenshot is turn 12 with a storm over the North. The same file runs batch experiments; a second script reproduces every number in the report.</a:t>
             </a:r>
             <a:endParaRPr lang="en-US" dirty="0"/>
           </a:p>
@@ -2168,7 +2168,7 @@
           <a:p>
             <a:r>
               <a:rPr lang="en-US" dirty="0"/>
-              <a:t>Left: Blue relaxes its risk budget while Red stays at 0.15. Right: both pick a budget; aggressive is a best response to everything for both, so the equilibrium is worst for the pair.</a:t>
+              <a:t>(~60 s) Left: Blue loosens its risk budget while Red stays moderate. Control rises fast up to about 0.15, then flattens, while war risk keeps rising. Right: both sides choose a budget. Aggressive is the best reply to anything, for both, so the only equilibrium is aggressive-aggressive, with the highest war rate, 34%. That is a prisoner's dilemma, Lecture 3. Restraint has to come from repetition or coordination, as in the previous example.</a:t>
             </a:r>
             <a:endParaRPr lang="en-US" dirty="0"/>
           </a:p>
@@ -2256,7 +2256,7 @@
           <a:p>
             <a:r>
               <a:rPr lang="en-US" dirty="0"/>
-              <a:t>Each Blue policy plays against three Red policies (rule-based, MIP best response, equilibrium); the bar is Blue's lowest payoff of the three. 200 games each, standard errors 1 to 7.</a:t>
+              <a:t>(~60 s) Each Blue policy plays three Red policies, 200 games each; the bar is Blue's payoff against its worst opponent. The Nash equilibrium plan has the best worst case, and half the war rate of the MIP best response. Best responses do well against weak opponents but escalate. The safety-first plan is cautious but gives up control. Differences under about 20 points are within noise.</a:t>
             </a:r>
             <a:endParaRPr lang="en-US" dirty="0"/>
           </a:p>
@@ -3050,7 +3050,7 @@
       </p:sp>
       <p:pic>
         <p:nvPicPr>
-          <p:cNvPr id="3" name="img71" descr="/home/claude/snap/slides/../prototype/results/figures/weather.png">    </p:cNvPr>
+          <p:cNvPr id="3" name="img71" descr="/home/claude/6.S974-Wargaming-Term-Project/slides/../prototype/results/figures/weather.png">    </p:cNvPr>
           <p:cNvPicPr>
             <a:picLocks noChangeAspect="1"/>
           </p:cNvPicPr>
@@ -4515,7 +4515,7 @@
       </p:sp>
       <p:pic>
         <p:nvPicPr>
-          <p:cNvPr id="3" name="img1" descr="/home/claude/snap/slides/../prototype/results/figures/network.png">    </p:cNvPr>
+          <p:cNvPr id="3" name="img1" descr="/home/claude/6.S974-Wargaming-Term-Project/slides/../prototype/results/figures/network.png">    </p:cNvPr>
           <p:cNvPicPr>
             <a:picLocks noChangeAspect="1"/>
           </p:cNvPicPr>
@@ -7920,7 +7920,7 @@
                   <a:schemeClr val="tx2"/>
                 </a:solidFill>
               </a:rPr>
-              <a:t>Small example: patrol or assert is a game of chicken</a:t>
+              <a:t>Small example: when does it pay to assert?</a:t>
             </a:r>
             <a:endParaRPr lang="en-US" sz="2800" dirty="0"/>
           </a:p>
@@ -8524,7 +8524,7 @@
                   <a:schemeClr val="accent5"/>
                 </a:solidFill>
               </a:rPr>
-              <a:t>Payoffs (Blue, Red) in one zone, relative to both patrolling</a:t>
+              <a:t>Payoffs (Blue, Red) with force splits fixed, relative to both patrolling</a:t>
             </a:r>
             <a:endParaRPr lang="en-US" sz="1200" dirty="0"/>
           </a:p>
@@ -8823,7 +8823,7 @@
       </p:sp>
       <p:pic>
         <p:nvPicPr>
-          <p:cNvPr id="3" name="img61" descr="/home/claude/snap/slides/../prototype/results/figures/gui_screenshot.png">    </p:cNvPr>
+          <p:cNvPr id="3" name="img61" descr="/home/claude/6.S974-Wargaming-Term-Project/slides/../prototype/results/figures/gui_screenshot.png">    </p:cNvPr>
           <p:cNvPicPr>
             <a:picLocks noChangeAspect="1"/>
           </p:cNvPicPr>
@@ -9122,7 +9122,7 @@
       </p:sp>
       <p:pic>
         <p:nvPicPr>
-          <p:cNvPr id="3" name="img63" descr="/home/claude/snap/slides/../prototype/results/figures/frontier.png">    </p:cNvPr>
+          <p:cNvPr id="3" name="img63" descr="/home/claude/6.S974-Wargaming-Term-Project/slides/../prototype/results/figures/frontier.png">    </p:cNvPr>
           <p:cNvPicPr>
             <a:picLocks noChangeAspect="1"/>
           </p:cNvPicPr>

</xml_diff>

<commit_message>
Workshop 1: QA pass edits
- README: describe the Workshop 1 model instead of the proposal-era one
- Report 4.1: name the one-period gain and the mixed-equilibrium payoffs used in the grim-trigger condition
- Slide 2: incidents can occur without assertion; assertion makes them likelier
- GUI: capitalize the Workshop 2 attack labels
</commit_message>
<xml_diff>
--- a/deliverables/02-workshop1-slides.pptx
+++ b/deliverables/02-workshop1-slides.pptx
@@ -118,20 +118,20 @@
   <p:extLst>
     <p:ext uri="{521415D9-36F7-43E2-AB2F-B90AF26B5E84}">
       <p14:sectionLst xmlns:p14="http://schemas.microsoft.com/office/powerpoint/2010/main">
-        <p14:section name="Introduction" id="{dda799a5-67a0-4af2-a0fa-d0581d00b8b3}">
+        <p14:section name="Introduction" id="{81f68543-5392-58dc-089d-12a64f633b83}">
           <p14:sldIdLst>
             <p14:sldId id="256"/>
             <p14:sldId id="257"/>
             <p14:sldId id="258"/>
           </p14:sldIdLst>
         </p14:section>
-        <p14:section name="Model" id="{2bb7dabf-79f3-0a5b-5a61-a8269a8bcffe}">
+        <p14:section name="Model" id="{5a3f77f8-c7e6-c034-d758-b0626a42e338}">
           <p14:sldIdLst>
             <p14:sldId id="259"/>
             <p14:sldId id="260"/>
           </p14:sldIdLst>
         </p14:section>
-        <p14:section name="Results" id="{65bec3ae-7f8b-a9fe-5d9f-d3cdc5148e70}">
+        <p14:section name="Results" id="{0f80536d-ed15-409f-49ea-616942d4e818}">
           <p14:sldIdLst>
             <p14:sldId id="261"/>
             <p14:sldId id="262"/>
@@ -141,7 +141,7 @@
             <p14:sldId id="266"/>
           </p14:sldIdLst>
         </p14:section>
-        <p14:section name="Next steps" id="{2ce56c99-754a-7463-d5af-25e00e80683c}">
+        <p14:section name="Next steps" id="{afe1e3a0-e7dd-bb85-ece2-5a4c7e8284d7}">
           <p14:sldIdLst>
             <p14:sldId id="267"/>
           </p14:sldIdLst>
@@ -4705,7 +4705,7 @@
                   <a:schemeClr val="tx1"/>
                 </a:solidFill>
               </a:rPr>
-              <a:t>happen when both are present and someone asserts. Incidents raise an escalation level; at the top is war, which costs both sides.</a:t>
+              <a:t>can happen when both sides are present, and are likelier if someone asserts. Incidents raise an escalation level; at the top is war, which costs both sides.</a:t>
             </a:r>
             <a:endParaRPr lang="en-US" sz="1800" dirty="0"/>
           </a:p>

</xml_diff>

<commit_message>
Workshop 1: updated slides and presenter notes
- slides/build.js and deliverables/02-workshop1-slides.pptx (+ PDF copy): synced with
  the 10/26 report review (no LCS, new RQ wording, paper notation, weather scenarios,
  movement budget)
- deliverables/02-workshop1-presenter-notes.md: talk script with timings, Q&A, sources
- deliverables/02-workshop1-notation-table.pdf: full notation table
- README: list the new files
</commit_message>
<xml_diff>
--- a/deliverables/02-workshop1-slides.pptx
+++ b/deliverables/02-workshop1-slides.pptx
@@ -118,20 +118,20 @@
   <p:extLst>
     <p:ext uri="{521415D9-36F7-43E2-AB2F-B90AF26B5E84}">
       <p14:sectionLst xmlns:p14="http://schemas.microsoft.com/office/powerpoint/2010/main">
-        <p14:section name="Introduction" id="{81f68543-5392-58dc-089d-12a64f633b83}">
+        <p14:section name="Introduction" id="{cb385875-f847-6463-b467-7080e2ff82b9}">
           <p14:sldIdLst>
             <p14:sldId id="256"/>
             <p14:sldId id="257"/>
             <p14:sldId id="258"/>
           </p14:sldIdLst>
         </p14:section>
-        <p14:section name="Model" id="{5a3f77f8-c7e6-c034-d758-b0626a42e338}">
+        <p14:section name="Model" id="{d3159dd9-a8a5-7742-9a7e-6409adb29cc9}">
           <p14:sldIdLst>
             <p14:sldId id="259"/>
             <p14:sldId id="260"/>
           </p14:sldIdLst>
         </p14:section>
-        <p14:section name="Results" id="{0f80536d-ed15-409f-49ea-616942d4e818}">
+        <p14:section name="Results" id="{69efdd96-be56-f70d-157b-55f758875db3}">
           <p14:sldIdLst>
             <p14:sldId id="261"/>
             <p14:sldId id="262"/>
@@ -141,7 +141,7 @@
             <p14:sldId id="266"/>
           </p14:sldIdLst>
         </p14:section>
-        <p14:section name="Next steps" id="{afe1e3a0-e7dd-bb85-ece2-5a4c7e8284d7}">
+        <p14:section name="Next steps" id="{135816a8-073f-f4ca-b68d-af76e9d1bd8d}">
           <p14:sldIdLst>
             <p14:sldId id="267"/>
           </p14:sldIdLst>
@@ -1552,7 +1552,7 @@
           <a:p>
             <a:r>
               <a:rPr lang="en-US" dirty="0"/>
-              <a:t>(~45 s) Workshop 2 follows the remaining course modules. First, Bayesian beliefs and the three Red attacks already coded. Then learning agents, once taught: does a learning Red exploit predictable Blue play? Then redesigns under attack and long typhoons, with a cost for the hotline. Final report December 8. Thank you; happy to take questions.</a:t>
+              <a:t>(~45 s) Workshop 2 follows the remaining course modules. First, Bayesian beliefs, weather scenarios tied to the calendar with odds from climatology data, and the three Red attacks already coded; we also decide whether to keep the theater-wide movement budget, which stands in for operational requirements and station-keeping. Then learning agents, once taught: does a learning Red exploit predictable Blue play? Then redesigns under attack and long typhoons, with a cost for the hotline. Final report December 8. Thank you; happy to take questions.</a:t>
             </a:r>
             <a:endParaRPr lang="en-US" dirty="0"/>
           </a:p>
@@ -1640,7 +1640,7 @@
           <a:p>
             <a:r>
               <a:rPr lang="en-US" dirty="0"/>
-              <a:t>(~60 s) Squares are home ports, circles are the eight contested zones, grouped North, Center, South. Dashed lines are the extra Philippine port, one of our redesigns. Three things make this a game rather than a single optimization: control is relative, so my best move depends on yours; escalation risk is shared, because incidents need both sides present and war costs both; and neither side sees everything.</a:t>
+              <a:t>(~60 s) China claims most of the South China Sea and contests the Senkakus, pressing those claims with coast guard and militia hulls backed by navy ships; the U.S. keeps the seas open with destroyers on presence and freedom-of-navigation patrols (Helmus 2024; Green 2017). Squares are home ports, circles are the eight contested zones, grouped North, Center, South. Dashed lines are the extra Philippine port, one of our redesigns. Three things make this a game rather than a single optimization: control is relative, so my best move depends on yours; escalation risk is shared, because incidents need both sides present and war costs both; and neither side sees the other's full fleet, only the ships where it also has ships.</a:t>
             </a:r>
             <a:endParaRPr lang="en-US" dirty="0"/>
           </a:p>
@@ -1728,7 +1728,7 @@
           <a:p>
             <a:r>
               <a:rPr lang="en-US" dirty="0"/>
-              <a:t>(~60 s) Three questions. RQ1: what does accepting more escalation risk buy, and what risk levels do both sides choose? RQ2: does game-theoretic play beat simple rules? RQ3, from Prof. Sapsis's comment: does the best strategy stay best when weather turns bad? The table maps each piece of Deliverable 1 feedback to what we changed. The main one: the model is now fully formal, and the proposal's strategy types are a single risk-budget number inside a MIP.</a:t>
+              <a:t>(~60 s) Three questions. RQ1: each side caps the incident risk it accepts per period; how much control does more risk buy, how much likelier does war become, and what cap does each side pick when the other is picking too? RQ2: does a side that plans with game theory beat one that follows simple rules, and can both sides stay at patrol over many periods, because asserting once would end the truce and push both into riskier play from then on? RQ3, from Prof. Sapsis's comment: does the best plan or Blue redesign in normal weather stay best across calm, typhoon and extreme weather scenarios, on average and in the worst scenario? The table maps each piece of Deliverable 1 feedback to what we changed. The main one: the model is now fully formal, and the proposal's strategy types are a single risk-budget number inside a MIP.</a:t>
             </a:r>
             <a:endParaRPr lang="en-US" dirty="0"/>
           </a:p>
@@ -1816,7 +1816,7 @@
           <a:p>
             <a:r>
               <a:rPr lang="en-US" dirty="0"/>
-              <a:t>(~70 s) Walk the timeline top to bottom: this is one two-day turn. Nature moves first with the weather, then both sides move at the same time without seeing each other's full fleet. The box holds all the dynamics. Control moves 30% of the way toward the local force ratio each turn. Incidents need both sides present, and are likelier when someone asserts and when tensions are already high. Payoff is value of zones held minus costs; war costs both sides 200, so the game is not zero-sum. If asked: every number is our assumption, listed in Table 1 of the report.</a:t>
+              <a:t>(~70 s) Walk the timeline top to bottom: this is one two-day turn. The weather is drawn first, then both sides move at the same time without seeing each other's full fleet. The box holds all the dynamics. Control moves 30% of the way toward the local force ratio each turn. Incidents need both sides present, and are likelier when someone asserts and when tensions are already high. Payoff is value of zones held minus fuel, tension, and for Blue the running cost of its redesign, zeta-D; war costs both sides 200, so the game is not zero-sum. If asked: every number is our assumption, listed in Table 1 of the report.</a:t>
             </a:r>
             <a:endParaRPr lang="en-US" dirty="0"/>
           </a:p>
@@ -1992,7 +1992,7 @@
           <a:p>
             <a:r>
               <a:rPr lang="en-US" dirty="0"/>
-              <a:t>(~70 s) A small example from our own game. Fix where ships go; each side only chooses patrol or assert. Read the table: asserting against a patroller pays a little, but if both assert, both lose more than 11. So the best reply is to do the opposite of the other side, like the shared-compute example in Lecture 3. Two fixes: a correlated equilibrium, which is what a mediator or hotline can implement, never recommends both asserting; and in the repeated game, grim trigger makes mutual patrolling a subgame perfect equilibrium whenever the discount factor is above 0.18. Ours is 0.98.</a:t>
+              <a:t>(~70 s) A small example from our own game. Fix where ships go; each side only chooses patrol or assert. Read the table: asserting against a patroller pays a little, but if both assert, both lose more than 11. So the best reply is to do the opposite of the other side, like the shared-compute example in Lecture 3. Two fixes: a correlated equilibrium, which is what a mediator or hotline can implement, never recommends both asserting; and in the repeated game, grim trigger (both patrol; after any assertion, both switch to the mixed equilibrium for good) makes mutual patrolling a subgame perfect equilibrium whenever the discount factor is above 0.18. Ours is 0.98.</a:t>
             </a:r>
             <a:endParaRPr lang="en-US" dirty="0"/>
           </a:p>
@@ -3941,7 +3941,7 @@
                   <a:schemeClr val="tx1"/>
                 </a:solidFill>
               </a:rPr>
-              <a:t>Bayesian beliefs about enemy positions; weather that persists; test the three coded Red attacks (blockade, jamming, false contacts)</a:t>
+              <a:t>Bayesian beliefs about enemy positions; weather tied to the calendar (typhoon season, winter monsoon) with odds from climatology data; test the three coded Red attacks (blockade, jamming, false contacts); decide whether to keep the movement budget or drop it</a:t>
             </a:r>
             <a:endParaRPr lang="en-US" sz="1500" dirty="0"/>
           </a:p>
@@ -4618,7 +4618,7 @@
                   <a:schemeClr val="tx1"/>
                 </a:solidFill>
               </a:rPr>
-              <a:t>Blue: 10 U.S. destroyers. Red: 8 navy ships + 6 coast guard / militia hulls.</a:t>
+              <a:t>Blue: 10 U.S. destroyers (DDG). Red: 8 navy ships (PLAN) + 6 coast guard / militia hulls (CCG).</a:t>
             </a:r>
             <a:endParaRPr lang="en-US" sz="1800" dirty="0"/>
           </a:p>
@@ -4647,7 +4647,7 @@
                   <a:schemeClr val="tx1"/>
                 </a:solidFill>
               </a:rPr>
-              <a:t>Each side chooses where its ships go and whether to patrol (P) or assert (A: shadow, block, water cannon).</a:t>
+              <a:t>Each side chooses where its ships go and whether to patrol (P) or assert (A: shadowing, close maneuvering, querying and warning; for the U.S. also freedom-of-navigation operations).</a:t>
             </a:r>
             <a:endParaRPr lang="en-US" sz="1800" dirty="0"/>
           </a:p>
@@ -4734,7 +4734,7 @@
                   <a:schemeClr val="tx1"/>
                 </a:solidFill>
               </a:rPr>
-              <a:t>Each side only partly sees the other's ships. Weather (Nature) can close zones.</a:t>
+              <a:t>Neither side sees the other's entire fleet disposition; only forces present where they also maintain forces. Storms can close zones.</a:t>
             </a:r>
             <a:endParaRPr lang="en-US" sz="1800" dirty="0"/>
           </a:p>
@@ -4856,7 +4856,7 @@
         </p:nvSpPr>
         <p:spPr>
           <a:xfrm>
-            <a:off x="548640" y="1417320"/>
+            <a:off x="548640" y="1325880"/>
             <a:ext cx="731520" cy="731520"/>
           </a:xfrm>
           <a:prstGeom prst="ellipse">
@@ -4876,7 +4876,7 @@
         </p:nvSpPr>
         <p:spPr>
           <a:xfrm>
-            <a:off x="548640" y="1417320"/>
+            <a:off x="548640" y="1325880"/>
             <a:ext cx="731520" cy="731520"/>
           </a:xfrm>
           <a:prstGeom prst="rect">
@@ -4912,8 +4912,8 @@
         </p:nvSpPr>
         <p:spPr>
           <a:xfrm>
-            <a:off x="1463040" y="1325880"/>
-            <a:ext cx="4572000" cy="1188720"/>
+            <a:off x="1463040" y="1234440"/>
+            <a:ext cx="4754880" cy="1371600"/>
           </a:xfrm>
           <a:prstGeom prst="rect">
             <a:avLst/>
@@ -4929,28 +4929,28 @@
               <a:buNone/>
             </a:pPr>
             <a:r>
-              <a:rPr lang="en-US" sz="1700" b="1" dirty="0">
+              <a:rPr lang="en-US" sz="1600" b="1" dirty="0">
                 <a:solidFill>
                   <a:schemeClr val="tx1"/>
                 </a:solidFill>
               </a:rPr>
-              <a:t>Control vs. escalation</a:t>
-            </a:r>
-            <a:endParaRPr lang="en-US" sz="1700" dirty="0"/>
+              <a:t>Control vs. war risk</a:t>
+            </a:r>
+            <a:endParaRPr lang="en-US" sz="1600" dirty="0"/>
           </a:p>
           <a:p>
             <a:pPr indent="0" marL="0">
               <a:buNone/>
             </a:pPr>
             <a:r>
-              <a:rPr lang="en-US" sz="1400" dirty="0">
+              <a:rPr lang="en-US" sz="1300" dirty="0">
                 <a:solidFill>
                   <a:schemeClr val="tx1"/>
                 </a:solidFill>
               </a:rPr>
-              <a:t>How much control does a looser escalation-risk budget buy, at what war risk, and what budgets do both sides pick in equilibrium?</a:t>
-            </a:r>
-            <a:endParaRPr lang="en-US" sz="1700" dirty="0"/>
+              <a:t>Each side caps how much incident risk it will accept each period (its risk budget ε). How much more control does a side gain by accepting more risk, how much more likely does war become, and what risk level does each side pick when it knows the other side is picking too?</a:t>
+            </a:r>
+            <a:endParaRPr lang="en-US" sz="1600" dirty="0"/>
           </a:p>
         </p:txBody>
       </p:sp>
@@ -5019,7 +5019,7 @@
         <p:spPr>
           <a:xfrm>
             <a:off x="1463040" y="2697480"/>
-            <a:ext cx="4572000" cy="1188720"/>
+            <a:ext cx="4754880" cy="1371600"/>
           </a:xfrm>
           <a:prstGeom prst="rect">
             <a:avLst/>
@@ -5035,28 +5035,28 @@
               <a:buNone/>
             </a:pPr>
             <a:r>
-              <a:rPr lang="en-US" sz="1700" b="1" dirty="0">
+              <a:rPr lang="en-US" sz="1600" b="1" dirty="0">
                 <a:solidFill>
                   <a:schemeClr val="tx1"/>
                 </a:solidFill>
               </a:rPr>
-              <a:t>Strategic vs. heuristic play</a:t>
-            </a:r>
-            <a:endParaRPr lang="en-US" sz="1700" dirty="0"/>
+              <a:t>Game theory vs. rules of thumb</a:t>
+            </a:r>
+            <a:endParaRPr lang="en-US" sz="1600" dirty="0"/>
           </a:p>
           <a:p>
             <a:pPr indent="0" marL="0">
               <a:buNone/>
             </a:pPr>
             <a:r>
-              <a:rPr lang="en-US" sz="1400" dirty="0">
+              <a:rPr lang="en-US" sz="1300" dirty="0">
                 <a:solidFill>
                   <a:schemeClr val="tx1"/>
                 </a:solidFill>
               </a:rPr>
-              <a:t>Do equilibrium, maximin and best-response policies beat simple rules, and can mutual restraint be sustained?</a:t>
-            </a:r>
-            <a:endParaRPr lang="en-US" sz="1700" dirty="0"/>
+              <a:t>Does planning with game theory (best responses, equilibrium or maximin plans) beat simple rules or random moves? Can both sides stay at patrol over many periods, because asserting once would end the truce and push both into riskier play from then on?</a:t>
+            </a:r>
+            <a:endParaRPr lang="en-US" sz="1600" dirty="0"/>
           </a:p>
         </p:txBody>
       </p:sp>
@@ -5068,7 +5068,7 @@
         </p:nvSpPr>
         <p:spPr>
           <a:xfrm>
-            <a:off x="548640" y="4160520"/>
+            <a:off x="548640" y="4251960"/>
             <a:ext cx="731520" cy="731520"/>
           </a:xfrm>
           <a:prstGeom prst="ellipse">
@@ -5088,7 +5088,7 @@
         </p:nvSpPr>
         <p:spPr>
           <a:xfrm>
-            <a:off x="548640" y="4160520"/>
+            <a:off x="548640" y="4251960"/>
             <a:ext cx="731520" cy="731520"/>
           </a:xfrm>
           <a:prstGeom prst="rect">
@@ -5124,8 +5124,8 @@
         </p:nvSpPr>
         <p:spPr>
           <a:xfrm>
-            <a:off x="1463040" y="4069080"/>
-            <a:ext cx="4572000" cy="1188720"/>
+            <a:off x="1463040" y="4160520"/>
+            <a:ext cx="4754880" cy="1371600"/>
           </a:xfrm>
           <a:prstGeom prst="rect">
             <a:avLst/>
@@ -5141,28 +5141,28 @@
               <a:buNone/>
             </a:pPr>
             <a:r>
-              <a:rPr lang="en-US" sz="1700" b="1" dirty="0">
+              <a:rPr lang="en-US" sz="1600" b="1" dirty="0">
                 <a:solidFill>
                   <a:schemeClr val="tx1"/>
                 </a:solidFill>
               </a:rPr>
-              <a:t>Robustness and redesign</a:t>
-            </a:r>
-            <a:endParaRPr lang="en-US" sz="1700" dirty="0"/>
+              <a:t>Weather and redesign</a:t>
+            </a:r>
+            <a:endParaRPr lang="en-US" sz="1600" dirty="0"/>
           </a:p>
           <a:p>
             <a:pPr indent="0" marL="0">
               <a:buNone/>
             </a:pPr>
             <a:r>
-              <a:rPr lang="en-US" sz="1400" dirty="0">
+              <a:rPr lang="en-US" sz="1300" dirty="0">
                 <a:solidFill>
                   <a:schemeClr val="tx1"/>
                 </a:solidFill>
               </a:rPr>
-              <a:t>Is the best policy or design in normal weather also best when weather turns bad (expected and worst case)?</a:t>
-            </a:r>
-            <a:endParaRPr lang="en-US" sz="1700" dirty="0"/>
+              <a:t>Does the plan or Blue redesign that works best in normal weather still work best across calm, typhoon and extreme weather scenarios, both on average and in the worst scenario?</a:t>
+            </a:r>
+            <a:endParaRPr lang="en-US" sz="1600" dirty="0"/>
           </a:p>
         </p:txBody>
       </p:sp>
@@ -5192,7 +5192,7 @@
                 <a:gridCol w="1828800"/>
                 <a:gridCol w="3383280"/>
               </a:tblGrid>
-              <a:tr h="566928">
+              <a:tr h="512064">
                 <a:tc>
                   <a:txBody>
                     <a:bodyPr/>
@@ -5316,7 +5316,7 @@
                   </a:tcPr>
                 </a:tc>
               </a:tr>
-              <a:tr h="566928">
+              <a:tr h="512064">
                 <a:tc>
                   <a:txBody>
                     <a:bodyPr/>
@@ -5389,7 +5389,7 @@
                             <a:schemeClr val="tx1"/>
                           </a:solidFill>
                         </a:rPr>
-                        <a:t>Full formal game: state, actions, information, dynamics, payoffs</a:t>
+                        <a:t>Formal game on a graph</a:t>
                       </a:r>
                       <a:endParaRPr lang="en-US" sz="1200" dirty="0"/>
                     </a:p>
@@ -5434,7 +5434,7 @@
                   </a:tcPr>
                 </a:tc>
               </a:tr>
-              <a:tr h="566928">
+              <a:tr h="512064">
                 <a:tc>
                   <a:txBody>
                     <a:bodyPr/>
@@ -5449,7 +5449,7 @@
                             <a:schemeClr val="tx1"/>
                           </a:solidFill>
                         </a:rPr>
-                        <a:t>Q1 is a feasible region / MIP</a:t>
+                        <a:t>Q1 is a feasible region, use a MIP</a:t>
                       </a:r>
                       <a:endParaRPr lang="en-US" sz="1200" dirty="0"/>
                     </a:p>
@@ -5507,7 +5507,7 @@
                             <a:schemeClr val="tx1"/>
                           </a:solidFill>
                         </a:rPr>
-                        <a:t>Best response solved as a MIP; aggressive/moderate/conservative = its risk budget ε</a:t>
+                        <a:t>Best response is an exact MIP; commander types become risk budgets ε</a:t>
                       </a:r>
                       <a:endParaRPr lang="en-US" sz="1200" dirty="0"/>
                     </a:p>
@@ -5552,7 +5552,7 @@
                   </a:tcPr>
                 </a:tc>
               </a:tr>
-              <a:tr h="566928">
+              <a:tr h="512064">
                 <a:tc>
                   <a:txBody>
                     <a:bodyPr/>
@@ -5625,7 +5625,7 @@
                             <a:schemeClr val="tx1"/>
                           </a:solidFill>
                         </a:rPr>
-                        <a:t>Frontier + budget game, equilibrium play, robustness and redesign</a:t>
+                        <a:t>Budget-game equilibrium (RQ1), equilibrium play (RQ2), robustness and redesign (RQ3)</a:t>
                       </a:r>
                       <a:endParaRPr lang="en-US" sz="1200" dirty="0"/>
                     </a:p>
@@ -5670,7 +5670,7 @@
                   </a:tcPr>
                 </a:tc>
               </a:tr>
-              <a:tr h="566928">
+              <a:tr h="512064">
                 <a:tc>
                   <a:txBody>
                     <a:bodyPr/>
@@ -5685,7 +5685,7 @@
                             <a:schemeClr val="tx1"/>
                           </a:solidFill>
                         </a:rPr>
-                        <a:t>Define the redesign</a:t>
+                        <a:t>Define the resilient redesign</a:t>
                       </a:r>
                       <a:endParaRPr lang="en-US" sz="1200" dirty="0"/>
                     </a:p>
@@ -5743,7 +5743,7 @@
                             <a:schemeClr val="tx1"/>
                           </a:solidFill>
                         </a:rPr>
-                        <a:t>Three Blue designs: extra port in the Philippines, extra surveillance, crisis hotline</a:t>
+                        <a:t>Three Blue designs</a:t>
                       </a:r>
                       <a:endParaRPr lang="en-US" sz="1200" dirty="0"/>
                     </a:p>
@@ -5788,7 +5788,7 @@
                   </a:tcPr>
                 </a:tc>
               </a:tr>
-              <a:tr h="566928">
+              <a:tr h="512064">
                 <a:tc>
                   <a:txBody>
                     <a:bodyPr/>
@@ -5803,7 +5803,7 @@
                             <a:schemeClr val="tx1"/>
                           </a:solidFill>
                         </a:rPr>
-                        <a:t>Propose missing values</a:t>
+                        <a:t>Propose values for missing data</a:t>
                       </a:r>
                       <a:endParaRPr lang="en-US" sz="1200" dirty="0"/>
                     </a:p>
@@ -5861,7 +5861,7 @@
                             <a:schemeClr val="tx1"/>
                           </a:solidFill>
                         </a:rPr>
-                        <a:t>All values listed and marked as assumptions</a:t>
+                        <a:t>Assumed values, listed in the report</a:t>
                       </a:r>
                       <a:endParaRPr lang="en-US" sz="1200" dirty="0"/>
                     </a:p>
@@ -5906,7 +5906,7 @@
                   </a:tcPr>
                 </a:tc>
               </a:tr>
-              <a:tr h="566928">
+              <a:tr h="512064">
                 <a:tc>
                   <a:txBody>
                     <a:bodyPr/>
@@ -5921,7 +5921,7 @@
                             <a:schemeClr val="tx1"/>
                           </a:solidFill>
                         </a:rPr>
-                        <a:t>Prof. Sapsis: weather</a:t>
+                        <a:t>Show preliminary results</a:t>
                       </a:r>
                       <a:endParaRPr lang="en-US" sz="1200" dirty="0"/>
                     </a:p>
@@ -5979,7 +5979,125 @@
                             <a:schemeClr val="tx1"/>
                           </a:solidFill>
                         </a:rPr>
-                        <a:t>Weather scenarios as Nature's move; expected and worst-case payoff</a:t>
+                        <a:t>Analytical results; 77 setups × 200 simulated games</a:t>
+                      </a:r>
+                      <a:endParaRPr lang="en-US" sz="1200" dirty="0"/>
+                    </a:p>
+                  </a:txBody>
+                  <a:tcPr marL="91440" marR="91440" marT="45720" marB="45720" anchor="ctr">
+                    <a:lnL w="6350" cap="flat" cmpd="sng" algn="ctr">
+                      <a:solidFill>
+                        <a:srgbClr val="8DA9C4"/>
+                      </a:solidFill>
+                      <a:prstDash val="solid"/>
+                      <a:round/>
+                      <a:headEnd type="none" w="med" len="med"/>
+                      <a:tailEnd type="none" w="med" len="med"/>
+                    </a:lnL>
+                    <a:lnR w="6350" cap="flat" cmpd="sng" algn="ctr">
+                      <a:solidFill>
+                        <a:srgbClr val="8DA9C4"/>
+                      </a:solidFill>
+                      <a:prstDash val="solid"/>
+                      <a:round/>
+                      <a:headEnd type="none" w="med" len="med"/>
+                      <a:tailEnd type="none" w="med" len="med"/>
+                    </a:lnR>
+                    <a:lnT w="6350" cap="flat" cmpd="sng" algn="ctr">
+                      <a:solidFill>
+                        <a:srgbClr val="8DA9C4"/>
+                      </a:solidFill>
+                      <a:prstDash val="solid"/>
+                      <a:round/>
+                      <a:headEnd type="none" w="med" len="med"/>
+                      <a:tailEnd type="none" w="med" len="med"/>
+                    </a:lnT>
+                    <a:lnB w="6350" cap="flat" cmpd="sng" algn="ctr">
+                      <a:solidFill>
+                        <a:srgbClr val="8DA9C4"/>
+                      </a:solidFill>
+                      <a:prstDash val="solid"/>
+                      <a:round/>
+                      <a:headEnd type="none" w="med" len="med"/>
+                      <a:tailEnd type="none" w="med" len="med"/>
+                    </a:lnB>
+                  </a:tcPr>
+                </a:tc>
+              </a:tr>
+              <a:tr h="512064">
+                <a:tc>
+                  <a:txBody>
+                    <a:bodyPr/>
+                    <a:lstStyle/>
+                    <a:p>
+                      <a:pPr indent="0" marL="0">
+                        <a:buNone/>
+                      </a:pPr>
+                      <a:r>
+                        <a:rPr lang="en-US" sz="1200" dirty="0">
+                          <a:solidFill>
+                            <a:schemeClr val="tx1"/>
+                          </a:solidFill>
+                        </a:rPr>
+                        <a:t>Add weather (Prof. Sapsis)</a:t>
+                      </a:r>
+                      <a:endParaRPr lang="en-US" sz="1200" dirty="0"/>
+                    </a:p>
+                  </a:txBody>
+                  <a:tcPr marL="91440" marR="91440" marT="45720" marB="45720" anchor="ctr">
+                    <a:lnL w="6350" cap="flat" cmpd="sng" algn="ctr">
+                      <a:solidFill>
+                        <a:srgbClr val="8DA9C4"/>
+                      </a:solidFill>
+                      <a:prstDash val="solid"/>
+                      <a:round/>
+                      <a:headEnd type="none" w="med" len="med"/>
+                      <a:tailEnd type="none" w="med" len="med"/>
+                    </a:lnL>
+                    <a:lnR w="6350" cap="flat" cmpd="sng" algn="ctr">
+                      <a:solidFill>
+                        <a:srgbClr val="8DA9C4"/>
+                      </a:solidFill>
+                      <a:prstDash val="solid"/>
+                      <a:round/>
+                      <a:headEnd type="none" w="med" len="med"/>
+                      <a:tailEnd type="none" w="med" len="med"/>
+                    </a:lnR>
+                    <a:lnT w="6350" cap="flat" cmpd="sng" algn="ctr">
+                      <a:solidFill>
+                        <a:srgbClr val="8DA9C4"/>
+                      </a:solidFill>
+                      <a:prstDash val="solid"/>
+                      <a:round/>
+                      <a:headEnd type="none" w="med" len="med"/>
+                      <a:tailEnd type="none" w="med" len="med"/>
+                    </a:lnT>
+                    <a:lnB w="6350" cap="flat" cmpd="sng" algn="ctr">
+                      <a:solidFill>
+                        <a:srgbClr val="8DA9C4"/>
+                      </a:solidFill>
+                      <a:prstDash val="solid"/>
+                      <a:round/>
+                      <a:headEnd type="none" w="med" len="med"/>
+                      <a:tailEnd type="none" w="med" len="med"/>
+                    </a:lnB>
+                  </a:tcPr>
+                </a:tc>
+                <a:tc>
+                  <a:txBody>
+                    <a:bodyPr/>
+                    <a:lstStyle/>
+                    <a:p>
+                      <a:pPr indent="0" marL="0">
+                        <a:buNone/>
+                      </a:pPr>
+                      <a:r>
+                        <a:rPr lang="en-US" sz="1200" dirty="0">
+                          <a:solidFill>
+                            <a:schemeClr val="tx1"/>
+                          </a:solidFill>
+                        </a:rPr>
+                        <a:t>Weather scenarios; expected and worst-case payoff</a:t>
                       </a:r>
                       <a:endParaRPr lang="en-US" sz="1200" dirty="0"/>
                     </a:p>
@@ -6222,7 +6340,7 @@
                   <a:schemeClr val="tx1"/>
                 </a:solidFill>
               </a:rPr>
-              <a:t>Nature draws the sea state of each region</a:t>
+              <a:t>The weather (sea state) of each region is drawn</a:t>
             </a:r>
             <a:endParaRPr lang="en-US" sz="1600" dirty="0"/>
           </a:p>
@@ -6590,7 +6708,7 @@
                   <a:schemeClr val="tx1"/>
                 </a:solidFill>
               </a:rPr>
-              <a:t>Moves happen within fuel budgets</a:t>
+              <a:t>Moves happen within movement budgets</a:t>
             </a:r>
             <a:endParaRPr lang="en-US" sz="1600" dirty="0"/>
           </a:p>
@@ -6854,7 +6972,7 @@
                 <a:ea typeface="Cambria" pitchFamily="34" charset="-122"/>
                 <a:cs typeface="Cambria" pitchFamily="34" charset="-120"/>
               </a:rPr>
-              <a:t>c ← 0.7·c + 0.3·φ,   φ = (S_B − S_R) / (S_B + S_R + 1)</a:t>
+              <a:t>c ← (1 − λ)·c + λ·φ,  λ = 0.3,   φ = (S_B − S_R) / (S_B + S_R + κ)</a:t>
             </a:r>
             <a:endParaRPr lang="en-US" sz="1400" dirty="0"/>
           </a:p>
@@ -6972,7 +7090,7 @@
                 <a:ea typeface="Cambria" pitchFamily="34" charset="-122"/>
                 <a:cs typeface="Cambria" pitchFamily="34" charset="-120"/>
               </a:rPr>
-              <a:t>Σ value × control − move cost − escalation cost − 200·[war]</a:t>
+              <a:t>g = Σ V·c − γ·moves − η·ℓ − ζ_D,   minus W = 200 at war</a:t>
             </a:r>
             <a:endParaRPr lang="en-US" sz="1400" dirty="0"/>
           </a:p>
@@ -6986,7 +7104,7 @@
                   <a:schemeClr val="accent5"/>
                 </a:solidFill>
               </a:rPr>
-              <a:t>War hurts both sides, so the game is not zero-sum.</a:t>
+              <a:t>Value of control minus fuel, tension and Blue's redesign cost ζ_D. War hurts both sides, so the game is not zero-sum.</a:t>
             </a:r>
             <a:endParaRPr lang="en-US" sz="1400" dirty="0"/>
           </a:p>
@@ -7290,7 +7408,7 @@
                   <a:schemeClr val="tx1"/>
                 </a:solidFill>
               </a:rPr>
-              <a:t>Each period, choose moves and postures to maximize value of control minus costs, subject to fuel, endurance, and an escalation-risk budget:</a:t>
+              <a:t>Each period, choose moves and postures to maximize value of control minus costs, subject to the movement budget, endurance, and an escalation-risk budget:</a:t>
             </a:r>
             <a:endParaRPr lang="en-US" sz="1500" dirty="0"/>
           </a:p>
@@ -7738,7 +7856,7 @@
                   <a:schemeClr val="accent5"/>
                 </a:solidFill>
               </a:rPr>
-              <a:t>Same seeds and weather for every policy</a:t>
+              <a:t>Same random draws and weather for every policy</a:t>
             </a:r>
             <a:endParaRPr lang="en-US" sz="1300" dirty="0"/>
           </a:p>
@@ -9006,7 +9124,7 @@
                   <a:schemeClr val="tx1"/>
                 </a:solidFill>
               </a:rPr>
-              <a:t>replays the same setup over many random seeds and reports averages.</a:t>
+              <a:t>plays the same setup as many simulated games and reports averages.</a:t>
             </a:r>
             <a:endParaRPr lang="en-US" sz="1600" dirty="0"/>
           </a:p>

</xml_diff>

<commit_message>
Slides: show paper names next to GUI policy names
</commit_message>
<xml_diff>
--- a/deliverables/02-workshop1-slides.pptx
+++ b/deliverables/02-workshop1-slides.pptx
@@ -118,20 +118,20 @@
   <p:extLst>
     <p:ext uri="{521415D9-36F7-43E2-AB2F-B90AF26B5E84}">
       <p14:sectionLst xmlns:p14="http://schemas.microsoft.com/office/powerpoint/2010/main">
-        <p14:section name="Introduction" id="{cb385875-f847-6463-b467-7080e2ff82b9}">
+        <p14:section name="Introduction" id="{e67397fb-4659-f535-0b4d-2ed884e452fa}">
           <p14:sldIdLst>
             <p14:sldId id="256"/>
             <p14:sldId id="257"/>
             <p14:sldId id="258"/>
           </p14:sldIdLst>
         </p14:section>
-        <p14:section name="Model" id="{d3159dd9-a8a5-7742-9a7e-6409adb29cc9}">
+        <p14:section name="Model" id="{b8dec795-b33e-78b8-9c0b-a7aff991efee}">
           <p14:sldIdLst>
             <p14:sldId id="259"/>
             <p14:sldId id="260"/>
           </p14:sldIdLst>
         </p14:section>
-        <p14:section name="Results" id="{69efdd96-be56-f70d-157b-55f758875db3}">
+        <p14:section name="Results" id="{d05ea303-db8b-17e1-cbe7-7231daf8b809}">
           <p14:sldIdLst>
             <p14:sldId id="261"/>
             <p14:sldId id="262"/>
@@ -141,7 +141,7 @@
             <p14:sldId id="266"/>
           </p14:sldIdLst>
         </p14:section>
-        <p14:section name="Next steps" id="{135816a8-073f-f4ca-b68d-af76e9d1bd8d}">
+        <p14:section name="Next steps" id="{9416f0a5-3b3a-8bdf-4871-2eb145ed5617}">
           <p14:sldIdLst>
             <p14:sldId id="267"/>
           </p14:sldIdLst>
@@ -317,19 +317,19 @@
                     <c:v>Random moves</c:v>
                   </c:pt>
                   <c:pt idx="1">
-                    <c:v>Rule of thumb</c:v>
+                    <c:v>Rule of thumb (rule-based)</c:v>
                   </c:pt>
                   <c:pt idx="2">
-                    <c:v>Safety-first plan</c:v>
+                    <c:v>Safety-first plan (maximin)</c:v>
                   </c:pt>
                   <c:pt idx="3">
                     <c:v>Best response (MIP)</c:v>
                   </c:pt>
                   <c:pt idx="4">
-                    <c:v>Quick best response</c:v>
+                    <c:v>Quick best response (greedy)</c:v>
                   </c:pt>
                   <c:pt idx="5">
-                    <c:v>Nash equilibrium plan</c:v>
+                    <c:v>Nash equilibrium plan (equilibrium)</c:v>
                   </c:pt>
                 </c:lvl>
               </c:multiLvlStrCache>
@@ -7764,7 +7764,7 @@
                   <a:schemeClr val="tx1"/>
                 </a:solidFill>
               </a:rPr>
-              <a:t>Random moves  |  Rule of thumb</a:t>
+              <a:t>Random moves</a:t>
             </a:r>
             <a:endParaRPr lang="en-US" sz="1500" dirty="0"/>
           </a:p>
@@ -7778,6 +7778,20 @@
                   <a:schemeClr val="tx1"/>
                 </a:solidFill>
               </a:rPr>
+              <a:t>Rule of thumb (rule-based)</a:t>
+            </a:r>
+            <a:endParaRPr lang="en-US" sz="1500" dirty="0"/>
+          </a:p>
+          <a:p>
+            <a:pPr indent="0" marL="0">
+              <a:buNone/>
+            </a:pPr>
+            <a:r>
+              <a:rPr lang="en-US" sz="1500" dirty="0">
+                <a:solidFill>
+                  <a:schemeClr val="tx1"/>
+                </a:solidFill>
+              </a:rPr>
               <a:t>Quick best response (greedy)</a:t>
             </a:r>
             <a:endParaRPr lang="en-US" sz="1500" dirty="0"/>
@@ -7806,7 +7820,7 @@
                   <a:schemeClr val="tx1"/>
                 </a:solidFill>
               </a:rPr>
-              <a:t>Nash equilibrium plan</a:t>
+              <a:t>Nash equilibrium plan (equilibrium)</a:t>
             </a:r>
             <a:endParaRPr lang="en-US" sz="1500" dirty="0"/>
           </a:p>

</xml_diff>

<commit_message>
Slides: drop lecture-number references
</commit_message>
<xml_diff>
--- a/deliverables/02-workshop1-slides.pptx
+++ b/deliverables/02-workshop1-slides.pptx
@@ -118,20 +118,20 @@
   <p:extLst>
     <p:ext uri="{521415D9-36F7-43E2-AB2F-B90AF26B5E84}">
       <p14:sectionLst xmlns:p14="http://schemas.microsoft.com/office/powerpoint/2010/main">
-        <p14:section name="Introduction" id="{e67397fb-4659-f535-0b4d-2ed884e452fa}">
+        <p14:section name="Introduction" id="{b7138723-2de2-4d78-3486-164cf1466f0f}">
           <p14:sldIdLst>
             <p14:sldId id="256"/>
             <p14:sldId id="257"/>
             <p14:sldId id="258"/>
           </p14:sldIdLst>
         </p14:section>
-        <p14:section name="Model" id="{b8dec795-b33e-78b8-9c0b-a7aff991efee}">
+        <p14:section name="Model" id="{bb76a8d3-24bd-e8a1-fb25-5d90c0b41535}">
           <p14:sldIdLst>
             <p14:sldId id="259"/>
             <p14:sldId id="260"/>
           </p14:sldIdLst>
         </p14:section>
-        <p14:section name="Results" id="{d05ea303-db8b-17e1-cbe7-7231daf8b809}">
+        <p14:section name="Results" id="{24bc6a3d-2d62-c62b-8090-55f678352be9}">
           <p14:sldIdLst>
             <p14:sldId id="261"/>
             <p14:sldId id="262"/>
@@ -141,7 +141,7 @@
             <p14:sldId id="266"/>
           </p14:sldIdLst>
         </p14:section>
-        <p14:section name="Next steps" id="{9416f0a5-3b3a-8bdf-4871-2eb145ed5617}">
+        <p14:section name="Next steps" id="{d2ac24c0-572d-10eb-a1d3-ee1a7c9aed81}">
           <p14:sldIdLst>
             <p14:sldId id="267"/>
           </p14:sldIdLst>
@@ -1376,7 +1376,7 @@
           <a:p>
             <a:r>
               <a:rPr lang="en-US" dirty="0"/>
-              <a:t>(~70 s) Robustness in the Lecture 1 sense: expected payoff over the four weather scenarios, and worst case. Left: the policy ranking does not change across weather; the top two plans stay on top. Bad weather slightly helps Blue here, because rough seas weaken Red's coast-guard hulls. Right: of the three redesigns, the crisis hotline is best on average and in the worst case, and cuts war about four times. Caveat: we gave it no cost yet, and it also helps Red, so it is a joint gain.</a:t>
+              <a:t>(~70 s) Robustness here means two numbers: expected payoff over the four weather scenarios, and worst case. Left: the policy ranking does not change across weather; the top two plans stay on top. Bad weather slightly helps Blue here, because rough seas weaken Red's coast-guard hulls. Right: of the three redesigns, the crisis hotline is best on average and in the worst case, and cuts war about four times. Caveat: we gave it no cost yet, and it also helps Red, so it is a joint gain.</a:t>
             </a:r>
             <a:endParaRPr lang="en-US" dirty="0"/>
           </a:p>
@@ -1904,7 +1904,7 @@
           <a:p>
             <a:r>
               <a:rPr lang="en-US" dirty="0"/>
-              <a:t>(~60 s) Two ways to decide. Left: each turn a player solves a MIP, the Lecture 2 tool, to pick moves, with a cap on expected incidents, epsilon. This answers the feedback that Q1 is a feasible region. Middle: for equilibrium analysis we shrink each side to 14 templates and solve the 14-by-14 game exactly with the Lecture 3-4 tools. Right: the six policies we compare. All of them see the same random draws.</a:t>
+              <a:t>(~60 s) Two ways to decide. Left: each turn a player solves a mixed-integer program (MIP) to pick moves, with a cap on expected incidents, epsilon. This answers the feedback that Q1 is a feasible region. Middle: for equilibrium analysis we shrink each side to 14 templates and solve the 14-by-14 game exactly. Right: the six policies we compare. All of them see the same random draws.</a:t>
             </a:r>
             <a:endParaRPr lang="en-US" dirty="0"/>
           </a:p>
@@ -1992,7 +1992,7 @@
           <a:p>
             <a:r>
               <a:rPr lang="en-US" dirty="0"/>
-              <a:t>(~70 s) A small example from our own game. Fix where ships go; each side only chooses patrol or assert. Read the table: asserting against a patroller pays a little, but if both assert, both lose more than 11. So the best reply is to do the opposite of the other side, like the shared-compute example in Lecture 3. Two fixes: a correlated equilibrium, which is what a mediator or hotline can implement, never recommends both asserting; and in the repeated game, grim trigger (both patrol; after any assertion, both switch to the mixed equilibrium for good) makes mutual patrolling a subgame perfect equilibrium whenever the discount factor is above 0.18. Ours is 0.98.</a:t>
+              <a:t>(~70 s) A small example from our own game. Fix where ships go; each side only chooses patrol or assert. Read the table: asserting against a patroller pays a little, but if both assert, both lose more than 11. So the best reply is to do the opposite of the other side. Two fixes: a correlated equilibrium, which is what a mediator or hotline can implement, never recommends both asserting; and in the repeated game, grim trigger (both patrol; after any assertion, both switch to the mixed equilibrium for good) makes mutual patrolling a subgame perfect equilibrium whenever the discount factor is above 0.18. Ours is 0.98.</a:t>
             </a:r>
             <a:endParaRPr lang="en-US" dirty="0"/>
           </a:p>
@@ -2168,7 +2168,7 @@
           <a:p>
             <a:r>
               <a:rPr lang="en-US" dirty="0"/>
-              <a:t>(~60 s) Left: Blue loosens its risk budget while Red stays moderate. Control rises fast up to about 0.15, then flattens, while war risk keeps rising. Right: both sides choose a budget. Aggressive is the best reply to anything, for both, so the only equilibrium is aggressive-aggressive, with the highest war rate, 34%. That is a prisoner's dilemma, Lecture 3. Restraint has to come from repetition or coordination, as in the previous example.</a:t>
+              <a:t>(~60 s) Left: Blue loosens its risk budget while Red stays moderate. Control rises fast up to about 0.15, then flattens, while war risk keeps rising. Right: both sides choose a budget. Aggressive is the best reply to anything, for both, so the only equilibrium is aggressive-aggressive, with the highest war rate, 34%. That is a prisoner's dilemma. Restraint has to come from repetition or coordination, as in the previous example.</a:t>
             </a:r>
             <a:endParaRPr lang="en-US" dirty="0"/>
           </a:p>
@@ -7944,7 +7944,7 @@
                   <a:schemeClr val="tx1"/>
                 </a:solidFill>
               </a:rPr>
-              <a:t>The proposal's strategy types are now one number, ε, inside an optimization the course covered (Lecture 2).</a:t>
+              <a:t>The proposal's strategy types are now one number, ε, inside an optimization (a MIP).</a:t>
             </a:r>
             <a:endParaRPr lang="en-US" sz="1600" dirty="0"/>
           </a:p>

</xml_diff>

<commit_message>
Slides: drop course-module reference from Workshop 2 takeaway
</commit_message>
<xml_diff>
--- a/deliverables/02-workshop1-slides.pptx
+++ b/deliverables/02-workshop1-slides.pptx
@@ -118,20 +118,20 @@
   <p:extLst>
     <p:ext uri="{521415D9-36F7-43E2-AB2F-B90AF26B5E84}">
       <p14:sectionLst xmlns:p14="http://schemas.microsoft.com/office/powerpoint/2010/main">
-        <p14:section name="Introduction" id="{b7138723-2de2-4d78-3486-164cf1466f0f}">
+        <p14:section name="Introduction" id="{d04f4568-4b56-e1e9-78b6-3c4dcd990b17}">
           <p14:sldIdLst>
             <p14:sldId id="256"/>
             <p14:sldId id="257"/>
             <p14:sldId id="258"/>
           </p14:sldIdLst>
         </p14:section>
-        <p14:section name="Model" id="{bb76a8d3-24bd-e8a1-fb25-5d90c0b41535}">
+        <p14:section name="Model" id="{007fe24e-155e-18c5-1309-8f4c4c098d56}">
           <p14:sldIdLst>
             <p14:sldId id="259"/>
             <p14:sldId id="260"/>
           </p14:sldIdLst>
         </p14:section>
-        <p14:section name="Results" id="{24bc6a3d-2d62-c62b-8090-55f678352be9}">
+        <p14:section name="Results" id="{ef96127b-ef48-7e84-474c-1b5453aca6e8}">
           <p14:sldIdLst>
             <p14:sldId id="261"/>
             <p14:sldId id="262"/>
@@ -141,7 +141,7 @@
             <p14:sldId id="266"/>
           </p14:sldIdLst>
         </p14:section>
-        <p14:section name="Next steps" id="{d2ac24c0-572d-10eb-a1d3-ee1a7c9aed81}">
+        <p14:section name="Next steps" id="{ae22a284-6ae3-c38b-34df-0cf5b9033e44}">
           <p14:sldIdLst>
             <p14:sldId id="267"/>
           </p14:sldIdLst>
@@ -4399,7 +4399,7 @@
                   <a:schemeClr val="tx1"/>
                 </a:solidFill>
               </a:rPr>
-              <a:t>Each step follows the remaining course modules: learning, attacks and defenses, resilient design.</a:t>
+              <a:t>Next: learning, attacks and defenses, and resilient design, in that order.</a:t>
             </a:r>
             <a:endParaRPr lang="en-US" sz="1600" dirty="0"/>
           </a:p>

</xml_diff>

<commit_message>
Slides and presenter notes: remove remaining course references
</commit_message>
<xml_diff>
--- a/deliverables/02-workshop1-slides.pptx
+++ b/deliverables/02-workshop1-slides.pptx
@@ -118,20 +118,20 @@
   <p:extLst>
     <p:ext uri="{521415D9-36F7-43E2-AB2F-B90AF26B5E84}">
       <p14:sectionLst xmlns:p14="http://schemas.microsoft.com/office/powerpoint/2010/main">
-        <p14:section name="Introduction" id="{d04f4568-4b56-e1e9-78b6-3c4dcd990b17}">
+        <p14:section name="Introduction" id="{97e13b2a-9dc8-cf31-3349-eb0e0eee05ca}">
           <p14:sldIdLst>
             <p14:sldId id="256"/>
             <p14:sldId id="257"/>
             <p14:sldId id="258"/>
           </p14:sldIdLst>
         </p14:section>
-        <p14:section name="Model" id="{007fe24e-155e-18c5-1309-8f4c4c098d56}">
+        <p14:section name="Model" id="{63e16109-cad6-62fa-fe8a-b7f089c1685e}">
           <p14:sldIdLst>
             <p14:sldId id="259"/>
             <p14:sldId id="260"/>
           </p14:sldIdLst>
         </p14:section>
-        <p14:section name="Results" id="{ef96127b-ef48-7e84-474c-1b5453aca6e8}">
+        <p14:section name="Results" id="{d3b0137c-bed6-0c98-1a18-b4a9039a10a5}">
           <p14:sldIdLst>
             <p14:sldId id="261"/>
             <p14:sldId id="262"/>
@@ -141,7 +141,7 @@
             <p14:sldId id="266"/>
           </p14:sldIdLst>
         </p14:section>
-        <p14:section name="Next steps" id="{ae22a284-6ae3-c38b-34df-0cf5b9033e44}">
+        <p14:section name="Next steps" id="{46e543ed-7878-f8ca-3031-93fc307b068b}">
           <p14:sldIdLst>
             <p14:sldId id="267"/>
           </p14:sldIdLst>
@@ -1552,7 +1552,7 @@
           <a:p>
             <a:r>
               <a:rPr lang="en-US" dirty="0"/>
-              <a:t>(~45 s) Workshop 2 follows the remaining course modules. First, Bayesian beliefs, weather scenarios tied to the calendar with odds from climatology data, and the three Red attacks already coded; we also decide whether to keep the theater-wide movement budget, which stands in for operational requirements and station-keeping. Then learning agents, once taught: does a learning Red exploit predictable Blue play? Then redesigns under attack and long typhoons, with a cost for the hotline. Final report December 8. Thank you; happy to take questions.</a:t>
+              <a:t>(~45 s) Workshop 2 plan. First, Bayesian beliefs, weather scenarios tied to the calendar with odds from climatology data, and the three Red attacks already coded; we also decide whether to keep the theater-wide movement budget, which stands in for operational requirements and station-keeping. Then learning agents: does a learning Red exploit predictable Blue play? Then redesigns under attack and long typhoons, with a cost for the hotline. Final report December 8. Thank you; happy to take questions.</a:t>
             </a:r>
             <a:endParaRPr lang="en-US" dirty="0"/>
           </a:p>
@@ -1992,7 +1992,7 @@
           <a:p>
             <a:r>
               <a:rPr lang="en-US" dirty="0"/>
-              <a:t>(~70 s) A small example from our own game. Fix where ships go; each side only chooses patrol or assert. Read the table: asserting against a patroller pays a little, but if both assert, both lose more than 11. So the best reply is to do the opposite of the other side. Two fixes: a correlated equilibrium, which is what a mediator or hotline can implement, never recommends both asserting; and in the repeated game, grim trigger (both patrol; after any assertion, both switch to the mixed equilibrium for good) makes mutual patrolling a subgame perfect equilibrium whenever the discount factor is above 0.18. Ours is 0.98.</a:t>
+              <a:t>(~70 s) A small example from our own game. Fix where ships go; each side only chooses patrol or assert. Read the table: asserting against a patroller pays a little, but if both assert, both lose more than 11. So the best reply is to do the opposite of the other side: an anti-coordination game. Two fixes: a correlated equilibrium, which is what a mediator or hotline can implement, never recommends both asserting; and in the repeated game, grim trigger (both patrol; after any assertion, both switch to the mixed equilibrium for good) makes mutual patrolling a subgame perfect equilibrium whenever the discount factor is above 0.18. Ours is 0.98.</a:t>
             </a:r>
             <a:endParaRPr lang="en-US" dirty="0"/>
           </a:p>

</xml_diff>

<commit_message>
Slides: rename D3 to de-escalation measures
</commit_message>
<xml_diff>
--- a/deliverables/02-workshop1-slides.pptx
+++ b/deliverables/02-workshop1-slides.pptx
@@ -118,20 +118,20 @@
   <p:extLst>
     <p:ext uri="{521415D9-36F7-43E2-AB2F-B90AF26B5E84}">
       <p14:sectionLst xmlns:p14="http://schemas.microsoft.com/office/powerpoint/2010/main">
-        <p14:section name="Introduction" id="{97e13b2a-9dc8-cf31-3349-eb0e0eee05ca}">
+        <p14:section name="Introduction" id="{0c4d45b8-d253-9cd8-8b84-261d4ac184b5}">
           <p14:sldIdLst>
             <p14:sldId id="256"/>
             <p14:sldId id="257"/>
             <p14:sldId id="258"/>
           </p14:sldIdLst>
         </p14:section>
-        <p14:section name="Model" id="{63e16109-cad6-62fa-fe8a-b7f089c1685e}">
+        <p14:section name="Model" id="{51754954-edf8-54f6-46bb-c29a9988cd7d}">
           <p14:sldIdLst>
             <p14:sldId id="259"/>
             <p14:sldId id="260"/>
           </p14:sldIdLst>
         </p14:section>
-        <p14:section name="Results" id="{d3b0137c-bed6-0c98-1a18-b4a9039a10a5}">
+        <p14:section name="Results" id="{7057c304-0ba2-c731-afa0-35df9b833987}">
           <p14:sldIdLst>
             <p14:sldId id="261"/>
             <p14:sldId id="262"/>
@@ -141,7 +141,7 @@
             <p14:sldId id="266"/>
           </p14:sldIdLst>
         </p14:section>
-        <p14:section name="Next steps" id="{46e543ed-7878-f8ca-3031-93fc307b068b}">
+        <p14:section name="Next steps" id="{b58ec03a-aeaf-8821-cda2-385e83cb8bf3}">
           <p14:sldIdLst>
             <p14:sldId id="267"/>
           </p14:sldIdLst>
@@ -612,7 +612,7 @@
                     <c:v>D2 Extra surveillance</c:v>
                   </c:pt>
                   <c:pt idx="3">
-                    <c:v>D3 Crisis hotline</c:v>
+                    <c:v>D3 De-escalation</c:v>
                   </c:pt>
                 </c:lvl>
               </c:multiLvlStrCache>
@@ -701,7 +701,7 @@
                     <c:v>D2 Extra surveillance</c:v>
                   </c:pt>
                   <c:pt idx="3">
-                    <c:v>D3 Crisis hotline</c:v>
+                    <c:v>D3 De-escalation</c:v>
                   </c:pt>
                 </c:lvl>
               </c:multiLvlStrCache>
@@ -1376,7 +1376,7 @@
           <a:p>
             <a:r>
               <a:rPr lang="en-US" dirty="0"/>
-              <a:t>(~70 s) Robustness here means two numbers: expected payoff over the four weather scenarios, and worst case. Left: the policy ranking does not change across weather; the top two plans stay on top. Bad weather slightly helps Blue here, because rough seas weaken Red's coast-guard hulls. Right: of the three redesigns, the crisis hotline is best on average and in the worst case, and cuts war about four times. Caveat: we gave it no cost yet, and it also helps Red, so it is a joint gain.</a:t>
+              <a:t>(~70 s) Robustness here means two numbers: expected payoff over the four weather scenarios, and worst case. Left: the policy ranking does not change across weather; the top two plans stay on top. Bad weather slightly helps Blue here, because rough seas weaken Red's coast-guard hulls. Right: of the three redesigns, de-escalation measures are best on average and in the worst case, and cut war about four times. Caveat: we gave them no cost yet, and they also help Red, so it is a joint gain.</a:t>
             </a:r>
             <a:endParaRPr lang="en-US" dirty="0"/>
           </a:p>
@@ -1464,7 +1464,7 @@
           <a:p>
             <a:r>
               <a:rPr lang="en-US" dirty="0"/>
-              <a:t>(~45 s) Be direct about limits. Left is what the runs support. Right is what they do not: values are assumptions, policies look one turn ahead, the war rate depends heavily on a few parameters, and the hotline result is partly built in. A sensitivity sweep is the first item for Workshop 2.</a:t>
+              <a:t>(~45 s) Be direct about limits. Left is what the runs support. Right is what they do not: values are assumptions, policies look one turn ahead, the war rate depends heavily on a few parameters, and the de-escalation result is partly built in. A sensitivity sweep is the first item for Workshop 2.</a:t>
             </a:r>
             <a:endParaRPr lang="en-US" dirty="0"/>
           </a:p>
@@ -1552,7 +1552,7 @@
           <a:p>
             <a:r>
               <a:rPr lang="en-US" dirty="0"/>
-              <a:t>(~45 s) Workshop 2 plan. First, Bayesian beliefs, weather scenarios tied to the calendar with odds from climatology data, and the three Red attacks already coded; we also decide whether to keep the theater-wide movement budget, which stands in for operational requirements and station-keeping. Then learning agents: does a learning Red exploit predictable Blue play? Then redesigns under attack and long typhoons, with a cost for the hotline. Final report December 8. Thank you; happy to take questions.</a:t>
+              <a:t>(~45 s) Workshop 2 plan. First, Bayesian beliefs, weather scenarios tied to the calendar with odds from climatology data, and the three Red attacks already coded; we also decide whether to keep the theater-wide movement budget, which stands in for operational requirements and station-keeping. Then learning agents: does a learning Red exploit predictable Blue play? Then redesigns under attack and long typhoons, with a cost for de-escalation measures. Final report December 8. Thank you; happy to take questions.</a:t>
             </a:r>
             <a:endParaRPr lang="en-US" dirty="0"/>
           </a:p>
@@ -3154,7 +3154,7 @@
                   <a:schemeClr val="accent5"/>
                 </a:solidFill>
               </a:rPr>
-              <a:t>War rate (normal weather): D0 20%, D1 28%, D2 23%, D3 5%. The hotline was given no cost yet.</a:t>
+              <a:t>War rate (normal weather): D0 20%, D1 28%, D2 23%, D3 5%. De-escalation measures were given no cost yet.</a:t>
             </a:r>
             <a:endParaRPr lang="en-US" sz="1300" dirty="0"/>
           </a:p>
@@ -3228,7 +3228,7 @@
                   <a:schemeClr val="tx1"/>
                 </a:solidFill>
               </a:rPr>
-              <a:t>The plan that is best on average is also best in the worst weather. The crisis hotline is the best design and cuts war about 4×.</a:t>
+              <a:t>The plan that is best on average is also best in the worst weather. De-escalation measures are the best design and cut war about 4×.</a:t>
             </a:r>
             <a:endParaRPr lang="en-US" sz="1600" dirty="0"/>
           </a:p>
@@ -3509,7 +3509,7 @@
                   <a:schemeClr val="tx1"/>
                 </a:solidFill>
               </a:rPr>
-              <a:t>A crisis hotline is a joint gain under every weather scenario</a:t>
+              <a:t>De-escalation measures are a joint gain under every weather scenario</a:t>
             </a:r>
             <a:endParaRPr lang="en-US" sz="1600" dirty="0"/>
           </a:p>
@@ -3664,7 +3664,7 @@
                   <a:schemeClr val="tx1"/>
                 </a:solidFill>
               </a:rPr>
-              <a:t>The hotline has no cost yet, so part of its win is built in</a:t>
+              <a:t>De-escalation measures have no cost yet, so part of their win is built in</a:t>
             </a:r>
             <a:endParaRPr lang="en-US" sz="1600" dirty="0"/>
           </a:p>
@@ -4197,7 +4197,7 @@
                   <a:schemeClr val="tx1"/>
                 </a:solidFill>
               </a:rPr>
-              <a:t>Designs and combinations under attacks, persistent weather and a rare long typhoon; hotline as a mediator</a:t>
+              <a:t>Designs and combinations under attacks, persistent weather and a rare long typhoon; a cost for de-escalation measures</a:t>
             </a:r>
             <a:endParaRPr lang="en-US" sz="1500" dirty="0"/>
           </a:p>

</xml_diff>

<commit_message>
Subic Bay label (not EDCA), D3 de-escalation label in GUI, IESDS spelled out; latest presenter notes
</commit_message>
<xml_diff>
--- a/deliverables/02-workshop1-slides.pptx
+++ b/deliverables/02-workshop1-slides.pptx
@@ -118,20 +118,20 @@
   <p:extLst>
     <p:ext uri="{521415D9-36F7-43E2-AB2F-B90AF26B5E84}">
       <p14:sectionLst xmlns:p14="http://schemas.microsoft.com/office/powerpoint/2010/main">
-        <p14:section name="Introduction" id="{0c4d45b8-d253-9cd8-8b84-261d4ac184b5}">
+        <p14:section name="Introduction" id="{607dbc1d-72ea-44c6-2f52-84dd377087bc}">
           <p14:sldIdLst>
             <p14:sldId id="256"/>
             <p14:sldId id="257"/>
             <p14:sldId id="258"/>
           </p14:sldIdLst>
         </p14:section>
-        <p14:section name="Model" id="{51754954-edf8-54f6-46bb-c29a9988cd7d}">
+        <p14:section name="Model" id="{fcf0c830-cdd8-efaf-cac2-1f8051ccaa94}">
           <p14:sldIdLst>
             <p14:sldId id="259"/>
             <p14:sldId id="260"/>
           </p14:sldIdLst>
         </p14:section>
-        <p14:section name="Results" id="{7057c304-0ba2-c731-afa0-35df9b833987}">
+        <p14:section name="Results" id="{d5b0d74e-8311-1a51-3a74-11fc5c36e075}">
           <p14:sldIdLst>
             <p14:sldId id="261"/>
             <p14:sldId id="262"/>
@@ -141,7 +141,7 @@
             <p14:sldId id="266"/>
           </p14:sldIdLst>
         </p14:section>
-        <p14:section name="Next steps" id="{b58ec03a-aeaf-8821-cda2-385e83cb8bf3}">
+        <p14:section name="Next steps" id="{fae0b144-61f2-6719-a30d-507ad040953a}">
           <p14:sldIdLst>
             <p14:sldId id="267"/>
           </p14:sldIdLst>
@@ -7642,7 +7642,7 @@
                   <a:schemeClr val="accent5"/>
                 </a:solidFill>
               </a:rPr>
-              <a:t>Solved with dominance, Nash equilibrium, maximin LP, correlated-equilibrium LP</a:t>
+              <a:t>Solved with iterated elimination of strictly dominated strategies (IESDS), Nash equilibrium, maximin LP, correlated-equilibrium LP</a:t>
             </a:r>
             <a:endParaRPr lang="en-US" sz="1300" dirty="0"/>
           </a:p>

</xml_diff>

<commit_message>
Slides: describe the repeated-game strategy without the grim-trigger label
</commit_message>
<xml_diff>
--- a/deliverables/02-workshop1-slides.pptx
+++ b/deliverables/02-workshop1-slides.pptx
@@ -118,20 +118,20 @@
   <p:extLst>
     <p:ext uri="{521415D9-36F7-43E2-AB2F-B90AF26B5E84}">
       <p14:sectionLst xmlns:p14="http://schemas.microsoft.com/office/powerpoint/2010/main">
-        <p14:section name="Introduction" id="{607dbc1d-72ea-44c6-2f52-84dd377087bc}">
+        <p14:section name="Introduction" id="{5bb63c19-2378-c3ea-6589-7003b476d557}">
           <p14:sldIdLst>
             <p14:sldId id="256"/>
             <p14:sldId id="257"/>
             <p14:sldId id="258"/>
           </p14:sldIdLst>
         </p14:section>
-        <p14:section name="Model" id="{fcf0c830-cdd8-efaf-cac2-1f8051ccaa94}">
+        <p14:section name="Model" id="{158af4d3-e48c-f480-a5ff-9db522be24c5}">
           <p14:sldIdLst>
             <p14:sldId id="259"/>
             <p14:sldId id="260"/>
           </p14:sldIdLst>
         </p14:section>
-        <p14:section name="Results" id="{d5b0d74e-8311-1a51-3a74-11fc5c36e075}">
+        <p14:section name="Results" id="{14e60b68-9f02-d4d7-eb03-6e17a76e1ae7}">
           <p14:sldIdLst>
             <p14:sldId id="261"/>
             <p14:sldId id="262"/>
@@ -141,7 +141,7 @@
             <p14:sldId id="266"/>
           </p14:sldIdLst>
         </p14:section>
-        <p14:section name="Next steps" id="{fae0b144-61f2-6719-a30d-507ad040953a}">
+        <p14:section name="Next steps" id="{929714c6-6718-aa73-7076-c413c15027bd}">
           <p14:sldIdLst>
             <p14:sldId id="267"/>
           </p14:sldIdLst>
@@ -1992,7 +1992,7 @@
           <a:p>
             <a:r>
               <a:rPr lang="en-US" dirty="0"/>
-              <a:t>(~70 s) A small example from our own game. Fix where ships go; each side only chooses patrol or assert. Read the table: asserting against a patroller pays a little, but if both assert, both lose more than 11. So the best reply is to do the opposite of the other side: an anti-coordination game. Two fixes: a correlated equilibrium, which is what a mediator or hotline can implement, never recommends both asserting; and in the repeated game, grim trigger (both patrol; after any assertion, both switch to the mixed equilibrium for good) makes mutual patrolling a subgame perfect equilibrium whenever the discount factor is above 0.18. Ours is 0.98.</a:t>
+              <a:t>(~70 s) A small example from our own game. Fix where ships go; each side only chooses patrol or assert. Read the table: asserting against a patroller pays a little, but if both assert, both lose more than 11. So the best reply is to do the opposite of the other side: an anti-coordination game. Two fixes: a correlated equilibrium, which is what a mediator or hotline can implement, never recommends both asserting; and in the repeated game, a standing threat (if either side pushes, the truce is off for good and both fall back to the mixed equilibrium) makes mutual patrolling a subgame perfect equilibrium whenever the discount factor is above 0.18. Ours is 0.98.</a:t>
             </a:r>
             <a:endParaRPr lang="en-US" dirty="0"/>
           </a:p>
@@ -8765,7 +8765,7 @@
                   <a:schemeClr val="tx1"/>
                 </a:solidFill>
               </a:rPr>
-              <a:t>with grim trigger, mutual patrolling is a subgame perfect equilibrium for any discount factor above 0.18. Ours is 0.98.</a:t>
+              <a:t>if both patrol and any assertion makes both fall back to the mixed equilibrium for good, mutual patrolling is a subgame perfect equilibrium for any discount factor above 0.18. Ours is 0.98.</a:t>
             </a:r>
             <a:endParaRPr lang="en-US" sz="1700" dirty="0"/>
           </a:p>

</xml_diff>

<commit_message>
Slides: short sentences instead of semicolons and colons; PD compared with moderate-moderate
</commit_message>
<xml_diff>
--- a/deliverables/02-workshop1-slides.pptx
+++ b/deliverables/02-workshop1-slides.pptx
@@ -118,20 +118,20 @@
   <p:extLst>
     <p:ext uri="{521415D9-36F7-43E2-AB2F-B90AF26B5E84}">
       <p14:sectionLst xmlns:p14="http://schemas.microsoft.com/office/powerpoint/2010/main">
-        <p14:section name="Introduction" id="{5bb63c19-2378-c3ea-6589-7003b476d557}">
+        <p14:section name="Introduction" id="{0fbe3ec4-8020-b131-25f0-b670e24e2bf3}">
           <p14:sldIdLst>
             <p14:sldId id="256"/>
             <p14:sldId id="257"/>
             <p14:sldId id="258"/>
           </p14:sldIdLst>
         </p14:section>
-        <p14:section name="Model" id="{158af4d3-e48c-f480-a5ff-9db522be24c5}">
+        <p14:section name="Model" id="{50465000-f2f7-f02c-a98d-4cc76d50dd65}">
           <p14:sldIdLst>
             <p14:sldId id="259"/>
             <p14:sldId id="260"/>
           </p14:sldIdLst>
         </p14:section>
-        <p14:section name="Results" id="{14e60b68-9f02-d4d7-eb03-6e17a76e1ae7}">
+        <p14:section name="Results" id="{0d4d7b2c-8def-66d2-44e1-402d25f4ee21}">
           <p14:sldIdLst>
             <p14:sldId id="261"/>
             <p14:sldId id="262"/>
@@ -141,7 +141,7 @@
             <p14:sldId id="266"/>
           </p14:sldIdLst>
         </p14:section>
-        <p14:section name="Next steps" id="{929714c6-6718-aa73-7076-c413c15027bd}">
+        <p14:section name="Next steps" id="{01a5634c-46eb-07d1-27d4-cf729a40bd8f}">
           <p14:sldIdLst>
             <p14:sldId id="267"/>
           </p14:sldIdLst>
@@ -1288,7 +1288,7 @@
           <a:p>
             <a:r>
               <a:rPr lang="en-US" dirty="0"/>
-              <a:t>(~30 s) We study day-to-day U.S.-China competition for control of the waters inside the First Island Chain, below the threshold of war. We built it as a game on a network. Today: the model, the prototype, and first results on three research questions.</a:t>
+              <a:t>(~30 s) We study day-to-day U.S.-China competition for control of the waters inside the First Island Chain, below the threshold of war. We built it as a game on a network. Today we cover the model, the prototype, and first results on three research questions.</a:t>
             </a:r>
             <a:endParaRPr lang="en-US" dirty="0"/>
           </a:p>
@@ -1376,7 +1376,7 @@
           <a:p>
             <a:r>
               <a:rPr lang="en-US" dirty="0"/>
-              <a:t>(~70 s) Robustness here means two numbers: expected payoff over the four weather scenarios, and worst case. Left: the policy ranking does not change across weather; the top two plans stay on top. Bad weather slightly helps Blue here, because rough seas weaken Red's coast-guard hulls. Right: of the three redesigns, de-escalation measures are best on average and in the worst case, and cut war about four times. Caveat: we gave them no cost yet, and they also help Red, so it is a joint gain.</a:t>
+              <a:t>(~70 s) Robustness here means two numbers, expected payoff over the four weather scenarios, and worst case. On the left, the policy ranking does not change across weather. The top two plans stay on top. Bad weather slightly helps Blue here, because rough seas weaken Red's coast-guard hulls. On the right, of the three redesigns, de-escalation measures are best on average and in the worst case, and cut war about four times. We gave them no cost yet, and they also help Red, so it is a joint gain.</a:t>
             </a:r>
             <a:endParaRPr lang="en-US" dirty="0"/>
           </a:p>
@@ -1464,7 +1464,7 @@
           <a:p>
             <a:r>
               <a:rPr lang="en-US" dirty="0"/>
-              <a:t>(~45 s) Be direct about limits. Left is what the runs support. Right is what they do not: values are assumptions, policies look one turn ahead, the war rate depends heavily on a few parameters, and the de-escalation result is partly built in. A sensitivity sweep is the first item for Workshop 2.</a:t>
+              <a:t>(~45 s) Be direct about limits. Left is what the runs support. Right is what they do not show. Values are assumptions, policies look one turn ahead, the war rate depends heavily on a few parameters, and the de-escalation result is partly built in. A sensitivity sweep is the first item for Workshop 2.</a:t>
             </a:r>
             <a:endParaRPr lang="en-US" dirty="0"/>
           </a:p>
@@ -1552,7 +1552,7 @@
           <a:p>
             <a:r>
               <a:rPr lang="en-US" dirty="0"/>
-              <a:t>(~45 s) Workshop 2 plan. First, Bayesian beliefs, weather scenarios tied to the calendar with odds from climatology data, and the three Red attacks already coded; we also decide whether to keep the theater-wide movement budget, which stands in for operational requirements and station-keeping. Then learning agents: does a learning Red exploit predictable Blue play? Then redesigns under attack and long typhoons, with a cost for de-escalation measures. Final report December 8. Thank you; happy to take questions.</a:t>
+              <a:t>(~45 s) Workshop 2 plan. First, Bayesian beliefs, weather scenarios tied to the calendar with odds from climatology data, and the three Red attacks already coded. We also decide whether to keep the theater-wide movement budget, which stands in for operational requirements and station-keeping. Then learning agents. Does a learning Red exploit predictable Blue play? Then redesigns under attack and long typhoons, with a cost for de-escalation measures. Final report December 8. Thank you. We are happy to take questions.</a:t>
             </a:r>
             <a:endParaRPr lang="en-US" dirty="0"/>
           </a:p>
@@ -1640,7 +1640,7 @@
           <a:p>
             <a:r>
               <a:rPr lang="en-US" dirty="0"/>
-              <a:t>(~60 s) China claims most of the South China Sea and contests the Senkakus, pressing those claims with coast guard and militia hulls backed by navy ships; the U.S. keeps the seas open with destroyers on presence and freedom-of-navigation patrols (Helmus 2024; Green 2017). Squares are home ports, circles are the eight contested zones, grouped North, Center, South. Dashed lines are the extra Philippine port, one of our redesigns. Three things make this a game rather than a single optimization: control is relative, so my best move depends on yours; escalation risk is shared, because incidents need both sides present and war costs both; and neither side sees the other's full fleet, only the ships where it also has ships.</a:t>
+              <a:t>(~60 s) China claims most of the South China Sea and contests the Senkakus, pressing those claims with coast guard and militia hulls backed by navy ships. The U.S. keeps the seas open with destroyers on presence and freedom-of-navigation patrols (Helmus 2024; Green 2017). Squares are home ports, circles are the eight contested zones, grouped North, Center, South. Dashed lines are the extra Philippine port, one of our redesigns. Three things make this a game rather than a single optimization. Control is relative, so my best move depends on yours. Escalation risk is shared, because incidents need both sides present and war costs both. And neither side sees the other's full fleet, only the ships where it also has ships.</a:t>
             </a:r>
             <a:endParaRPr lang="en-US" dirty="0"/>
           </a:p>
@@ -1728,7 +1728,7 @@
           <a:p>
             <a:r>
               <a:rPr lang="en-US" dirty="0"/>
-              <a:t>(~60 s) Three questions. RQ1: each side caps the incident risk it accepts per period; how much control does more risk buy, how much likelier does war become, and what cap does each side pick when the other is picking too? RQ2: does a side that plans with game theory beat one that follows simple rules, and can both sides stay at patrol over many periods, because asserting once would end the truce and push both into riskier play from then on? RQ3, from Prof. Sapsis's comment: does the best plan or Blue redesign in normal weather stay best across calm, typhoon and extreme weather scenarios, on average and in the worst scenario? The table maps each piece of Deliverable 1 feedback to what we changed. The main one: the model is now fully formal, and the proposal's strategy types are a single risk-budget number inside a MIP.</a:t>
+              <a:t>(~60 s) Three questions. RQ1 asks this. Each side caps the incident risk it accepts per period. How much control does more risk buy, how much likelier does war become, and what cap does each side pick when the other is picking too? RQ2 asks whether a side that plans with game theory beat one that follows simple rules, and can both sides stay at patrol over many periods, because asserting once would end the truce and push both into riskier play from then on? RQ3 comes from Prof. Sapsis's comment. Does the best plan or Blue redesign in normal weather stay best across calm, typhoon and extreme weather scenarios, on average and in the worst scenario? The table maps each piece of Deliverable 1 feedback to what we changed. The main change is that the model is now fully formal, and the proposal's strategy types are a single risk-budget number inside a MIP.</a:t>
             </a:r>
             <a:endParaRPr lang="en-US" dirty="0"/>
           </a:p>
@@ -1816,7 +1816,7 @@
           <a:p>
             <a:r>
               <a:rPr lang="en-US" dirty="0"/>
-              <a:t>(~70 s) Walk the timeline top to bottom: this is one two-day turn. The weather is drawn first, then both sides move at the same time without seeing each other's full fleet. The box holds all the dynamics. Control moves 30% of the way toward the local force ratio each turn. Incidents need both sides present, and are likelier when someone asserts and when tensions are already high. Payoff is value of zones held minus fuel, tension, and for Blue the running cost of its redesign, zeta-D; war costs both sides 200, so the game is not zero-sum. If asked: every number is our assumption, listed in Table 1 of the report.</a:t>
+              <a:t>(~70 s) Walk the timeline top to bottom. This is one two-day turn. The weather is drawn first, then both sides move at the same time without seeing each other's full fleet. The box holds all the dynamics. Control moves 30% of the way toward the local force ratio each turn. Incidents need both sides present, and are likelier when someone asserts and when tensions are already high. Payoff is value of zones held minus fuel, tension, and for Blue the running cost of its redesign, zeta-D. War costs both sides 200, so the game is not zero-sum. If asked, every number is our assumption, listed in Table 1 of the report.</a:t>
             </a:r>
             <a:endParaRPr lang="en-US" dirty="0"/>
           </a:p>
@@ -1904,7 +1904,7 @@
           <a:p>
             <a:r>
               <a:rPr lang="en-US" dirty="0"/>
-              <a:t>(~60 s) Two ways to decide. Left: each turn a player solves a mixed-integer program (MIP) to pick moves, with a cap on expected incidents, epsilon. This answers the feedback that Q1 is a feasible region. Middle: for equilibrium analysis we shrink each side to 14 templates and solve the 14-by-14 game exactly. Right: the six policies we compare. All of them see the same random draws.</a:t>
+              <a:t>(~60 s) Two ways to decide. On the left, each turn a player solves a mixed-integer program (MIP) to pick moves, with a cap on expected incidents, epsilon. This answers the feedback that Q1 is a feasible region. In the middle, for equilibrium analysis we shrink each side to 14 templates and solve the 14-by-14 game exactly. On the right are the six policies we compare. All of them see the same random draws.</a:t>
             </a:r>
             <a:endParaRPr lang="en-US" dirty="0"/>
           </a:p>
@@ -1992,7 +1992,7 @@
           <a:p>
             <a:r>
               <a:rPr lang="en-US" dirty="0"/>
-              <a:t>(~70 s) A small example from our own game. Fix where ships go; each side only chooses patrol or assert. Read the table: asserting against a patroller pays a little, but if both assert, both lose more than 11. So the best reply is to do the opposite of the other side: an anti-coordination game. Two fixes: a correlated equilibrium, which is what a mediator or hotline can implement, never recommends both asserting; and in the repeated game, a standing threat (if either side pushes, the truce is off for good and both fall back to the mixed equilibrium) makes mutual patrolling a subgame perfect equilibrium whenever the discount factor is above 0.18. Ours is 0.98.</a:t>
+              <a:t>(~70 s) A small example from our own game. Fix where ships go, so each side only chooses patrol or assert. In the table, asserting against a patroller pays a little, but if both assert, both lose more than 11. So the best reply is to do the opposite of the other side. That is an anti-coordination game. There are two fixes. First, a correlated equilibrium, which a mediator or hotline can implement, never recommends both asserting. Second, in the repeated game, a standing threat (if either side pushes, the truce is off for good and both fall back to the mixed equilibrium) makes mutual patrolling a subgame perfect equilibrium whenever the discount factor is above 0.18. Ours is 0.98.</a:t>
             </a:r>
             <a:endParaRPr lang="en-US" dirty="0"/>
           </a:p>
@@ -2080,7 +2080,7 @@
           <a:p>
             <a:r>
               <a:rPr lang="en-US" dirty="0"/>
-              <a:t>(~60 s, or a 60 s live demo) This is the prototype. Pick a plan for each side, a design and the weather, then Step or Play. Zone color is who controls it. Letters count ships. Thick outlines mean asserting, an orange ring is an incident, shading is bad weather. Bottom left is the escalation ladder; level 5 is war. 'Run many games' gives averages. The screenshot is turn 12 with a storm over the North. The same file runs batch experiments; a second script reproduces every number in the report.</a:t>
+              <a:t>(~60 s, or a 60 s live demo) This is the prototype. Pick a plan for each side, a design and the weather, then Step or Play. Zone color is who controls it. Letters count ships. Thick outlines mean asserting, an orange ring is an incident, shading is bad weather. Bottom left is the escalation ladder. Level 5 is war. 'Run many games' gives averages. The screenshot is turn 12 with a storm over the North. The same file runs batch experiments, and a second script reproduces every number in the report.</a:t>
             </a:r>
             <a:endParaRPr lang="en-US" dirty="0"/>
           </a:p>
@@ -2168,7 +2168,7 @@
           <a:p>
             <a:r>
               <a:rPr lang="en-US" dirty="0"/>
-              <a:t>(~60 s) Left: Blue loosens its risk budget while Red stays moderate. Control rises fast up to about 0.15, then flattens, while war risk keeps rising. Right: both sides choose a budget. Aggressive is the best reply to anything, for both, so the only equilibrium is aggressive-aggressive, with the highest war rate, 34%. That is a prisoner's dilemma. Restraint has to come from repetition or coordination, as in the previous example.</a:t>
+              <a:t>(~60 s) On the left, Blue loosens its risk budget while Red stays moderate. Control rises fast up to about 0.15, then flattens, while war risk keeps rising. On the right, both sides choose a budget. Aggressive is the best reply to anything, for both, so the only equilibrium is aggressive-aggressive, with the highest war rate, 34%. Both would do better at moderate-moderate. Blue gets −144 instead of −151, Red gets 101 instead of 39, and war falls to 20%. That is a prisoner's dilemma. Restraint has to come from repetition or coordination, as in the previous example.</a:t>
             </a:r>
             <a:endParaRPr lang="en-US" dirty="0"/>
           </a:p>
@@ -2256,7 +2256,7 @@
           <a:p>
             <a:r>
               <a:rPr lang="en-US" dirty="0"/>
-              <a:t>(~60 s) Each Blue policy plays three Red policies, 200 games each; the bar is Blue's payoff against its worst opponent. The Nash equilibrium plan has the best worst case, and half the war rate of the MIP best response. Best responses do well against weak opponents but escalate. The safety-first plan is cautious but gives up control. Differences under about 20 points are within noise.</a:t>
+              <a:t>(~60 s) Each Blue policy plays three Red policies, 200 games each. The bar is Blue's payoff against its worst opponent. The Nash equilibrium plan has the best worst case, and half the war rate of the MIP best response. Best responses do well against weak opponents but escalate. The safety-first plan is cautious but gives up control.</a:t>
             </a:r>
             <a:endParaRPr lang="en-US" dirty="0"/>
           </a:p>
@@ -3154,7 +3154,7 @@
                   <a:schemeClr val="accent5"/>
                 </a:solidFill>
               </a:rPr>
-              <a:t>War rate (normal weather): D0 20%, D1 28%, D2 23%, D3 5%. De-escalation measures were given no cost yet.</a:t>
+              <a:t>War rate in normal weather is D0 20%, D1 28%, D2 23%, D3 5%. De-escalation measures were given no cost yet.</a:t>
             </a:r>
             <a:endParaRPr lang="en-US" sz="1300" dirty="0"/>
           </a:p>
@@ -3646,7 +3646,7 @@
                   <a:schemeClr val="tx1"/>
                 </a:solidFill>
               </a:rPr>
-              <a:t>War penalty may be too small: the top-payoff policy also has the most wars</a:t>
+              <a:t>War penalty may be too small. The top-payoff policy also has the most wars</a:t>
             </a:r>
             <a:endParaRPr lang="en-US" sz="1600" dirty="0"/>
           </a:p>
@@ -3665,24 +3665,6 @@
                 </a:solidFill>
               </a:rPr>
               <a:t>De-escalation measures have no cost yet, so part of their win is built in</a:t>
-            </a:r>
-            <a:endParaRPr lang="en-US" sz="1600" dirty="0"/>
-          </a:p>
-          <a:p>
-            <a:pPr marL="342900" indent="-342900">
-              <a:spcAft>
-                <a:spcPts val="600"/>
-              </a:spcAft>
-              <a:buSzPct val="100000"/>
-              <a:buChar char="•"/>
-            </a:pPr>
-            <a:r>
-              <a:rPr lang="en-US" sz="1600" dirty="0">
-                <a:solidFill>
-                  <a:schemeClr val="tx1"/>
-                </a:solidFill>
-              </a:rPr>
-              <a:t>Differences under about 20 payoff points are ties</a:t>
             </a:r>
             <a:endParaRPr lang="en-US" sz="1600" dirty="0"/>
           </a:p>
@@ -3941,7 +3923,7 @@
                   <a:schemeClr val="tx1"/>
                 </a:solidFill>
               </a:rPr>
-              <a:t>Bayesian beliefs about enemy positions; weather tied to the calendar (typhoon season, winter monsoon) with odds from climatology data; test the three coded Red attacks (blockade, jamming, false contacts); decide whether to keep the movement budget or drop it</a:t>
+              <a:t>Bayesian beliefs about enemy positions. Weather tied to the calendar (typhoon season, winter monsoon) with odds from climatology data. Test the three coded Red attacks (blockade, jamming, false contacts). Decide whether to keep the movement budget</a:t>
             </a:r>
             <a:endParaRPr lang="en-US" sz="1500" dirty="0"/>
           </a:p>
@@ -4069,7 +4051,7 @@
                   <a:schemeClr val="tx1"/>
                 </a:solidFill>
               </a:rPr>
-              <a:t>Red agents that learn from experience: do they exploit predictable Blue play? An attacker that moves after seeing Blue</a:t>
+              <a:t>Red agents that learn from experience. Do they exploit predictable Blue play? An attacker that moves after seeing Blue</a:t>
             </a:r>
             <a:endParaRPr lang="en-US" sz="1500" dirty="0"/>
           </a:p>
@@ -4197,7 +4179,7 @@
                   <a:schemeClr val="tx1"/>
                 </a:solidFill>
               </a:rPr>
-              <a:t>Designs and combinations under attacks, persistent weather and a rare long typhoon; a cost for de-escalation measures</a:t>
+              <a:t>Designs and combinations under attacks, persistent weather and a rare long typhoon. A cost for de-escalation measures</a:t>
             </a:r>
             <a:endParaRPr lang="en-US" sz="1500" dirty="0"/>
           </a:p>
@@ -4399,7 +4381,7 @@
                   <a:schemeClr val="tx1"/>
                 </a:solidFill>
               </a:rPr>
-              <a:t>Next: learning, attacks and defenses, and resilient design, in that order.</a:t>
+              <a:t>Next come learning, attacks and defenses, and resilient design, in that order.</a:t>
             </a:r>
             <a:endParaRPr lang="en-US" sz="1600" dirty="0"/>
           </a:p>
@@ -4647,7 +4629,7 @@
                   <a:schemeClr val="tx1"/>
                 </a:solidFill>
               </a:rPr>
-              <a:t>Each side chooses where its ships go and whether to patrol (P) or assert (A: shadowing, close maneuvering, querying and warning; for the U.S. also freedom-of-navigation operations).</a:t>
+              <a:t>Each side chooses where its ships go and whether to patrol (P) or assert (A). Asserting means shadowing, close maneuvering, or querying and warning. For the U.S. it also covers freedom-of-navigation operations.</a:t>
             </a:r>
             <a:endParaRPr lang="en-US" sz="1800" dirty="0"/>
           </a:p>
@@ -4705,7 +4687,7 @@
                   <a:schemeClr val="tx1"/>
                 </a:solidFill>
               </a:rPr>
-              <a:t>can happen when both sides are present, and are likelier if someone asserts. Incidents raise an escalation level; at the top is war, which costs both sides.</a:t>
+              <a:t>can happen when both sides are present, and are likelier if someone asserts. Incidents raise an escalation level. At the top is war, which costs both sides.</a:t>
             </a:r>
             <a:endParaRPr lang="en-US" sz="1800" dirty="0"/>
           </a:p>
@@ -4734,7 +4716,7 @@
                   <a:schemeClr val="tx1"/>
                 </a:solidFill>
               </a:rPr>
-              <a:t>Neither side sees the other's entire fleet disposition; only forces present where they also maintain forces. Storms can close zones.</a:t>
+              <a:t>Neither side sees the other's entire fleet disposition, only forces present where it also maintains forces. Storms can close zones.</a:t>
             </a:r>
             <a:endParaRPr lang="en-US" sz="1800" dirty="0"/>
           </a:p>
@@ -5507,7 +5489,7 @@
                             <a:schemeClr val="tx1"/>
                           </a:solidFill>
                         </a:rPr>
-                        <a:t>Best response is an exact MIP; commander types become risk budgets ε</a:t>
+                        <a:t>Best response is an exact MIP. Commander types become risk budgets ε</a:t>
                       </a:r>
                       <a:endParaRPr lang="en-US" sz="1200" dirty="0"/>
                     </a:p>
@@ -5979,7 +5961,7 @@
                             <a:schemeClr val="tx1"/>
                           </a:solidFill>
                         </a:rPr>
-                        <a:t>Analytical results; 77 setups × 200 simulated games</a:t>
+                        <a:t>Analytical results, plus 77 setups × 200 simulated games</a:t>
                       </a:r>
                       <a:endParaRPr lang="en-US" sz="1200" dirty="0"/>
                     </a:p>
@@ -6097,7 +6079,7 @@
                             <a:schemeClr val="tx1"/>
                           </a:solidFill>
                         </a:rPr>
-                        <a:t>Weather scenarios; expected and worst-case payoff</a:t>
+                        <a:t>Weather scenarios, scored by expected and worst-case payoff</a:t>
                       </a:r>
                       <a:endParaRPr lang="en-US" sz="1200" dirty="0"/>
                     </a:p>
@@ -6800,7 +6782,7 @@
                   <a:schemeClr val="tx1"/>
                 </a:solidFill>
               </a:rPr>
-              <a:t>Control updates; incidents are drawn; escalation level moves</a:t>
+              <a:t>Control updates. Incidents are drawn. The escalation level moves</a:t>
             </a:r>
             <a:endParaRPr lang="en-US" sz="1600" dirty="0"/>
           </a:p>
@@ -6892,7 +6874,7 @@
                   <a:schemeClr val="tx1"/>
                 </a:solidFill>
               </a:rPr>
-              <a:t>Payoffs are paid; stop at war or after 60 periods</a:t>
+              <a:t>Payoffs are paid. The game stops at war or after 60 periods</a:t>
             </a:r>
             <a:endParaRPr lang="en-US" sz="1600" dirty="0"/>
           </a:p>
@@ -6986,7 +6968,7 @@
                   <a:schemeClr val="accent5"/>
                 </a:solidFill>
               </a:rPr>
-              <a:t>Presence builds control slowly; leaving lets it decay.</a:t>
+              <a:t>Presence builds control slowly. Leaving lets it decay.</a:t>
             </a:r>
             <a:endParaRPr lang="en-US" sz="1400" dirty="0"/>
           </a:p>
@@ -7045,7 +7027,7 @@
                   <a:schemeClr val="accent5"/>
                 </a:solidFill>
               </a:rPr>
-              <a:t>Needs both sides present; grows with assertion and with the escalation level ℓ.</a:t>
+              <a:t>Needs both sides present. Grows with assertion and with the escalation level ℓ.</a:t>
             </a:r>
             <a:endParaRPr lang="en-US" sz="1400" dirty="0"/>
           </a:p>
@@ -7408,7 +7390,7 @@
                   <a:schemeClr val="tx1"/>
                 </a:solidFill>
               </a:rPr>
-              <a:t>Each period, choose moves and postures to maximize value of control minus costs, subject to the movement budget, endurance, and an escalation-risk budget:</a:t>
+              <a:t>Each period, choose moves and postures to maximize value of control minus costs, subject to the movement budget, endurance, and an escalation-risk budget.</a:t>
             </a:r>
             <a:endParaRPr lang="en-US" sz="1500" dirty="0"/>
           </a:p>
@@ -7428,7 +7410,7 @@
                   <a:schemeClr val="tx1"/>
                 </a:solidFill>
               </a:rPr>
-              <a:t>expected incidents ≤ ε</a:t>
+              <a:t>Expected incidents ≤ ε</a:t>
             </a:r>
             <a:endParaRPr lang="en-US" sz="1500" dirty="0"/>
           </a:p>
@@ -7586,7 +7568,7 @@
                   <a:schemeClr val="tx1"/>
                 </a:solidFill>
               </a:rPr>
-              <a:t>Abstract each side to 14 templates: how to split ships North / Center / South, and patrol or assert.</a:t>
+              <a:t>Abstract each side to 14 templates. A template says how to split ships North / Center / South, and whether to patrol or assert.</a:t>
             </a:r>
             <a:endParaRPr lang="en-US" sz="1500" dirty="0"/>
           </a:p>
@@ -9022,7 +9004,7 @@
                   <a:schemeClr val="tx1"/>
                 </a:solidFill>
               </a:rPr>
-              <a:t>a plan for each side, a design and the weather on the right; press New game, then Step or Play. Help explains the map.</a:t>
+              <a:t>a plan for each side, a design and the weather on the right. Press New game, then Step or Play. Help explains the map.</a:t>
             </a:r>
             <a:endParaRPr lang="en-US" sz="1600" dirty="0"/>
           </a:p>
@@ -9051,7 +9033,7 @@
                   <a:schemeClr val="tx1"/>
                 </a:solidFill>
               </a:rPr>
-              <a:t>shows control: blue = Blue, red = Red.</a:t>
+              <a:t>shows control. Blue = Blue, red = Red.</a:t>
             </a:r>
             <a:endParaRPr lang="en-US" sz="1600" dirty="0"/>
           </a:p>
@@ -10412,7 +10394,7 @@
                   <a:schemeClr val="accent5"/>
                 </a:solidFill>
               </a:rPr>
-              <a:t>Risk-budget game: payoffs (Blue, Red) and war rate. Red bold = the only equilibrium.</a:t>
+              <a:t>Risk-budget game. Payoffs (Blue, Red) and war rate. Red bold = the only equilibrium.</a:t>
             </a:r>
             <a:endParaRPr lang="en-US" sz="1200" dirty="0"/>
           </a:p>
@@ -10448,7 +10430,7 @@
                   <a:schemeClr val="accent5"/>
                 </a:solidFill>
               </a:rPr>
-              <a:t>Raising Blue's budget from 0.02 to 0.15 lifts its control a lot; beyond 0.25 it barely moves.</a:t>
+              <a:t>Raising Blue's budget from 0.02 to 0.15 lifts its control a lot. Beyond 0.25 it barely moves.</a:t>
             </a:r>
             <a:endParaRPr lang="en-US" sz="1300" dirty="0"/>
           </a:p>
@@ -10522,7 +10504,7 @@
                   <a:schemeClr val="tx1"/>
                 </a:solidFill>
               </a:rPr>
-              <a:t>Both sides choose aggressive, giving the highest war rate (34%): a prisoner's dilemma.</a:t>
+              <a:t>Both sides choose aggressive (war 34%), yet both do better at moderate (war 20%). That is a prisoner's dilemma.</a:t>
             </a:r>
             <a:endParaRPr lang="en-US" sz="1600" dirty="0"/>
           </a:p>

</xml_diff>

<commit_message>
Slides: restore the ties caveat to match the paper
</commit_message>
<xml_diff>
--- a/deliverables/02-workshop1-slides.pptx
+++ b/deliverables/02-workshop1-slides.pptx
@@ -118,20 +118,20 @@
   <p:extLst>
     <p:ext uri="{521415D9-36F7-43E2-AB2F-B90AF26B5E84}">
       <p14:sectionLst xmlns:p14="http://schemas.microsoft.com/office/powerpoint/2010/main">
-        <p14:section name="Introduction" id="{0fbe3ec4-8020-b131-25f0-b670e24e2bf3}">
+        <p14:section name="Introduction" id="{f5e8e2f3-d7bc-3698-a8ba-355479acce70}">
           <p14:sldIdLst>
             <p14:sldId id="256"/>
             <p14:sldId id="257"/>
             <p14:sldId id="258"/>
           </p14:sldIdLst>
         </p14:section>
-        <p14:section name="Model" id="{50465000-f2f7-f02c-a98d-4cc76d50dd65}">
+        <p14:section name="Model" id="{cdf5e4da-6913-bd85-f877-02b3e33aa109}">
           <p14:sldIdLst>
             <p14:sldId id="259"/>
             <p14:sldId id="260"/>
           </p14:sldIdLst>
         </p14:section>
-        <p14:section name="Results" id="{0d4d7b2c-8def-66d2-44e1-402d25f4ee21}">
+        <p14:section name="Results" id="{9dfbe3bd-60c0-7b14-784b-7b13aaadd2fa}">
           <p14:sldIdLst>
             <p14:sldId id="261"/>
             <p14:sldId id="262"/>
@@ -141,7 +141,7 @@
             <p14:sldId id="266"/>
           </p14:sldIdLst>
         </p14:section>
-        <p14:section name="Next steps" id="{01a5634c-46eb-07d1-27d4-cf729a40bd8f}">
+        <p14:section name="Next steps" id="{1538b483-61e4-6345-cc4d-16d46052991b}">
           <p14:sldIdLst>
             <p14:sldId id="267"/>
           </p14:sldIdLst>
@@ -2256,7 +2256,7 @@
           <a:p>
             <a:r>
               <a:rPr lang="en-US" dirty="0"/>
-              <a:t>(~60 s) Each Blue policy plays three Red policies, 200 games each. The bar is Blue's payoff against its worst opponent. The Nash equilibrium plan has the best worst case, and half the war rate of the MIP best response. Best responses do well against weak opponents but escalate. The safety-first plan is cautious but gives up control.</a:t>
+              <a:t>(~60 s) Each Blue policy plays three Red policies, 200 games each. The bar is Blue's payoff against its worst opponent. The Nash equilibrium plan has the best worst case, and half the war rate of the MIP best response. Best responses do well against weak opponents but escalate. The safety-first plan is cautious but gives up control. Differences under about 20 points are ties.</a:t>
             </a:r>
             <a:endParaRPr lang="en-US" dirty="0"/>
           </a:p>
@@ -3665,6 +3665,24 @@
                 </a:solidFill>
               </a:rPr>
               <a:t>De-escalation measures have no cost yet, so part of their win is built in</a:t>
+            </a:r>
+            <a:endParaRPr lang="en-US" sz="1600" dirty="0"/>
+          </a:p>
+          <a:p>
+            <a:pPr marL="342900" indent="-342900">
+              <a:spcAft>
+                <a:spcPts val="600"/>
+              </a:spcAft>
+              <a:buSzPct val="100000"/>
+              <a:buChar char="•"/>
+            </a:pPr>
+            <a:r>
+              <a:rPr lang="en-US" sz="1600" dirty="0">
+                <a:solidFill>
+                  <a:schemeClr val="tx1"/>
+                </a:solidFill>
+              </a:rPr>
+              <a:t>Differences under about 20 payoff points are ties</a:t>
             </a:r>
             <a:endParaRPr lang="en-US" sz="1600" dirty="0"/>
           </a:p>

</xml_diff>

<commit_message>
Workshop 1 slides: navy and gold theme, Franklin Gothic, destroyer title photo
Title photo is USS Kidd (DDG 100) underway in the Pacific, U.S. Navy photo 110518-N-OI955-090 (public domain).
</commit_message>
<xml_diff>
--- a/deliverables/02-workshop1-slides.pptx
+++ b/deliverables/02-workshop1-slides.pptx
@@ -119,7 +119,7 @@
   <p:extLst>
     <p:ext uri="{521415D9-36F7-43E2-AB2F-B90AF26B5E84}">
       <p14:sectionLst xmlns:p14="http://schemas.microsoft.com/office/powerpoint/2010/main">
-        <p14:section name="Introduction" id="{808ef798-ba40-4087-aad4-88dbb231a70f}">
+        <p14:section name="Introduction" id="{9d943e11-28f3-a7a0-daf9-6f332cc9e2ef}">
           <p14:sldIdLst>
             <p14:sldId id="256"/>
             <p14:sldId id="257"/>
@@ -127,13 +127,13 @@
             <p14:sldId id="259"/>
           </p14:sldIdLst>
         </p14:section>
-        <p14:section name="Model" id="{13a136d4-9f28-bea6-8b8c-60ffee568c11}">
+        <p14:section name="Model" id="{d7b41c09-5649-16f1-c14b-08ba2e03d35d}">
           <p14:sldIdLst>
             <p14:sldId id="260"/>
             <p14:sldId id="261"/>
           </p14:sldIdLst>
         </p14:section>
-        <p14:section name="Results" id="{bc0d337e-be32-8fbf-7c32-781afd1040b9}">
+        <p14:section name="Results" id="{71154c76-f399-c5ce-e552-fdb92830e052}">
           <p14:sldIdLst>
             <p14:sldId id="262"/>
             <p14:sldId id="263"/>
@@ -143,7 +143,7 @@
             <p14:sldId id="267"/>
           </p14:sldIdLst>
         </p14:section>
-        <p14:section name="Next steps" id="{7a378030-f6af-aa70-e420-ee2ea23d6350}">
+        <p14:section name="Next steps" id="{52cfb7bc-7fac-cf48-2c15-5619c4ddc974}">
           <p14:sldIdLst>
             <p14:sldId id="268"/>
           </p14:sldIdLst>
@@ -171,7 +171,7 @@
             <a:pPr>
               <a:defRPr sz="1400" b="0" i="0" u="none" strike="noStrike">
                 <a:solidFill>
-                  <a:srgbClr val="0B2545"/>
+                  <a:srgbClr val="0B1F3A"/>
                 </a:solidFill>
                 <a:latin typeface="+mn-lt"/>
               </a:defRPr>
@@ -179,7 +179,7 @@
             <a:r>
               <a:rPr sz="1400" b="0" i="0" u="none" strike="noStrike">
                 <a:solidFill>
-                  <a:srgbClr val="0B2545"/>
+                  <a:srgbClr val="0B1F3A"/>
                 </a:solidFill>
                 <a:latin typeface="+mn-lt"/>
               </a:rPr>
@@ -214,7 +214,7 @@
           </c:tx>
           <c:spPr>
             <a:solidFill>
-              <a:srgbClr val="6B7A8F"/>
+              <a:srgbClr val="5E6B7D"/>
             </a:solidFill>
             <a:effectLst/>
           </c:spPr>
@@ -228,7 +228,7 @@
                 <a:pPr>
                   <a:defRPr b="0" i="0" strike="noStrike" sz="1200" u="none">
                     <a:solidFill>
-                      <a:srgbClr val="1B2430"/>
+                      <a:srgbClr val="1A2233"/>
                     </a:solidFill>
                     <a:latin typeface="+mn-lt"/>
                   </a:defRPr>
@@ -249,7 +249,7 @@
             <c:bubble3D val="0"/>
             <c:spPr>
               <a:solidFill>
-                <a:srgbClr val="6B7A8F"/>
+                <a:srgbClr val="5E6B7D"/>
               </a:solidFill>
               <a:effectLst/>
             </c:spPr>
@@ -260,7 +260,7 @@
             <c:bubble3D val="0"/>
             <c:spPr>
               <a:solidFill>
-                <a:srgbClr val="6B7A8F"/>
+                <a:srgbClr val="5E6B7D"/>
               </a:solidFill>
               <a:effectLst/>
             </c:spPr>
@@ -271,7 +271,7 @@
             <c:bubble3D val="0"/>
             <c:spPr>
               <a:solidFill>
-                <a:srgbClr val="6B7A8F"/>
+                <a:srgbClr val="5E6B7D"/>
               </a:solidFill>
               <a:effectLst/>
             </c:spPr>
@@ -282,7 +282,7 @@
             <c:bubble3D val="0"/>
             <c:spPr>
               <a:solidFill>
-                <a:srgbClr val="1F4E9C"/>
+                <a:srgbClr val="1D3E72"/>
               </a:solidFill>
               <a:effectLst/>
             </c:spPr>
@@ -293,7 +293,7 @@
             <c:bubble3D val="0"/>
             <c:spPr>
               <a:solidFill>
-                <a:srgbClr val="1F4E9C"/>
+                <a:srgbClr val="1D3E72"/>
               </a:solidFill>
               <a:effectLst/>
             </c:spPr>
@@ -304,7 +304,7 @@
             <c:bubble3D val="0"/>
             <c:spPr>
               <a:solidFill>
-                <a:srgbClr val="13807A"/>
+                <a:srgbClr val="B8901E"/>
               </a:solidFill>
               <a:effectLst/>
             </c:spPr>
@@ -374,7 +374,7 @@
               <a:pPr>
                 <a:defRPr b="0" i="0" strike="noStrike" sz="1200" u="none">
                   <a:solidFill>
-                    <a:srgbClr val="1B2430"/>
+                    <a:srgbClr val="1A2233"/>
                   </a:solidFill>
                   <a:latin typeface="+mn-lt"/>
                 </a:defRPr>
@@ -422,7 +422,7 @@
             <a:pPr>
               <a:defRPr sz="1300" b="0" i="0" u="none" strike="noStrike">
                 <a:solidFill>
-                  <a:srgbClr val="1B2430"/>
+                  <a:srgbClr val="1A2233"/>
                 </a:solidFill>
                 <a:latin typeface="+mn-lt"/>
               </a:defRPr>
@@ -476,7 +476,7 @@
             <a:pPr>
               <a:defRPr sz="1100" b="0" i="0" u="none" strike="noStrike">
                 <a:solidFill>
-                  <a:srgbClr val="6B7A8F"/>
+                  <a:srgbClr val="5E6B7D"/>
                 </a:solidFill>
                 <a:latin typeface="+mn-lt"/>
               </a:defRPr>
@@ -526,7 +526,7 @@
             <a:pPr>
               <a:defRPr sz="1400" b="0" i="0" u="none" strike="noStrike">
                 <a:solidFill>
-                  <a:srgbClr val="0B2545"/>
+                  <a:srgbClr val="0B1F3A"/>
                 </a:solidFill>
                 <a:latin typeface="+mn-lt"/>
               </a:defRPr>
@@ -534,7 +534,7 @@
             <a:r>
               <a:rPr sz="1400" b="0" i="0" u="none" strike="noStrike">
                 <a:solidFill>
-                  <a:srgbClr val="0B2545"/>
+                  <a:srgbClr val="0B1F3A"/>
                 </a:solidFill>
                 <a:latin typeface="+mn-lt"/>
               </a:rPr>
@@ -569,7 +569,7 @@
           </c:tx>
           <c:spPr>
             <a:solidFill>
-              <a:srgbClr val="1F4E9C"/>
+              <a:srgbClr val="1D3E72"/>
             </a:solidFill>
             <a:effectLst/>
           </c:spPr>
@@ -583,7 +583,7 @@
                 <a:pPr>
                   <a:defRPr b="0" i="0" strike="noStrike" sz="1100" u="none">
                     <a:solidFill>
-                      <a:srgbClr val="1B2430"/>
+                      <a:srgbClr val="1A2233"/>
                     </a:solidFill>
                     <a:latin typeface="+mn-lt"/>
                   </a:defRPr>
@@ -658,7 +658,7 @@
           </c:tx>
           <c:spPr>
             <a:solidFill>
-              <a:srgbClr val="B23A48"/>
+              <a:srgbClr val="A97C14"/>
             </a:solidFill>
             <a:effectLst/>
           </c:spPr>
@@ -672,7 +672,7 @@
                 <a:pPr>
                   <a:defRPr b="0" i="0" strike="noStrike" sz="1100" u="none">
                     <a:solidFill>
-                      <a:srgbClr val="1B2430"/>
+                      <a:srgbClr val="1A2233"/>
                     </a:solidFill>
                     <a:latin typeface="+mn-lt"/>
                   </a:defRPr>
@@ -740,7 +740,7 @@
               <a:pPr>
                 <a:defRPr b="0" i="0" strike="noStrike" sz="1100" u="none">
                   <a:solidFill>
-                    <a:srgbClr val="1B2430"/>
+                    <a:srgbClr val="1A2233"/>
                   </a:solidFill>
                   <a:latin typeface="+mn-lt"/>
                 </a:defRPr>
@@ -788,7 +788,7 @@
             <a:pPr>
               <a:defRPr sz="1200" b="0" i="0" u="none" strike="noStrike">
                 <a:solidFill>
-                  <a:srgbClr val="1B2430"/>
+                  <a:srgbClr val="1A2233"/>
                 </a:solidFill>
                 <a:latin typeface="+mn-lt"/>
               </a:defRPr>
@@ -842,7 +842,7 @@
             <a:pPr>
               <a:defRPr sz="1100" b="0" i="0" u="none" strike="noStrike">
                 <a:solidFill>
-                  <a:srgbClr val="6B7A8F"/>
+                  <a:srgbClr val="5E6B7D"/>
                 </a:solidFill>
                 <a:latin typeface="+mn-lt"/>
               </a:defRPr>
@@ -2452,8 +2452,8 @@
         </p:nvSpPr>
         <p:spPr>
           <a:xfrm>
-            <a:off x="731520" y="2103120"/>
-            <a:ext cx="10698480" cy="1463040"/>
+            <a:off x="731520" y="1737360"/>
+            <a:ext cx="5669280" cy="2194560"/>
           </a:xfrm>
           <a:prstGeom prst="rect">
             <a:avLst/>
@@ -2464,9 +2464,9 @@
         <p:txBody>
           <a:bodyPr wrap="square" rtlCol="0"/>
           <a:lstStyle>
-            <a:lvl1pPr indent="0" marL="0">
-              <a:buNone/>
-              <a:defRPr lang="en-US" sz="4000" b="1" dirty="0">
+            <a:lvl1pPr algn="l" indent="0" marL="0">
+              <a:buNone/>
+              <a:defRPr lang="en-US" sz="3800" b="1" dirty="0">
                 <a:solidFill>
                   <a:schemeClr val="bg1"/>
                 </a:solidFill>
@@ -2474,10 +2474,10 @@
             </a:lvl1pPr>
           </a:lstStyle>
           <a:p>
-            <a:pPr indent="0" marL="0">
-              <a:buNone/>
-            </a:pPr>
-            <a:endParaRPr lang="en-US" sz="4000" dirty="0"/>
+            <a:pPr algn="l" indent="0" marL="0">
+              <a:buNone/>
+            </a:pPr>
+            <a:endParaRPr lang="en-US" sz="3800" dirty="0"/>
           </a:p>
         </p:txBody>
       </p:sp>
@@ -2491,8 +2491,8 @@
         </p:nvSpPr>
         <p:spPr>
           <a:xfrm>
-            <a:off x="731520" y="3703320"/>
-            <a:ext cx="10698480" cy="1463040"/>
+            <a:off x="731520" y="4343400"/>
+            <a:ext cx="5669280" cy="1280160"/>
           </a:xfrm>
           <a:prstGeom prst="rect">
             <a:avLst/>
@@ -2503,17 +2503,17 @@
         <p:txBody>
           <a:bodyPr wrap="square" rtlCol="0"/>
           <a:lstStyle>
-            <a:lvl1pPr indent="0" marL="0">
+            <a:lvl1pPr algn="l" indent="0" marL="0">
               <a:buNone/>
               <a:defRPr lang="en-US" sz="1800" dirty="0">
                 <a:solidFill>
-                  <a:schemeClr val="accent6"/>
+                  <a:schemeClr val="accent3"/>
                 </a:solidFill>
               </a:defRPr>
             </a:lvl1pPr>
           </a:lstStyle>
           <a:p>
-            <a:pPr indent="0" marL="0">
+            <a:pPr algn="l" indent="0" marL="0">
               <a:buNone/>
             </a:pPr>
             <a:endParaRPr lang="en-US" sz="1800" dirty="0"/>
@@ -2554,10 +2554,70 @@
       </p:grpSpPr>
       <p:sp>
         <p:nvSpPr>
-          <p:cNvPr id="2" name="Text 0"/>
+          <p:cNvPr id="2" name="Shape 0"/>
+          <p:cNvSpPr/>
+          <p:nvPr/>
+        </p:nvSpPr>
+        <p:spPr>
+          <a:xfrm>
+            <a:off x="0" y="0"/>
+            <a:ext cx="12191695" cy="128016"/>
+          </a:xfrm>
+          <a:prstGeom prst="rect">
+            <a:avLst/>
+          </a:prstGeom>
+          <a:solidFill>
+            <a:srgbClr val="0B1F3A"/>
+          </a:solidFill>
+          <a:ln/>
+        </p:spPr>
+      </p:sp>
+      <p:sp>
+        <p:nvSpPr>
+          <p:cNvPr id="3" name="Shape 1"/>
+          <p:cNvSpPr/>
+          <p:nvPr/>
+        </p:nvSpPr>
+        <p:spPr>
+          <a:xfrm>
+            <a:off x="0" y="128016"/>
+            <a:ext cx="12191695" cy="36576"/>
+          </a:xfrm>
+          <a:prstGeom prst="rect">
+            <a:avLst/>
+          </a:prstGeom>
+          <a:solidFill>
+            <a:srgbClr val="D4AF37"/>
+          </a:solidFill>
+          <a:ln/>
+        </p:spPr>
+      </p:sp>
+      <p:sp>
+        <p:nvSpPr>
+          <p:cNvPr id="4" name="Shape 2"/>
+          <p:cNvSpPr/>
+          <p:nvPr/>
+        </p:nvSpPr>
+        <p:spPr>
+          <a:xfrm>
+            <a:off x="5593385" y="1069848"/>
+            <a:ext cx="1005840" cy="45720"/>
+          </a:xfrm>
+          <a:prstGeom prst="rect">
+            <a:avLst/>
+          </a:prstGeom>
+          <a:solidFill>
+            <a:srgbClr val="D4AF37"/>
+          </a:solidFill>
+          <a:ln/>
+        </p:spPr>
+      </p:sp>
+      <p:sp>
+        <p:nvSpPr>
+          <p:cNvPr id="5" name="Text 3"/>
           <p:cNvSpPr/>
           <p:nvPr>
-            <p:ph idx="100" type="title" hasCustomPrompt="1"/>
+            <p:ph idx="103" type="title" hasCustomPrompt="1"/>
           </p:nvPr>
         </p:nvSpPr>
         <p:spPr>
@@ -2985,9 +3045,94 @@
           <a:chExt cx="0" cy="0"/>
         </a:xfrm>
       </p:grpSpPr>
-      <p:sp>
-        <p:nvSpPr>
-          <p:cNvPr id="2" name="Text 0"/>
+      <p:pic>
+        <p:nvPicPr>
+          <p:cNvPr id="2" name="img1" descr="/Users/seanbowman/Documents/MIT/Fall26/6.s974/repo/slides/assets/title_ddg.jpg">    </p:cNvPr>
+          <p:cNvPicPr>
+            <a:picLocks noChangeAspect="1"/>
+          </p:cNvPicPr>
+          <p:nvPr/>
+        </p:nvPicPr>
+        <p:blipFill>
+          <a:blip r:embed="rId1"/>
+          <a:stretch>
+            <a:fillRect/>
+          </a:stretch>
+        </p:blipFill>
+        <p:spPr>
+          <a:xfrm>
+            <a:off x="4572000" y="0"/>
+            <a:ext cx="7619695" cy="6858000"/>
+          </a:xfrm>
+          <a:prstGeom prst="rect">
+            <a:avLst/>
+          </a:prstGeom>
+        </p:spPr>
+      </p:pic>
+      <p:sp>
+        <p:nvSpPr>
+          <p:cNvPr id="3" name="gold2"/>
+          <p:cNvSpPr/>
+          <p:nvPr/>
+        </p:nvSpPr>
+        <p:spPr>
+          <a:xfrm>
+            <a:off x="731520" y="4069080"/>
+            <a:ext cx="1463040" cy="64008"/>
+          </a:xfrm>
+          <a:prstGeom prst="rect">
+            <a:avLst/>
+          </a:prstGeom>
+          <a:solidFill>
+            <a:schemeClr val="accent3"/>
+          </a:solidFill>
+          <a:ln w="12700">
+            <a:solidFill>
+              <a:schemeClr val="accent3"/>
+            </a:solidFill>
+            <a:prstDash val="solid"/>
+          </a:ln>
+        </p:spPr>
+      </p:sp>
+      <p:sp>
+        <p:nvSpPr>
+          <p:cNvPr id="4" name="t3"/>
+          <p:cNvSpPr txBox="1"/>
+          <p:nvPr/>
+        </p:nvSpPr>
+        <p:spPr>
+          <a:xfrm>
+            <a:off x="10607040" y="6510528"/>
+            <a:ext cx="1371600" cy="228600"/>
+          </a:xfrm>
+          <a:prstGeom prst="rect">
+            <a:avLst/>
+          </a:prstGeom>
+          <a:noFill/>
+          <a:ln/>
+        </p:spPr>
+        <p:txBody>
+          <a:bodyPr wrap="square" lIns="0" tIns="0" rIns="0" bIns="0" rtlCol="0" anchor="ctr"/>
+          <a:lstStyle/>
+          <a:p>
+            <a:pPr algn="r" indent="0" marL="0">
+              <a:buNone/>
+            </a:pPr>
+            <a:r>
+              <a:rPr lang="en-US" sz="900" dirty="0">
+                <a:solidFill>
+                  <a:schemeClr val="bg1"/>
+                </a:solidFill>
+              </a:rPr>
+              <a:t>U.S. Navy photo</a:t>
+            </a:r>
+            <a:endParaRPr lang="en-US" sz="900" dirty="0"/>
+          </a:p>
+        </p:txBody>
+      </p:sp>
+      <p:sp>
+        <p:nvSpPr>
+          <p:cNvPr id="5" name="Text 0"/>
           <p:cNvSpPr/>
           <p:nvPr>
             <p:ph idx="100" type="title" hasCustomPrompt="1"/>
@@ -2995,8 +3140,8 @@
         </p:nvSpPr>
         <p:spPr>
           <a:xfrm>
-            <a:off x="731520" y="2103120"/>
-            <a:ext cx="10698480" cy="1463040"/>
+            <a:off x="731520" y="1737360"/>
+            <a:ext cx="5669280" cy="2194560"/>
           </a:xfrm>
           <a:prstGeom prst="rect">
             <a:avLst/>
@@ -3008,24 +3153,24 @@
           <a:bodyPr wrap="square" rtlCol="0" anchor="b"/>
           <a:lstStyle/>
           <a:p>
-            <a:pPr indent="0" marL="0">
-              <a:buNone/>
-            </a:pPr>
-            <a:r>
-              <a:rPr lang="en-US" sz="4000" b="1" dirty="0">
+            <a:pPr algn="l" indent="0" marL="0">
+              <a:buNone/>
+            </a:pPr>
+            <a:r>
+              <a:rPr lang="en-US" sz="3800" b="1" dirty="0">
                 <a:solidFill>
                   <a:schemeClr val="bg1"/>
                 </a:solidFill>
               </a:rPr>
               <a:t>Gray-Zone Maritime Control in the First Island Chain</a:t>
             </a:r>
-            <a:endParaRPr lang="en-US" sz="4000" dirty="0"/>
-          </a:p>
-        </p:txBody>
-      </p:sp>
-      <p:sp>
-        <p:nvSpPr>
-          <p:cNvPr id="3" name="Text 0"/>
+            <a:endParaRPr lang="en-US" sz="3800" dirty="0"/>
+          </a:p>
+        </p:txBody>
+      </p:sp>
+      <p:sp>
+        <p:nvSpPr>
+          <p:cNvPr id="6" name="Text 0"/>
           <p:cNvSpPr/>
           <p:nvPr>
             <p:ph idx="101" type="body" hasCustomPrompt="1"/>
@@ -3033,8 +3178,8 @@
         </p:nvSpPr>
         <p:spPr>
           <a:xfrm>
-            <a:off x="731520" y="3703320"/>
-            <a:ext cx="10698480" cy="1463040"/>
+            <a:off x="731520" y="4343400"/>
+            <a:ext cx="5669280" cy="1280160"/>
           </a:xfrm>
           <a:prstGeom prst="rect">
             <a:avLst/>
@@ -3046,13 +3191,13 @@
           <a:bodyPr wrap="square" rtlCol="0" anchor="t"/>
           <a:lstStyle/>
           <a:p>
-            <a:pPr indent="0" marL="0">
+            <a:pPr algn="l" indent="0" marL="0">
               <a:buNone/>
             </a:pPr>
             <a:r>
               <a:rPr lang="en-US" sz="1800" dirty="0">
                 <a:solidFill>
-                  <a:schemeClr val="accent6"/>
+                  <a:schemeClr val="accent3"/>
                 </a:solidFill>
               </a:rPr>
               <a:t>A networked escalation game  |  Workshop 1</a:t>
@@ -3060,13 +3205,13 @@
             <a:endParaRPr lang="en-US" sz="1800" dirty="0"/>
           </a:p>
           <a:p>
-            <a:pPr indent="0" marL="0">
+            <a:pPr algn="l" indent="0" marL="0">
               <a:buNone/>
             </a:pPr>
             <a:r>
               <a:rPr lang="en-US" sz="1800" dirty="0">
                 <a:solidFill>
-                  <a:schemeClr val="accent6"/>
+                  <a:schemeClr val="accent3"/>
                 </a:solidFill>
               </a:rPr>
               <a:t>Sean Bowman, Tate Murphy, Matthew Newell</a:t>
@@ -3102,10 +3247,10 @@
       </p:grpSpPr>
       <p:sp>
         <p:nvSpPr>
-          <p:cNvPr id="2" name="Text 0"/>
+          <p:cNvPr id="2" name="Text 3"/>
           <p:cNvSpPr/>
           <p:nvPr>
-            <p:ph idx="100" type="title" hasCustomPrompt="1"/>
+            <p:ph idx="103" type="title" hasCustomPrompt="1"/>
           </p:nvPr>
         </p:nvSpPr>
         <p:spPr>
@@ -3156,7 +3301,7 @@
       </p:graphicFrame>
       <p:sp>
         <p:nvSpPr>
-          <p:cNvPr id="4" name="t84"/>
+          <p:cNvPr id="4" name="t87"/>
           <p:cNvSpPr txBox="1"/>
           <p:nvPr/>
         </p:nvSpPr>
@@ -3364,10 +3509,10 @@
       </p:grpSpPr>
       <p:sp>
         <p:nvSpPr>
-          <p:cNvPr id="2" name="Text 0"/>
+          <p:cNvPr id="2" name="Text 3"/>
           <p:cNvSpPr/>
           <p:nvPr>
-            <p:ph idx="100" type="title" hasCustomPrompt="1"/>
+            <p:ph idx="103" type="title" hasCustomPrompt="1"/>
           </p:nvPr>
         </p:nvSpPr>
         <p:spPr>
@@ -3402,7 +3547,7 @@
       </p:sp>
       <p:pic>
         <p:nvPicPr>
-          <p:cNvPr id="3" name="img85" descr="/Users/seanbowman/Documents/MIT/Fall26/6.s974/repo/slides/../prototype/results/figures/weather.png">    </p:cNvPr>
+          <p:cNvPr id="3" name="img88" descr="/Users/seanbowman/Documents/MIT/Fall26/6.s974/repo/slides/../prototype/results/figures/weather.png">    </p:cNvPr>
           <p:cNvPicPr>
             <a:picLocks noChangeAspect="1"/>
           </p:cNvPicPr>
@@ -3426,7 +3571,7 @@
       </p:pic>
       <p:sp>
         <p:nvSpPr>
-          <p:cNvPr id="4" name="t86"/>
+          <p:cNvPr id="4" name="t89"/>
           <p:cNvSpPr txBox="1"/>
           <p:nvPr/>
         </p:nvSpPr>
@@ -3478,7 +3623,7 @@
       </p:graphicFrame>
       <p:sp>
         <p:nvSpPr>
-          <p:cNvPr id="6" name="t88"/>
+          <p:cNvPr id="6" name="t91"/>
           <p:cNvSpPr txBox="1"/>
           <p:nvPr/>
         </p:nvSpPr>
@@ -3514,7 +3659,7 @@
       </p:sp>
       <p:sp>
         <p:nvSpPr>
-          <p:cNvPr id="7" name="tk89"/>
+          <p:cNvPr id="7" name="tk92"/>
           <p:cNvSpPr/>
           <p:nvPr/>
         </p:nvSpPr>
@@ -3541,7 +3686,7 @@
       </p:sp>
       <p:sp>
         <p:nvSpPr>
-          <p:cNvPr id="8" name="t90"/>
+          <p:cNvPr id="8" name="t93"/>
           <p:cNvSpPr txBox="1"/>
           <p:nvPr/>
         </p:nvSpPr>
@@ -3658,10 +3803,10 @@
       </p:grpSpPr>
       <p:sp>
         <p:nvSpPr>
-          <p:cNvPr id="2" name="Text 0"/>
+          <p:cNvPr id="2" name="Text 3"/>
           <p:cNvSpPr/>
           <p:nvPr>
-            <p:ph idx="100" type="title" hasCustomPrompt="1"/>
+            <p:ph idx="103" type="title" hasCustomPrompt="1"/>
           </p:nvPr>
         </p:nvSpPr>
         <p:spPr>
@@ -3696,7 +3841,7 @@
       </p:sp>
       <p:sp>
         <p:nvSpPr>
-          <p:cNvPr id="3" name="cv91"/>
+          <p:cNvPr id="3" name="cv94"/>
           <p:cNvSpPr/>
           <p:nvPr/>
         </p:nvSpPr>
@@ -3721,7 +3866,7 @@
       </p:sp>
       <p:sp>
         <p:nvSpPr>
-          <p:cNvPr id="4" name="t92"/>
+          <p:cNvPr id="4" name="t95"/>
           <p:cNvSpPr txBox="1"/>
           <p:nvPr/>
         </p:nvSpPr>
@@ -3757,7 +3902,7 @@
       </p:sp>
       <p:sp>
         <p:nvSpPr>
-          <p:cNvPr id="5" name="t93"/>
+          <p:cNvPr id="5" name="t96"/>
           <p:cNvSpPr txBox="1"/>
           <p:nvPr/>
         </p:nvSpPr>
@@ -3869,7 +4014,7 @@
       </p:sp>
       <p:sp>
         <p:nvSpPr>
-          <p:cNvPr id="6" name="cv94"/>
+          <p:cNvPr id="6" name="cv97"/>
           <p:cNvSpPr/>
           <p:nvPr/>
         </p:nvSpPr>
@@ -3894,7 +4039,7 @@
       </p:sp>
       <p:sp>
         <p:nvSpPr>
-          <p:cNvPr id="7" name="t95"/>
+          <p:cNvPr id="7" name="t98"/>
           <p:cNvSpPr txBox="1"/>
           <p:nvPr/>
         </p:nvSpPr>
@@ -3930,7 +4075,7 @@
       </p:sp>
       <p:sp>
         <p:nvSpPr>
-          <p:cNvPr id="8" name="t96"/>
+          <p:cNvPr id="8" name="t99"/>
           <p:cNvSpPr txBox="1"/>
           <p:nvPr/>
         </p:nvSpPr>
@@ -4112,10 +4257,10 @@
       </p:grpSpPr>
       <p:sp>
         <p:nvSpPr>
-          <p:cNvPr id="2" name="Text 0"/>
+          <p:cNvPr id="2" name="Text 3"/>
           <p:cNvSpPr/>
           <p:nvPr>
-            <p:ph idx="100" type="title" hasCustomPrompt="1"/>
+            <p:ph idx="103" type="title" hasCustomPrompt="1"/>
           </p:nvPr>
         </p:nvSpPr>
         <p:spPr>
@@ -4150,7 +4295,7 @@
       </p:sp>
       <p:sp>
         <p:nvSpPr>
-          <p:cNvPr id="3" name="tp97"/>
+          <p:cNvPr id="3" name="tp100"/>
           <p:cNvSpPr/>
           <p:nvPr/>
         </p:nvSpPr>
@@ -4170,7 +4315,7 @@
       </p:sp>
       <p:sp>
         <p:nvSpPr>
-          <p:cNvPr id="4" name="t98"/>
+          <p:cNvPr id="4" name="t101"/>
           <p:cNvSpPr txBox="1"/>
           <p:nvPr/>
         </p:nvSpPr>
@@ -4206,7 +4351,7 @@
       </p:sp>
       <p:sp>
         <p:nvSpPr>
-          <p:cNvPr id="5" name="t99"/>
+          <p:cNvPr id="5" name="t102"/>
           <p:cNvSpPr txBox="1"/>
           <p:nvPr/>
         </p:nvSpPr>
@@ -4242,7 +4387,7 @@
       </p:sp>
       <p:sp>
         <p:nvSpPr>
-          <p:cNvPr id="6" name="t100"/>
+          <p:cNvPr id="6" name="t103"/>
           <p:cNvSpPr txBox="1"/>
           <p:nvPr/>
         </p:nvSpPr>
@@ -4278,7 +4423,7 @@
       </p:sp>
       <p:sp>
         <p:nvSpPr>
-          <p:cNvPr id="7" name="tp101"/>
+          <p:cNvPr id="7" name="tp104"/>
           <p:cNvSpPr/>
           <p:nvPr/>
         </p:nvSpPr>
@@ -4298,7 +4443,7 @@
       </p:sp>
       <p:sp>
         <p:nvSpPr>
-          <p:cNvPr id="8" name="t102"/>
+          <p:cNvPr id="8" name="t105"/>
           <p:cNvSpPr txBox="1"/>
           <p:nvPr/>
         </p:nvSpPr>
@@ -4334,7 +4479,7 @@
       </p:sp>
       <p:sp>
         <p:nvSpPr>
-          <p:cNvPr id="9" name="t103"/>
+          <p:cNvPr id="9" name="t106"/>
           <p:cNvSpPr txBox="1"/>
           <p:nvPr/>
         </p:nvSpPr>
@@ -4370,7 +4515,7 @@
       </p:sp>
       <p:sp>
         <p:nvSpPr>
-          <p:cNvPr id="10" name="t104"/>
+          <p:cNvPr id="10" name="t107"/>
           <p:cNvSpPr txBox="1"/>
           <p:nvPr/>
         </p:nvSpPr>
@@ -4406,7 +4551,7 @@
       </p:sp>
       <p:sp>
         <p:nvSpPr>
-          <p:cNvPr id="11" name="tp105"/>
+          <p:cNvPr id="11" name="tp108"/>
           <p:cNvSpPr/>
           <p:nvPr/>
         </p:nvSpPr>
@@ -4426,7 +4571,7 @@
       </p:sp>
       <p:sp>
         <p:nvSpPr>
-          <p:cNvPr id="12" name="t106"/>
+          <p:cNvPr id="12" name="t109"/>
           <p:cNvSpPr txBox="1"/>
           <p:nvPr/>
         </p:nvSpPr>
@@ -4462,7 +4607,7 @@
       </p:sp>
       <p:sp>
         <p:nvSpPr>
-          <p:cNvPr id="13" name="t107"/>
+          <p:cNvPr id="13" name="t110"/>
           <p:cNvSpPr txBox="1"/>
           <p:nvPr/>
         </p:nvSpPr>
@@ -4498,7 +4643,7 @@
       </p:sp>
       <p:sp>
         <p:nvSpPr>
-          <p:cNvPr id="14" name="t108"/>
+          <p:cNvPr id="14" name="t111"/>
           <p:cNvSpPr txBox="1"/>
           <p:nvPr/>
         </p:nvSpPr>
@@ -4534,7 +4679,7 @@
       </p:sp>
       <p:sp>
         <p:nvSpPr>
-          <p:cNvPr id="15" name="tp109"/>
+          <p:cNvPr id="15" name="tp112"/>
           <p:cNvSpPr/>
           <p:nvPr/>
         </p:nvSpPr>
@@ -4554,7 +4699,7 @@
       </p:sp>
       <p:sp>
         <p:nvSpPr>
-          <p:cNvPr id="16" name="t110"/>
+          <p:cNvPr id="16" name="t113"/>
           <p:cNvSpPr txBox="1"/>
           <p:nvPr/>
         </p:nvSpPr>
@@ -4590,7 +4735,7 @@
       </p:sp>
       <p:sp>
         <p:nvSpPr>
-          <p:cNvPr id="17" name="t111"/>
+          <p:cNvPr id="17" name="t114"/>
           <p:cNvSpPr txBox="1"/>
           <p:nvPr/>
         </p:nvSpPr>
@@ -4626,7 +4771,7 @@
       </p:sp>
       <p:sp>
         <p:nvSpPr>
-          <p:cNvPr id="18" name="t112"/>
+          <p:cNvPr id="18" name="t115"/>
           <p:cNvSpPr txBox="1"/>
           <p:nvPr/>
         </p:nvSpPr>
@@ -4662,7 +4807,7 @@
       </p:sp>
       <p:sp>
         <p:nvSpPr>
-          <p:cNvPr id="19" name="tk113"/>
+          <p:cNvPr id="19" name="tk116"/>
           <p:cNvSpPr/>
           <p:nvPr/>
         </p:nvSpPr>
@@ -4689,7 +4834,7 @@
       </p:sp>
       <p:sp>
         <p:nvSpPr>
-          <p:cNvPr id="20" name="t114"/>
+          <p:cNvPr id="20" name="t117"/>
           <p:cNvSpPr txBox="1"/>
           <p:nvPr/>
         </p:nvSpPr>
@@ -4806,10 +4951,10 @@
       </p:grpSpPr>
       <p:sp>
         <p:nvSpPr>
-          <p:cNvPr id="2" name="Text 0"/>
+          <p:cNvPr id="2" name="Text 3"/>
           <p:cNvSpPr/>
           <p:nvPr>
-            <p:ph idx="100" type="title" hasCustomPrompt="1"/>
+            <p:ph idx="103" type="title" hasCustomPrompt="1"/>
           </p:nvPr>
         </p:nvSpPr>
         <p:spPr>
@@ -4844,7 +4989,7 @@
       </p:sp>
       <p:sp>
         <p:nvSpPr>
-          <p:cNvPr id="3" name="wb1"/>
+          <p:cNvPr id="3" name="wb4"/>
           <p:cNvSpPr/>
           <p:nvPr/>
         </p:nvSpPr>
@@ -4869,7 +5014,7 @@
       </p:sp>
       <p:sp>
         <p:nvSpPr>
-          <p:cNvPr id="4" name="t2"/>
+          <p:cNvPr id="4" name="t5"/>
           <p:cNvSpPr txBox="1"/>
           <p:nvPr/>
         </p:nvSpPr>
@@ -4905,7 +5050,7 @@
       </p:sp>
       <p:sp>
         <p:nvSpPr>
-          <p:cNvPr id="5" name="t3"/>
+          <p:cNvPr id="5" name="t6"/>
           <p:cNvSpPr txBox="1"/>
           <p:nvPr/>
         </p:nvSpPr>
@@ -4941,7 +5086,7 @@
       </p:sp>
       <p:sp>
         <p:nvSpPr>
-          <p:cNvPr id="6" name="wb4"/>
+          <p:cNvPr id="6" name="wb7"/>
           <p:cNvSpPr/>
           <p:nvPr/>
         </p:nvSpPr>
@@ -4966,7 +5111,7 @@
       </p:sp>
       <p:sp>
         <p:nvSpPr>
-          <p:cNvPr id="7" name="t5"/>
+          <p:cNvPr id="7" name="t8"/>
           <p:cNvSpPr txBox="1"/>
           <p:nvPr/>
         </p:nvSpPr>
@@ -5002,7 +5147,7 @@
       </p:sp>
       <p:sp>
         <p:nvSpPr>
-          <p:cNvPr id="8" name="t6"/>
+          <p:cNvPr id="8" name="t9"/>
           <p:cNvSpPr txBox="1"/>
           <p:nvPr/>
         </p:nvSpPr>
@@ -5038,7 +5183,7 @@
       </p:sp>
       <p:sp>
         <p:nvSpPr>
-          <p:cNvPr id="9" name="wb7"/>
+          <p:cNvPr id="9" name="wb10"/>
           <p:cNvSpPr/>
           <p:nvPr/>
         </p:nvSpPr>
@@ -5063,7 +5208,7 @@
       </p:sp>
       <p:sp>
         <p:nvSpPr>
-          <p:cNvPr id="10" name="t8"/>
+          <p:cNvPr id="10" name="t11"/>
           <p:cNvSpPr txBox="1"/>
           <p:nvPr/>
         </p:nvSpPr>
@@ -5099,7 +5244,7 @@
       </p:sp>
       <p:sp>
         <p:nvSpPr>
-          <p:cNvPr id="11" name="t9"/>
+          <p:cNvPr id="11" name="t12"/>
           <p:cNvSpPr txBox="1"/>
           <p:nvPr/>
         </p:nvSpPr>
@@ -5135,7 +5280,7 @@
       </p:sp>
       <p:sp>
         <p:nvSpPr>
-          <p:cNvPr id="12" name="wb10"/>
+          <p:cNvPr id="12" name="wb13"/>
           <p:cNvSpPr/>
           <p:nvPr/>
         </p:nvSpPr>
@@ -5160,7 +5305,7 @@
       </p:sp>
       <p:sp>
         <p:nvSpPr>
-          <p:cNvPr id="13" name="t11"/>
+          <p:cNvPr id="13" name="t14"/>
           <p:cNvSpPr txBox="1"/>
           <p:nvPr/>
         </p:nvSpPr>
@@ -5196,7 +5341,7 @@
       </p:sp>
       <p:sp>
         <p:nvSpPr>
-          <p:cNvPr id="14" name="t12"/>
+          <p:cNvPr id="14" name="t15"/>
           <p:cNvSpPr txBox="1"/>
           <p:nvPr/>
         </p:nvSpPr>
@@ -5232,7 +5377,7 @@
       </p:sp>
       <p:sp>
         <p:nvSpPr>
-          <p:cNvPr id="15" name="tk13"/>
+          <p:cNvPr id="15" name="tk16"/>
           <p:cNvSpPr/>
           <p:nvPr/>
         </p:nvSpPr>
@@ -5259,7 +5404,7 @@
       </p:sp>
       <p:sp>
         <p:nvSpPr>
-          <p:cNvPr id="16" name="t14"/>
+          <p:cNvPr id="16" name="t17"/>
           <p:cNvSpPr txBox="1"/>
           <p:nvPr/>
         </p:nvSpPr>
@@ -5376,10 +5521,10 @@
       </p:grpSpPr>
       <p:sp>
         <p:nvSpPr>
-          <p:cNvPr id="2" name="Text 0"/>
+          <p:cNvPr id="2" name="Text 3"/>
           <p:cNvSpPr/>
           <p:nvPr>
-            <p:ph idx="100" type="title" hasCustomPrompt="1"/>
+            <p:ph idx="103" type="title" hasCustomPrompt="1"/>
           </p:nvPr>
         </p:nvSpPr>
         <p:spPr>
@@ -5414,7 +5559,7 @@
       </p:sp>
       <p:pic>
         <p:nvPicPr>
-          <p:cNvPr id="3" name="img15" descr="/Users/seanbowman/Documents/MIT/Fall26/6.s974/repo/slides/../prototype/results/figures/network.png">    </p:cNvPr>
+          <p:cNvPr id="3" name="img18" descr="/Users/seanbowman/Documents/MIT/Fall26/6.s974/repo/slides/../prototype/results/figures/network.png">    </p:cNvPr>
           <p:cNvPicPr>
             <a:picLocks noChangeAspect="1"/>
           </p:cNvPicPr>
@@ -5438,7 +5583,7 @@
       </p:pic>
       <p:sp>
         <p:nvSpPr>
-          <p:cNvPr id="4" name="t16"/>
+          <p:cNvPr id="4" name="t19"/>
           <p:cNvSpPr txBox="1"/>
           <p:nvPr/>
         </p:nvSpPr>
@@ -5474,7 +5619,7 @@
       </p:sp>
       <p:sp>
         <p:nvSpPr>
-          <p:cNvPr id="5" name="t17"/>
+          <p:cNvPr id="5" name="t20"/>
           <p:cNvSpPr txBox="1"/>
           <p:nvPr/>
         </p:nvSpPr>
@@ -5711,10 +5856,10 @@
       </p:grpSpPr>
       <p:sp>
         <p:nvSpPr>
-          <p:cNvPr id="2" name="Text 0"/>
+          <p:cNvPr id="2" name="Text 3"/>
           <p:cNvSpPr/>
           <p:nvPr>
-            <p:ph idx="100" type="title" hasCustomPrompt="1"/>
+            <p:ph idx="103" type="title" hasCustomPrompt="1"/>
           </p:nvPr>
         </p:nvSpPr>
         <p:spPr>
@@ -5749,7 +5894,7 @@
       </p:sp>
       <p:sp>
         <p:nvSpPr>
-          <p:cNvPr id="3" name="c18"/>
+          <p:cNvPr id="3" name="c21"/>
           <p:cNvSpPr/>
           <p:nvPr/>
         </p:nvSpPr>
@@ -5769,7 +5914,7 @@
       </p:sp>
       <p:sp>
         <p:nvSpPr>
-          <p:cNvPr id="4" name="t19"/>
+          <p:cNvPr id="4" name="t22"/>
           <p:cNvSpPr txBox="1"/>
           <p:nvPr/>
         </p:nvSpPr>
@@ -5805,7 +5950,7 @@
       </p:sp>
       <p:sp>
         <p:nvSpPr>
-          <p:cNvPr id="5" name="t20"/>
+          <p:cNvPr id="5" name="t23"/>
           <p:cNvSpPr txBox="1"/>
           <p:nvPr/>
         </p:nvSpPr>
@@ -5855,7 +6000,7 @@
       </p:sp>
       <p:sp>
         <p:nvSpPr>
-          <p:cNvPr id="6" name="c21"/>
+          <p:cNvPr id="6" name="c24"/>
           <p:cNvSpPr/>
           <p:nvPr/>
         </p:nvSpPr>
@@ -5875,7 +6020,7 @@
       </p:sp>
       <p:sp>
         <p:nvSpPr>
-          <p:cNvPr id="7" name="t22"/>
+          <p:cNvPr id="7" name="t25"/>
           <p:cNvSpPr txBox="1"/>
           <p:nvPr/>
         </p:nvSpPr>
@@ -5911,7 +6056,7 @@
       </p:sp>
       <p:sp>
         <p:nvSpPr>
-          <p:cNvPr id="8" name="t23"/>
+          <p:cNvPr id="8" name="t26"/>
           <p:cNvSpPr txBox="1"/>
           <p:nvPr/>
         </p:nvSpPr>
@@ -5961,7 +6106,7 @@
       </p:sp>
       <p:sp>
         <p:nvSpPr>
-          <p:cNvPr id="9" name="c24"/>
+          <p:cNvPr id="9" name="c27"/>
           <p:cNvSpPr/>
           <p:nvPr/>
         </p:nvSpPr>
@@ -5981,7 +6126,7 @@
       </p:sp>
       <p:sp>
         <p:nvSpPr>
-          <p:cNvPr id="10" name="t25"/>
+          <p:cNvPr id="10" name="t28"/>
           <p:cNvSpPr txBox="1"/>
           <p:nvPr/>
         </p:nvSpPr>
@@ -6017,7 +6162,7 @@
       </p:sp>
       <p:sp>
         <p:nvSpPr>
-          <p:cNvPr id="11" name="t26"/>
+          <p:cNvPr id="11" name="t29"/>
           <p:cNvSpPr txBox="1"/>
           <p:nvPr/>
         </p:nvSpPr>
@@ -6114,7 +6259,7 @@
                   <a:tcPr marL="91440" marR="91440" marT="45720" marB="45720" anchor="ctr">
                     <a:lnL w="6350" cap="flat" cmpd="sng" algn="ctr">
                       <a:solidFill>
-                        <a:srgbClr val="8DA9C4"/>
+                        <a:srgbClr val="A9B8CC"/>
                       </a:solidFill>
                       <a:prstDash val="solid"/>
                       <a:round/>
@@ -6123,7 +6268,7 @@
                     </a:lnL>
                     <a:lnR w="6350" cap="flat" cmpd="sng" algn="ctr">
                       <a:solidFill>
-                        <a:srgbClr val="8DA9C4"/>
+                        <a:srgbClr val="A9B8CC"/>
                       </a:solidFill>
                       <a:prstDash val="solid"/>
                       <a:round/>
@@ -6132,7 +6277,7 @@
                     </a:lnR>
                     <a:lnT w="6350" cap="flat" cmpd="sng" algn="ctr">
                       <a:solidFill>
-                        <a:srgbClr val="8DA9C4"/>
+                        <a:srgbClr val="A9B8CC"/>
                       </a:solidFill>
                       <a:prstDash val="solid"/>
                       <a:round/>
@@ -6141,7 +6286,7 @@
                     </a:lnT>
                     <a:lnB w="6350" cap="flat" cmpd="sng" algn="ctr">
                       <a:solidFill>
-                        <a:srgbClr val="8DA9C4"/>
+                        <a:srgbClr val="A9B8CC"/>
                       </a:solidFill>
                       <a:prstDash val="solid"/>
                       <a:round/>
@@ -6175,7 +6320,7 @@
                   <a:tcPr marL="91440" marR="91440" marT="45720" marB="45720" anchor="ctr">
                     <a:lnL w="6350" cap="flat" cmpd="sng" algn="ctr">
                       <a:solidFill>
-                        <a:srgbClr val="8DA9C4"/>
+                        <a:srgbClr val="A9B8CC"/>
                       </a:solidFill>
                       <a:prstDash val="solid"/>
                       <a:round/>
@@ -6184,7 +6329,7 @@
                     </a:lnL>
                     <a:lnR w="6350" cap="flat" cmpd="sng" algn="ctr">
                       <a:solidFill>
-                        <a:srgbClr val="8DA9C4"/>
+                        <a:srgbClr val="A9B8CC"/>
                       </a:solidFill>
                       <a:prstDash val="solid"/>
                       <a:round/>
@@ -6193,7 +6338,7 @@
                     </a:lnR>
                     <a:lnT w="6350" cap="flat" cmpd="sng" algn="ctr">
                       <a:solidFill>
-                        <a:srgbClr val="8DA9C4"/>
+                        <a:srgbClr val="A9B8CC"/>
                       </a:solidFill>
                       <a:prstDash val="solid"/>
                       <a:round/>
@@ -6202,7 +6347,7 @@
                     </a:lnT>
                     <a:lnB w="6350" cap="flat" cmpd="sng" algn="ctr">
                       <a:solidFill>
-                        <a:srgbClr val="8DA9C4"/>
+                        <a:srgbClr val="A9B8CC"/>
                       </a:solidFill>
                       <a:prstDash val="solid"/>
                       <a:round/>
@@ -6238,7 +6383,7 @@
                   <a:tcPr marL="91440" marR="91440" marT="45720" marB="45720" anchor="ctr">
                     <a:lnL w="6350" cap="flat" cmpd="sng" algn="ctr">
                       <a:solidFill>
-                        <a:srgbClr val="8DA9C4"/>
+                        <a:srgbClr val="A9B8CC"/>
                       </a:solidFill>
                       <a:prstDash val="solid"/>
                       <a:round/>
@@ -6247,7 +6392,7 @@
                     </a:lnL>
                     <a:lnR w="6350" cap="flat" cmpd="sng" algn="ctr">
                       <a:solidFill>
-                        <a:srgbClr val="8DA9C4"/>
+                        <a:srgbClr val="A9B8CC"/>
                       </a:solidFill>
                       <a:prstDash val="solid"/>
                       <a:round/>
@@ -6256,7 +6401,7 @@
                     </a:lnR>
                     <a:lnT w="6350" cap="flat" cmpd="sng" algn="ctr">
                       <a:solidFill>
-                        <a:srgbClr val="8DA9C4"/>
+                        <a:srgbClr val="A9B8CC"/>
                       </a:solidFill>
                       <a:prstDash val="solid"/>
                       <a:round/>
@@ -6265,7 +6410,7 @@
                     </a:lnT>
                     <a:lnB w="6350" cap="flat" cmpd="sng" algn="ctr">
                       <a:solidFill>
-                        <a:srgbClr val="8DA9C4"/>
+                        <a:srgbClr val="A9B8CC"/>
                       </a:solidFill>
                       <a:prstDash val="solid"/>
                       <a:round/>
@@ -6296,7 +6441,7 @@
                   <a:tcPr marL="91440" marR="91440" marT="45720" marB="45720" anchor="ctr">
                     <a:lnL w="6350" cap="flat" cmpd="sng" algn="ctr">
                       <a:solidFill>
-                        <a:srgbClr val="8DA9C4"/>
+                        <a:srgbClr val="A9B8CC"/>
                       </a:solidFill>
                       <a:prstDash val="solid"/>
                       <a:round/>
@@ -6305,7 +6450,7 @@
                     </a:lnL>
                     <a:lnR w="6350" cap="flat" cmpd="sng" algn="ctr">
                       <a:solidFill>
-                        <a:srgbClr val="8DA9C4"/>
+                        <a:srgbClr val="A9B8CC"/>
                       </a:solidFill>
                       <a:prstDash val="solid"/>
                       <a:round/>
@@ -6314,7 +6459,7 @@
                     </a:lnR>
                     <a:lnT w="6350" cap="flat" cmpd="sng" algn="ctr">
                       <a:solidFill>
-                        <a:srgbClr val="8DA9C4"/>
+                        <a:srgbClr val="A9B8CC"/>
                       </a:solidFill>
                       <a:prstDash val="solid"/>
                       <a:round/>
@@ -6323,7 +6468,7 @@
                     </a:lnT>
                     <a:lnB w="6350" cap="flat" cmpd="sng" algn="ctr">
                       <a:solidFill>
-                        <a:srgbClr val="8DA9C4"/>
+                        <a:srgbClr val="A9B8CC"/>
                       </a:solidFill>
                       <a:prstDash val="solid"/>
                       <a:round/>
@@ -6356,7 +6501,7 @@
                   <a:tcPr marL="91440" marR="91440" marT="45720" marB="45720" anchor="ctr">
                     <a:lnL w="6350" cap="flat" cmpd="sng" algn="ctr">
                       <a:solidFill>
-                        <a:srgbClr val="8DA9C4"/>
+                        <a:srgbClr val="A9B8CC"/>
                       </a:solidFill>
                       <a:prstDash val="solid"/>
                       <a:round/>
@@ -6365,7 +6510,7 @@
                     </a:lnL>
                     <a:lnR w="6350" cap="flat" cmpd="sng" algn="ctr">
                       <a:solidFill>
-                        <a:srgbClr val="8DA9C4"/>
+                        <a:srgbClr val="A9B8CC"/>
                       </a:solidFill>
                       <a:prstDash val="solid"/>
                       <a:round/>
@@ -6374,7 +6519,7 @@
                     </a:lnR>
                     <a:lnT w="6350" cap="flat" cmpd="sng" algn="ctr">
                       <a:solidFill>
-                        <a:srgbClr val="8DA9C4"/>
+                        <a:srgbClr val="A9B8CC"/>
                       </a:solidFill>
                       <a:prstDash val="solid"/>
                       <a:round/>
@@ -6383,7 +6528,7 @@
                     </a:lnT>
                     <a:lnB w="6350" cap="flat" cmpd="sng" algn="ctr">
                       <a:solidFill>
-                        <a:srgbClr val="8DA9C4"/>
+                        <a:srgbClr val="A9B8CC"/>
                       </a:solidFill>
                       <a:prstDash val="solid"/>
                       <a:round/>
@@ -6414,7 +6559,7 @@
                   <a:tcPr marL="91440" marR="91440" marT="45720" marB="45720" anchor="ctr">
                     <a:lnL w="6350" cap="flat" cmpd="sng" algn="ctr">
                       <a:solidFill>
-                        <a:srgbClr val="8DA9C4"/>
+                        <a:srgbClr val="A9B8CC"/>
                       </a:solidFill>
                       <a:prstDash val="solid"/>
                       <a:round/>
@@ -6423,7 +6568,7 @@
                     </a:lnL>
                     <a:lnR w="6350" cap="flat" cmpd="sng" algn="ctr">
                       <a:solidFill>
-                        <a:srgbClr val="8DA9C4"/>
+                        <a:srgbClr val="A9B8CC"/>
                       </a:solidFill>
                       <a:prstDash val="solid"/>
                       <a:round/>
@@ -6432,7 +6577,7 @@
                     </a:lnR>
                     <a:lnT w="6350" cap="flat" cmpd="sng" algn="ctr">
                       <a:solidFill>
-                        <a:srgbClr val="8DA9C4"/>
+                        <a:srgbClr val="A9B8CC"/>
                       </a:solidFill>
                       <a:prstDash val="solid"/>
                       <a:round/>
@@ -6441,7 +6586,7 @@
                     </a:lnT>
                     <a:lnB w="6350" cap="flat" cmpd="sng" algn="ctr">
                       <a:solidFill>
-                        <a:srgbClr val="8DA9C4"/>
+                        <a:srgbClr val="A9B8CC"/>
                       </a:solidFill>
                       <a:prstDash val="solid"/>
                       <a:round/>
@@ -6474,7 +6619,7 @@
                   <a:tcPr marL="91440" marR="91440" marT="45720" marB="45720" anchor="ctr">
                     <a:lnL w="6350" cap="flat" cmpd="sng" algn="ctr">
                       <a:solidFill>
-                        <a:srgbClr val="8DA9C4"/>
+                        <a:srgbClr val="A9B8CC"/>
                       </a:solidFill>
                       <a:prstDash val="solid"/>
                       <a:round/>
@@ -6483,7 +6628,7 @@
                     </a:lnL>
                     <a:lnR w="6350" cap="flat" cmpd="sng" algn="ctr">
                       <a:solidFill>
-                        <a:srgbClr val="8DA9C4"/>
+                        <a:srgbClr val="A9B8CC"/>
                       </a:solidFill>
                       <a:prstDash val="solid"/>
                       <a:round/>
@@ -6492,7 +6637,7 @@
                     </a:lnR>
                     <a:lnT w="6350" cap="flat" cmpd="sng" algn="ctr">
                       <a:solidFill>
-                        <a:srgbClr val="8DA9C4"/>
+                        <a:srgbClr val="A9B8CC"/>
                       </a:solidFill>
                       <a:prstDash val="solid"/>
                       <a:round/>
@@ -6501,7 +6646,7 @@
                     </a:lnT>
                     <a:lnB w="6350" cap="flat" cmpd="sng" algn="ctr">
                       <a:solidFill>
-                        <a:srgbClr val="8DA9C4"/>
+                        <a:srgbClr val="A9B8CC"/>
                       </a:solidFill>
                       <a:prstDash val="solid"/>
                       <a:round/>
@@ -6532,7 +6677,7 @@
                   <a:tcPr marL="91440" marR="91440" marT="45720" marB="45720" anchor="ctr">
                     <a:lnL w="6350" cap="flat" cmpd="sng" algn="ctr">
                       <a:solidFill>
-                        <a:srgbClr val="8DA9C4"/>
+                        <a:srgbClr val="A9B8CC"/>
                       </a:solidFill>
                       <a:prstDash val="solid"/>
                       <a:round/>
@@ -6541,7 +6686,7 @@
                     </a:lnL>
                     <a:lnR w="6350" cap="flat" cmpd="sng" algn="ctr">
                       <a:solidFill>
-                        <a:srgbClr val="8DA9C4"/>
+                        <a:srgbClr val="A9B8CC"/>
                       </a:solidFill>
                       <a:prstDash val="solid"/>
                       <a:round/>
@@ -6550,7 +6695,7 @@
                     </a:lnR>
                     <a:lnT w="6350" cap="flat" cmpd="sng" algn="ctr">
                       <a:solidFill>
-                        <a:srgbClr val="8DA9C4"/>
+                        <a:srgbClr val="A9B8CC"/>
                       </a:solidFill>
                       <a:prstDash val="solid"/>
                       <a:round/>
@@ -6559,7 +6704,7 @@
                     </a:lnT>
                     <a:lnB w="6350" cap="flat" cmpd="sng" algn="ctr">
                       <a:solidFill>
-                        <a:srgbClr val="8DA9C4"/>
+                        <a:srgbClr val="A9B8CC"/>
                       </a:solidFill>
                       <a:prstDash val="solid"/>
                       <a:round/>
@@ -6592,7 +6737,7 @@
                   <a:tcPr marL="91440" marR="91440" marT="45720" marB="45720" anchor="ctr">
                     <a:lnL w="6350" cap="flat" cmpd="sng" algn="ctr">
                       <a:solidFill>
-                        <a:srgbClr val="8DA9C4"/>
+                        <a:srgbClr val="A9B8CC"/>
                       </a:solidFill>
                       <a:prstDash val="solid"/>
                       <a:round/>
@@ -6601,7 +6746,7 @@
                     </a:lnL>
                     <a:lnR w="6350" cap="flat" cmpd="sng" algn="ctr">
                       <a:solidFill>
-                        <a:srgbClr val="8DA9C4"/>
+                        <a:srgbClr val="A9B8CC"/>
                       </a:solidFill>
                       <a:prstDash val="solid"/>
                       <a:round/>
@@ -6610,7 +6755,7 @@
                     </a:lnR>
                     <a:lnT w="6350" cap="flat" cmpd="sng" algn="ctr">
                       <a:solidFill>
-                        <a:srgbClr val="8DA9C4"/>
+                        <a:srgbClr val="A9B8CC"/>
                       </a:solidFill>
                       <a:prstDash val="solid"/>
                       <a:round/>
@@ -6619,7 +6764,7 @@
                     </a:lnT>
                     <a:lnB w="6350" cap="flat" cmpd="sng" algn="ctr">
                       <a:solidFill>
-                        <a:srgbClr val="8DA9C4"/>
+                        <a:srgbClr val="A9B8CC"/>
                       </a:solidFill>
                       <a:prstDash val="solid"/>
                       <a:round/>
@@ -6650,7 +6795,7 @@
                   <a:tcPr marL="91440" marR="91440" marT="45720" marB="45720" anchor="ctr">
                     <a:lnL w="6350" cap="flat" cmpd="sng" algn="ctr">
                       <a:solidFill>
-                        <a:srgbClr val="8DA9C4"/>
+                        <a:srgbClr val="A9B8CC"/>
                       </a:solidFill>
                       <a:prstDash val="solid"/>
                       <a:round/>
@@ -6659,7 +6804,7 @@
                     </a:lnL>
                     <a:lnR w="6350" cap="flat" cmpd="sng" algn="ctr">
                       <a:solidFill>
-                        <a:srgbClr val="8DA9C4"/>
+                        <a:srgbClr val="A9B8CC"/>
                       </a:solidFill>
                       <a:prstDash val="solid"/>
                       <a:round/>
@@ -6668,7 +6813,7 @@
                     </a:lnR>
                     <a:lnT w="6350" cap="flat" cmpd="sng" algn="ctr">
                       <a:solidFill>
-                        <a:srgbClr val="8DA9C4"/>
+                        <a:srgbClr val="A9B8CC"/>
                       </a:solidFill>
                       <a:prstDash val="solid"/>
                       <a:round/>
@@ -6677,7 +6822,7 @@
                     </a:lnT>
                     <a:lnB w="6350" cap="flat" cmpd="sng" algn="ctr">
                       <a:solidFill>
-                        <a:srgbClr val="8DA9C4"/>
+                        <a:srgbClr val="A9B8CC"/>
                       </a:solidFill>
                       <a:prstDash val="solid"/>
                       <a:round/>
@@ -6710,7 +6855,7 @@
                   <a:tcPr marL="91440" marR="91440" marT="45720" marB="45720" anchor="ctr">
                     <a:lnL w="6350" cap="flat" cmpd="sng" algn="ctr">
                       <a:solidFill>
-                        <a:srgbClr val="8DA9C4"/>
+                        <a:srgbClr val="A9B8CC"/>
                       </a:solidFill>
                       <a:prstDash val="solid"/>
                       <a:round/>
@@ -6719,7 +6864,7 @@
                     </a:lnL>
                     <a:lnR w="6350" cap="flat" cmpd="sng" algn="ctr">
                       <a:solidFill>
-                        <a:srgbClr val="8DA9C4"/>
+                        <a:srgbClr val="A9B8CC"/>
                       </a:solidFill>
                       <a:prstDash val="solid"/>
                       <a:round/>
@@ -6728,7 +6873,7 @@
                     </a:lnR>
                     <a:lnT w="6350" cap="flat" cmpd="sng" algn="ctr">
                       <a:solidFill>
-                        <a:srgbClr val="8DA9C4"/>
+                        <a:srgbClr val="A9B8CC"/>
                       </a:solidFill>
                       <a:prstDash val="solid"/>
                       <a:round/>
@@ -6737,7 +6882,7 @@
                     </a:lnT>
                     <a:lnB w="6350" cap="flat" cmpd="sng" algn="ctr">
                       <a:solidFill>
-                        <a:srgbClr val="8DA9C4"/>
+                        <a:srgbClr val="A9B8CC"/>
                       </a:solidFill>
                       <a:prstDash val="solid"/>
                       <a:round/>
@@ -6768,7 +6913,7 @@
                   <a:tcPr marL="91440" marR="91440" marT="45720" marB="45720" anchor="ctr">
                     <a:lnL w="6350" cap="flat" cmpd="sng" algn="ctr">
                       <a:solidFill>
-                        <a:srgbClr val="8DA9C4"/>
+                        <a:srgbClr val="A9B8CC"/>
                       </a:solidFill>
                       <a:prstDash val="solid"/>
                       <a:round/>
@@ -6777,7 +6922,7 @@
                     </a:lnL>
                     <a:lnR w="6350" cap="flat" cmpd="sng" algn="ctr">
                       <a:solidFill>
-                        <a:srgbClr val="8DA9C4"/>
+                        <a:srgbClr val="A9B8CC"/>
                       </a:solidFill>
                       <a:prstDash val="solid"/>
                       <a:round/>
@@ -6786,7 +6931,7 @@
                     </a:lnR>
                     <a:lnT w="6350" cap="flat" cmpd="sng" algn="ctr">
                       <a:solidFill>
-                        <a:srgbClr val="8DA9C4"/>
+                        <a:srgbClr val="A9B8CC"/>
                       </a:solidFill>
                       <a:prstDash val="solid"/>
                       <a:round/>
@@ -6795,7 +6940,7 @@
                     </a:lnT>
                     <a:lnB w="6350" cap="flat" cmpd="sng" algn="ctr">
                       <a:solidFill>
-                        <a:srgbClr val="8DA9C4"/>
+                        <a:srgbClr val="A9B8CC"/>
                       </a:solidFill>
                       <a:prstDash val="solid"/>
                       <a:round/>
@@ -6828,7 +6973,7 @@
                   <a:tcPr marL="91440" marR="91440" marT="45720" marB="45720" anchor="ctr">
                     <a:lnL w="6350" cap="flat" cmpd="sng" algn="ctr">
                       <a:solidFill>
-                        <a:srgbClr val="8DA9C4"/>
+                        <a:srgbClr val="A9B8CC"/>
                       </a:solidFill>
                       <a:prstDash val="solid"/>
                       <a:round/>
@@ -6837,7 +6982,7 @@
                     </a:lnL>
                     <a:lnR w="6350" cap="flat" cmpd="sng" algn="ctr">
                       <a:solidFill>
-                        <a:srgbClr val="8DA9C4"/>
+                        <a:srgbClr val="A9B8CC"/>
                       </a:solidFill>
                       <a:prstDash val="solid"/>
                       <a:round/>
@@ -6846,7 +6991,7 @@
                     </a:lnR>
                     <a:lnT w="6350" cap="flat" cmpd="sng" algn="ctr">
                       <a:solidFill>
-                        <a:srgbClr val="8DA9C4"/>
+                        <a:srgbClr val="A9B8CC"/>
                       </a:solidFill>
                       <a:prstDash val="solid"/>
                       <a:round/>
@@ -6855,7 +7000,7 @@
                     </a:lnT>
                     <a:lnB w="6350" cap="flat" cmpd="sng" algn="ctr">
                       <a:solidFill>
-                        <a:srgbClr val="8DA9C4"/>
+                        <a:srgbClr val="A9B8CC"/>
                       </a:solidFill>
                       <a:prstDash val="solid"/>
                       <a:round/>
@@ -6886,7 +7031,7 @@
                   <a:tcPr marL="91440" marR="91440" marT="45720" marB="45720" anchor="ctr">
                     <a:lnL w="6350" cap="flat" cmpd="sng" algn="ctr">
                       <a:solidFill>
-                        <a:srgbClr val="8DA9C4"/>
+                        <a:srgbClr val="A9B8CC"/>
                       </a:solidFill>
                       <a:prstDash val="solid"/>
                       <a:round/>
@@ -6895,7 +7040,7 @@
                     </a:lnL>
                     <a:lnR w="6350" cap="flat" cmpd="sng" algn="ctr">
                       <a:solidFill>
-                        <a:srgbClr val="8DA9C4"/>
+                        <a:srgbClr val="A9B8CC"/>
                       </a:solidFill>
                       <a:prstDash val="solid"/>
                       <a:round/>
@@ -6904,7 +7049,7 @@
                     </a:lnR>
                     <a:lnT w="6350" cap="flat" cmpd="sng" algn="ctr">
                       <a:solidFill>
-                        <a:srgbClr val="8DA9C4"/>
+                        <a:srgbClr val="A9B8CC"/>
                       </a:solidFill>
                       <a:prstDash val="solid"/>
                       <a:round/>
@@ -6913,7 +7058,7 @@
                     </a:lnT>
                     <a:lnB w="6350" cap="flat" cmpd="sng" algn="ctr">
                       <a:solidFill>
-                        <a:srgbClr val="8DA9C4"/>
+                        <a:srgbClr val="A9B8CC"/>
                       </a:solidFill>
                       <a:prstDash val="solid"/>
                       <a:round/>
@@ -6946,7 +7091,7 @@
                   <a:tcPr marL="91440" marR="91440" marT="45720" marB="45720" anchor="ctr">
                     <a:lnL w="6350" cap="flat" cmpd="sng" algn="ctr">
                       <a:solidFill>
-                        <a:srgbClr val="8DA9C4"/>
+                        <a:srgbClr val="A9B8CC"/>
                       </a:solidFill>
                       <a:prstDash val="solid"/>
                       <a:round/>
@@ -6955,7 +7100,7 @@
                     </a:lnL>
                     <a:lnR w="6350" cap="flat" cmpd="sng" algn="ctr">
                       <a:solidFill>
-                        <a:srgbClr val="8DA9C4"/>
+                        <a:srgbClr val="A9B8CC"/>
                       </a:solidFill>
                       <a:prstDash val="solid"/>
                       <a:round/>
@@ -6964,7 +7109,7 @@
                     </a:lnR>
                     <a:lnT w="6350" cap="flat" cmpd="sng" algn="ctr">
                       <a:solidFill>
-                        <a:srgbClr val="8DA9C4"/>
+                        <a:srgbClr val="A9B8CC"/>
                       </a:solidFill>
                       <a:prstDash val="solid"/>
                       <a:round/>
@@ -6973,7 +7118,7 @@
                     </a:lnT>
                     <a:lnB w="6350" cap="flat" cmpd="sng" algn="ctr">
                       <a:solidFill>
-                        <a:srgbClr val="8DA9C4"/>
+                        <a:srgbClr val="A9B8CC"/>
                       </a:solidFill>
                       <a:prstDash val="solid"/>
                       <a:round/>
@@ -7004,7 +7149,7 @@
                   <a:tcPr marL="91440" marR="91440" marT="45720" marB="45720" anchor="ctr">
                     <a:lnL w="6350" cap="flat" cmpd="sng" algn="ctr">
                       <a:solidFill>
-                        <a:srgbClr val="8DA9C4"/>
+                        <a:srgbClr val="A9B8CC"/>
                       </a:solidFill>
                       <a:prstDash val="solid"/>
                       <a:round/>
@@ -7013,7 +7158,7 @@
                     </a:lnL>
                     <a:lnR w="6350" cap="flat" cmpd="sng" algn="ctr">
                       <a:solidFill>
-                        <a:srgbClr val="8DA9C4"/>
+                        <a:srgbClr val="A9B8CC"/>
                       </a:solidFill>
                       <a:prstDash val="solid"/>
                       <a:round/>
@@ -7022,7 +7167,7 @@
                     </a:lnR>
                     <a:lnT w="6350" cap="flat" cmpd="sng" algn="ctr">
                       <a:solidFill>
-                        <a:srgbClr val="8DA9C4"/>
+                        <a:srgbClr val="A9B8CC"/>
                       </a:solidFill>
                       <a:prstDash val="solid"/>
                       <a:round/>
@@ -7031,7 +7176,7 @@
                     </a:lnT>
                     <a:lnB w="6350" cap="flat" cmpd="sng" algn="ctr">
                       <a:solidFill>
-                        <a:srgbClr val="8DA9C4"/>
+                        <a:srgbClr val="A9B8CC"/>
                       </a:solidFill>
                       <a:prstDash val="solid"/>
                       <a:round/>
@@ -7117,10 +7262,10 @@
       </p:grpSpPr>
       <p:sp>
         <p:nvSpPr>
-          <p:cNvPr id="2" name="Text 0"/>
+          <p:cNvPr id="2" name="Text 3"/>
           <p:cNvSpPr/>
           <p:nvPr>
-            <p:ph idx="100" type="title" hasCustomPrompt="1"/>
+            <p:ph idx="103" type="title" hasCustomPrompt="1"/>
           </p:nvPr>
         </p:nvSpPr>
         <p:spPr>
@@ -7155,7 +7300,7 @@
       </p:sp>
       <p:sp>
         <p:nvSpPr>
-          <p:cNvPr id="3" name="st28"/>
+          <p:cNvPr id="3" name="st31"/>
           <p:cNvSpPr/>
           <p:nvPr/>
         </p:nvSpPr>
@@ -7175,7 +7320,7 @@
       </p:sp>
       <p:sp>
         <p:nvSpPr>
-          <p:cNvPr id="4" name="t29"/>
+          <p:cNvPr id="4" name="t32"/>
           <p:cNvSpPr txBox="1"/>
           <p:nvPr/>
         </p:nvSpPr>
@@ -7211,7 +7356,7 @@
       </p:sp>
       <p:sp>
         <p:nvSpPr>
-          <p:cNvPr id="5" name="t30"/>
+          <p:cNvPr id="5" name="t33"/>
           <p:cNvSpPr txBox="1"/>
           <p:nvPr/>
         </p:nvSpPr>
@@ -7247,7 +7392,7 @@
       </p:sp>
       <p:sp>
         <p:nvSpPr>
-          <p:cNvPr id="6" name="st31"/>
+          <p:cNvPr id="6" name="st34"/>
           <p:cNvSpPr/>
           <p:nvPr/>
         </p:nvSpPr>
@@ -7267,7 +7412,7 @@
       </p:sp>
       <p:sp>
         <p:nvSpPr>
-          <p:cNvPr id="7" name="t32"/>
+          <p:cNvPr id="7" name="t35"/>
           <p:cNvSpPr txBox="1"/>
           <p:nvPr/>
         </p:nvSpPr>
@@ -7303,7 +7448,7 @@
       </p:sp>
       <p:sp>
         <p:nvSpPr>
-          <p:cNvPr id="8" name="t33"/>
+          <p:cNvPr id="8" name="t36"/>
           <p:cNvSpPr txBox="1"/>
           <p:nvPr/>
         </p:nvSpPr>
@@ -7339,7 +7484,7 @@
       </p:sp>
       <p:sp>
         <p:nvSpPr>
-          <p:cNvPr id="9" name="st34"/>
+          <p:cNvPr id="9" name="st37"/>
           <p:cNvSpPr/>
           <p:nvPr/>
         </p:nvSpPr>
@@ -7359,7 +7504,7 @@
       </p:sp>
       <p:sp>
         <p:nvSpPr>
-          <p:cNvPr id="10" name="t35"/>
+          <p:cNvPr id="10" name="t38"/>
           <p:cNvSpPr txBox="1"/>
           <p:nvPr/>
         </p:nvSpPr>
@@ -7395,7 +7540,7 @@
       </p:sp>
       <p:sp>
         <p:nvSpPr>
-          <p:cNvPr id="11" name="t36"/>
+          <p:cNvPr id="11" name="t39"/>
           <p:cNvSpPr txBox="1"/>
           <p:nvPr/>
         </p:nvSpPr>
@@ -7431,7 +7576,7 @@
       </p:sp>
       <p:sp>
         <p:nvSpPr>
-          <p:cNvPr id="12" name="st37"/>
+          <p:cNvPr id="12" name="st40"/>
           <p:cNvSpPr/>
           <p:nvPr/>
         </p:nvSpPr>
@@ -7451,7 +7596,7 @@
       </p:sp>
       <p:sp>
         <p:nvSpPr>
-          <p:cNvPr id="13" name="t38"/>
+          <p:cNvPr id="13" name="t41"/>
           <p:cNvSpPr txBox="1"/>
           <p:nvPr/>
         </p:nvSpPr>
@@ -7487,7 +7632,7 @@
       </p:sp>
       <p:sp>
         <p:nvSpPr>
-          <p:cNvPr id="14" name="t39"/>
+          <p:cNvPr id="14" name="t42"/>
           <p:cNvSpPr txBox="1"/>
           <p:nvPr/>
         </p:nvSpPr>
@@ -7523,7 +7668,7 @@
       </p:sp>
       <p:sp>
         <p:nvSpPr>
-          <p:cNvPr id="15" name="st40"/>
+          <p:cNvPr id="15" name="st43"/>
           <p:cNvSpPr/>
           <p:nvPr/>
         </p:nvSpPr>
@@ -7543,7 +7688,7 @@
       </p:sp>
       <p:sp>
         <p:nvSpPr>
-          <p:cNvPr id="16" name="t41"/>
+          <p:cNvPr id="16" name="t44"/>
           <p:cNvSpPr txBox="1"/>
           <p:nvPr/>
         </p:nvSpPr>
@@ -7579,7 +7724,7 @@
       </p:sp>
       <p:sp>
         <p:nvSpPr>
-          <p:cNvPr id="17" name="t42"/>
+          <p:cNvPr id="17" name="t45"/>
           <p:cNvSpPr txBox="1"/>
           <p:nvPr/>
         </p:nvSpPr>
@@ -7615,7 +7760,7 @@
       </p:sp>
       <p:sp>
         <p:nvSpPr>
-          <p:cNvPr id="18" name="st43"/>
+          <p:cNvPr id="18" name="st46"/>
           <p:cNvSpPr/>
           <p:nvPr/>
         </p:nvSpPr>
@@ -7635,7 +7780,7 @@
       </p:sp>
       <p:sp>
         <p:nvSpPr>
-          <p:cNvPr id="19" name="t44"/>
+          <p:cNvPr id="19" name="t47"/>
           <p:cNvSpPr txBox="1"/>
           <p:nvPr/>
         </p:nvSpPr>
@@ -7671,7 +7816,7 @@
       </p:sp>
       <p:sp>
         <p:nvSpPr>
-          <p:cNvPr id="20" name="t45"/>
+          <p:cNvPr id="20" name="t48"/>
           <p:cNvSpPr txBox="1"/>
           <p:nvPr/>
         </p:nvSpPr>
@@ -7707,7 +7852,7 @@
       </p:sp>
       <p:sp>
         <p:nvSpPr>
-          <p:cNvPr id="21" name="st46"/>
+          <p:cNvPr id="21" name="st49"/>
           <p:cNvSpPr/>
           <p:nvPr/>
         </p:nvSpPr>
@@ -7727,7 +7872,7 @@
       </p:sp>
       <p:sp>
         <p:nvSpPr>
-          <p:cNvPr id="22" name="t47"/>
+          <p:cNvPr id="22" name="t50"/>
           <p:cNvSpPr txBox="1"/>
           <p:nvPr/>
         </p:nvSpPr>
@@ -7763,7 +7908,7 @@
       </p:sp>
       <p:sp>
         <p:nvSpPr>
-          <p:cNvPr id="23" name="t48"/>
+          <p:cNvPr id="23" name="t51"/>
           <p:cNvSpPr txBox="1"/>
           <p:nvPr/>
         </p:nvSpPr>
@@ -7826,7 +7971,7 @@
       </p:sp>
       <p:sp>
         <p:nvSpPr>
-          <p:cNvPr id="25" name="t50"/>
+          <p:cNvPr id="25" name="t53"/>
           <p:cNvSpPr txBox="1"/>
           <p:nvPr/>
         </p:nvSpPr>
@@ -7867,9 +8012,6 @@
                 <a:solidFill>
                   <a:schemeClr val="tx1"/>
                 </a:solidFill>
-                <a:latin typeface="Cambria" pitchFamily="34" charset="0"/>
-                <a:ea typeface="Cambria" pitchFamily="34" charset="-122"/>
-                <a:cs typeface="Cambria" pitchFamily="34" charset="-120"/>
               </a:rPr>
               <a:t>c ← (1 − λ)·c + λ·φ,  λ = 0.3,   φ = (S_B − S_R) / (S_B + S_R + κ)</a:t>
             </a:r>
@@ -7926,9 +8068,6 @@
                 <a:solidFill>
                   <a:schemeClr val="tx1"/>
                 </a:solidFill>
-                <a:latin typeface="Cambria" pitchFamily="34" charset="0"/>
-                <a:ea typeface="Cambria" pitchFamily="34" charset="-122"/>
-                <a:cs typeface="Cambria" pitchFamily="34" charset="-120"/>
               </a:rPr>
               <a:t>h = (h₀ + h_A·[asserts]) · min(S_B, S_R) · (1 + ℓ/2),  ρ = 1 − e^(−h)</a:t>
             </a:r>
@@ -7985,9 +8124,6 @@
                 <a:solidFill>
                   <a:schemeClr val="tx1"/>
                 </a:solidFill>
-                <a:latin typeface="Cambria" pitchFamily="34" charset="0"/>
-                <a:ea typeface="Cambria" pitchFamily="34" charset="-122"/>
-                <a:cs typeface="Cambria" pitchFamily="34" charset="-120"/>
               </a:rPr>
               <a:t>g = Σ V·c − γ·moves − η·ℓ − ζ_D,   minus W = 200 at war</a:t>
             </a:r>
@@ -8011,7 +8147,7 @@
       </p:sp>
       <p:sp>
         <p:nvSpPr>
-          <p:cNvPr id="26" name="tk51"/>
+          <p:cNvPr id="26" name="tk54"/>
           <p:cNvSpPr/>
           <p:nvPr/>
         </p:nvSpPr>
@@ -8038,7 +8174,7 @@
       </p:sp>
       <p:sp>
         <p:nvSpPr>
-          <p:cNvPr id="27" name="t52"/>
+          <p:cNvPr id="27" name="t55"/>
           <p:cNvSpPr txBox="1"/>
           <p:nvPr/>
         </p:nvSpPr>
@@ -8155,10 +8291,10 @@
       </p:grpSpPr>
       <p:sp>
         <p:nvSpPr>
-          <p:cNvPr id="2" name="Text 0"/>
+          <p:cNvPr id="2" name="Text 3"/>
           <p:cNvSpPr/>
           <p:nvPr>
-            <p:ph idx="100" type="title" hasCustomPrompt="1"/>
+            <p:ph idx="103" type="title" hasCustomPrompt="1"/>
           </p:nvPr>
         </p:nvSpPr>
         <p:spPr>
@@ -8193,7 +8329,7 @@
       </p:sp>
       <p:sp>
         <p:nvSpPr>
-          <p:cNvPr id="3" name="cd53"/>
+          <p:cNvPr id="3" name="cd56"/>
           <p:cNvSpPr/>
           <p:nvPr/>
         </p:nvSpPr>
@@ -8218,7 +8354,7 @@
       </p:sp>
       <p:sp>
         <p:nvSpPr>
-          <p:cNvPr id="4" name="cdh54"/>
+          <p:cNvPr id="4" name="cdh57"/>
           <p:cNvSpPr/>
           <p:nvPr/>
         </p:nvSpPr>
@@ -8243,7 +8379,7 @@
       </p:sp>
       <p:sp>
         <p:nvSpPr>
-          <p:cNvPr id="5" name="t55"/>
+          <p:cNvPr id="5" name="t58"/>
           <p:cNvSpPr txBox="1"/>
           <p:nvPr/>
         </p:nvSpPr>
@@ -8279,7 +8415,7 @@
       </p:sp>
       <p:sp>
         <p:nvSpPr>
-          <p:cNvPr id="6" name="t56"/>
+          <p:cNvPr id="6" name="t59"/>
           <p:cNvSpPr txBox="1"/>
           <p:nvPr/>
         </p:nvSpPr>
@@ -8335,7 +8471,7 @@
       </p:sp>
       <p:sp>
         <p:nvSpPr>
-          <p:cNvPr id="7" name="t57"/>
+          <p:cNvPr id="7" name="t60"/>
           <p:cNvSpPr txBox="1"/>
           <p:nvPr/>
         </p:nvSpPr>
@@ -8371,7 +8507,7 @@
       </p:sp>
       <p:sp>
         <p:nvSpPr>
-          <p:cNvPr id="8" name="cd58"/>
+          <p:cNvPr id="8" name="cd61"/>
           <p:cNvSpPr/>
           <p:nvPr/>
         </p:nvSpPr>
@@ -8396,7 +8532,7 @@
       </p:sp>
       <p:sp>
         <p:nvSpPr>
-          <p:cNvPr id="9" name="cdh59"/>
+          <p:cNvPr id="9" name="cdh62"/>
           <p:cNvSpPr/>
           <p:nvPr/>
         </p:nvSpPr>
@@ -8421,7 +8557,7 @@
       </p:sp>
       <p:sp>
         <p:nvSpPr>
-          <p:cNvPr id="10" name="t60"/>
+          <p:cNvPr id="10" name="t63"/>
           <p:cNvSpPr txBox="1"/>
           <p:nvPr/>
         </p:nvSpPr>
@@ -8457,7 +8593,7 @@
       </p:sp>
       <p:sp>
         <p:nvSpPr>
-          <p:cNvPr id="11" name="t61"/>
+          <p:cNvPr id="11" name="t64"/>
           <p:cNvSpPr txBox="1"/>
           <p:nvPr/>
         </p:nvSpPr>
@@ -8513,7 +8649,7 @@
       </p:sp>
       <p:sp>
         <p:nvSpPr>
-          <p:cNvPr id="12" name="t62"/>
+          <p:cNvPr id="12" name="t65"/>
           <p:cNvSpPr txBox="1"/>
           <p:nvPr/>
         </p:nvSpPr>
@@ -8549,7 +8685,7 @@
       </p:sp>
       <p:sp>
         <p:nvSpPr>
-          <p:cNvPr id="13" name="cd63"/>
+          <p:cNvPr id="13" name="cd66"/>
           <p:cNvSpPr/>
           <p:nvPr/>
         </p:nvSpPr>
@@ -8574,7 +8710,7 @@
       </p:sp>
       <p:sp>
         <p:nvSpPr>
-          <p:cNvPr id="14" name="cdh64"/>
+          <p:cNvPr id="14" name="cdh67"/>
           <p:cNvSpPr/>
           <p:nvPr/>
         </p:nvSpPr>
@@ -8599,7 +8735,7 @@
       </p:sp>
       <p:sp>
         <p:nvSpPr>
-          <p:cNvPr id="15" name="t65"/>
+          <p:cNvPr id="15" name="t68"/>
           <p:cNvSpPr txBox="1"/>
           <p:nvPr/>
         </p:nvSpPr>
@@ -8635,7 +8771,7 @@
       </p:sp>
       <p:sp>
         <p:nvSpPr>
-          <p:cNvPr id="16" name="t66"/>
+          <p:cNvPr id="16" name="t69"/>
           <p:cNvSpPr txBox="1"/>
           <p:nvPr/>
         </p:nvSpPr>
@@ -8741,7 +8877,7 @@
       </p:sp>
       <p:sp>
         <p:nvSpPr>
-          <p:cNvPr id="17" name="t67"/>
+          <p:cNvPr id="17" name="t70"/>
           <p:cNvSpPr txBox="1"/>
           <p:nvPr/>
         </p:nvSpPr>
@@ -8777,7 +8913,7 @@
       </p:sp>
       <p:sp>
         <p:nvSpPr>
-          <p:cNvPr id="18" name="tk68"/>
+          <p:cNvPr id="18" name="tk71"/>
           <p:cNvSpPr/>
           <p:nvPr/>
         </p:nvSpPr>
@@ -8804,7 +8940,7 @@
       </p:sp>
       <p:sp>
         <p:nvSpPr>
-          <p:cNvPr id="19" name="t69"/>
+          <p:cNvPr id="19" name="t72"/>
           <p:cNvSpPr txBox="1"/>
           <p:nvPr/>
         </p:nvSpPr>
@@ -8921,10 +9057,10 @@
       </p:grpSpPr>
       <p:sp>
         <p:nvSpPr>
-          <p:cNvPr id="2" name="Text 0"/>
+          <p:cNvPr id="2" name="Text 3"/>
           <p:cNvSpPr/>
           <p:nvPr>
-            <p:ph idx="100" type="title" hasCustomPrompt="1"/>
+            <p:ph idx="103" type="title" hasCustomPrompt="1"/>
           </p:nvPr>
         </p:nvSpPr>
         <p:spPr>
@@ -9007,7 +9143,7 @@
                   <a:tcPr marL="91440" marR="91440" marT="45720" marB="45720" anchor="ctr">
                     <a:lnL w="9525" cap="flat" cmpd="sng" algn="ctr">
                       <a:solidFill>
-                        <a:srgbClr val="8DA9C4"/>
+                        <a:srgbClr val="A9B8CC"/>
                       </a:solidFill>
                       <a:prstDash val="solid"/>
                       <a:round/>
@@ -9016,7 +9152,7 @@
                     </a:lnL>
                     <a:lnR w="9525" cap="flat" cmpd="sng" algn="ctr">
                       <a:solidFill>
-                        <a:srgbClr val="8DA9C4"/>
+                        <a:srgbClr val="A9B8CC"/>
                       </a:solidFill>
                       <a:prstDash val="solid"/>
                       <a:round/>
@@ -9025,7 +9161,7 @@
                     </a:lnR>
                     <a:lnT w="9525" cap="flat" cmpd="sng" algn="ctr">
                       <a:solidFill>
-                        <a:srgbClr val="8DA9C4"/>
+                        <a:srgbClr val="A9B8CC"/>
                       </a:solidFill>
                       <a:prstDash val="solid"/>
                       <a:round/>
@@ -9034,7 +9170,7 @@
                     </a:lnT>
                     <a:lnB w="9525" cap="flat" cmpd="sng" algn="ctr">
                       <a:solidFill>
-                        <a:srgbClr val="8DA9C4"/>
+                        <a:srgbClr val="A9B8CC"/>
                       </a:solidFill>
                       <a:prstDash val="solid"/>
                       <a:round/>
@@ -9068,7 +9204,7 @@
                   <a:tcPr marL="91440" marR="91440" marT="45720" marB="45720" anchor="ctr">
                     <a:lnL w="9525" cap="flat" cmpd="sng" algn="ctr">
                       <a:solidFill>
-                        <a:srgbClr val="8DA9C4"/>
+                        <a:srgbClr val="A9B8CC"/>
                       </a:solidFill>
                       <a:prstDash val="solid"/>
                       <a:round/>
@@ -9077,7 +9213,7 @@
                     </a:lnL>
                     <a:lnR w="9525" cap="flat" cmpd="sng" algn="ctr">
                       <a:solidFill>
-                        <a:srgbClr val="8DA9C4"/>
+                        <a:srgbClr val="A9B8CC"/>
                       </a:solidFill>
                       <a:prstDash val="solid"/>
                       <a:round/>
@@ -9086,7 +9222,7 @@
                     </a:lnR>
                     <a:lnT w="9525" cap="flat" cmpd="sng" algn="ctr">
                       <a:solidFill>
-                        <a:srgbClr val="8DA9C4"/>
+                        <a:srgbClr val="A9B8CC"/>
                       </a:solidFill>
                       <a:prstDash val="solid"/>
                       <a:round/>
@@ -9095,7 +9231,7 @@
                     </a:lnT>
                     <a:lnB w="9525" cap="flat" cmpd="sng" algn="ctr">
                       <a:solidFill>
-                        <a:srgbClr val="8DA9C4"/>
+                        <a:srgbClr val="A9B8CC"/>
                       </a:solidFill>
                       <a:prstDash val="solid"/>
                       <a:round/>
@@ -9129,7 +9265,7 @@
                   <a:tcPr marL="91440" marR="91440" marT="45720" marB="45720" anchor="ctr">
                     <a:lnL w="9525" cap="flat" cmpd="sng" algn="ctr">
                       <a:solidFill>
-                        <a:srgbClr val="8DA9C4"/>
+                        <a:srgbClr val="A9B8CC"/>
                       </a:solidFill>
                       <a:prstDash val="solid"/>
                       <a:round/>
@@ -9138,7 +9274,7 @@
                     </a:lnL>
                     <a:lnR w="9525" cap="flat" cmpd="sng" algn="ctr">
                       <a:solidFill>
-                        <a:srgbClr val="8DA9C4"/>
+                        <a:srgbClr val="A9B8CC"/>
                       </a:solidFill>
                       <a:prstDash val="solid"/>
                       <a:round/>
@@ -9147,7 +9283,7 @@
                     </a:lnR>
                     <a:lnT w="9525" cap="flat" cmpd="sng" algn="ctr">
                       <a:solidFill>
-                        <a:srgbClr val="8DA9C4"/>
+                        <a:srgbClr val="A9B8CC"/>
                       </a:solidFill>
                       <a:prstDash val="solid"/>
                       <a:round/>
@@ -9156,7 +9292,7 @@
                     </a:lnT>
                     <a:lnB w="9525" cap="flat" cmpd="sng" algn="ctr">
                       <a:solidFill>
-                        <a:srgbClr val="8DA9C4"/>
+                        <a:srgbClr val="A9B8CC"/>
                       </a:solidFill>
                       <a:prstDash val="solid"/>
                       <a:round/>
@@ -9192,7 +9328,7 @@
                   <a:tcPr marL="91440" marR="91440" marT="45720" marB="45720" anchor="ctr">
                     <a:lnL w="9525" cap="flat" cmpd="sng" algn="ctr">
                       <a:solidFill>
-                        <a:srgbClr val="8DA9C4"/>
+                        <a:srgbClr val="A9B8CC"/>
                       </a:solidFill>
                       <a:prstDash val="solid"/>
                       <a:round/>
@@ -9201,7 +9337,7 @@
                     </a:lnL>
                     <a:lnR w="9525" cap="flat" cmpd="sng" algn="ctr">
                       <a:solidFill>
-                        <a:srgbClr val="8DA9C4"/>
+                        <a:srgbClr val="A9B8CC"/>
                       </a:solidFill>
                       <a:prstDash val="solid"/>
                       <a:round/>
@@ -9210,7 +9346,7 @@
                     </a:lnR>
                     <a:lnT w="9525" cap="flat" cmpd="sng" algn="ctr">
                       <a:solidFill>
-                        <a:srgbClr val="8DA9C4"/>
+                        <a:srgbClr val="A9B8CC"/>
                       </a:solidFill>
                       <a:prstDash val="solid"/>
                       <a:round/>
@@ -9219,7 +9355,7 @@
                     </a:lnT>
                     <a:lnB w="9525" cap="flat" cmpd="sng" algn="ctr">
                       <a:solidFill>
-                        <a:srgbClr val="8DA9C4"/>
+                        <a:srgbClr val="A9B8CC"/>
                       </a:solidFill>
                       <a:prstDash val="solid"/>
                       <a:round/>
@@ -9250,7 +9386,7 @@
                   <a:tcPr marL="91440" marR="91440" marT="45720" marB="45720" anchor="ctr">
                     <a:lnL w="9525" cap="flat" cmpd="sng" algn="ctr">
                       <a:solidFill>
-                        <a:srgbClr val="8DA9C4"/>
+                        <a:srgbClr val="A9B8CC"/>
                       </a:solidFill>
                       <a:prstDash val="solid"/>
                       <a:round/>
@@ -9259,7 +9395,7 @@
                     </a:lnL>
                     <a:lnR w="9525" cap="flat" cmpd="sng" algn="ctr">
                       <a:solidFill>
-                        <a:srgbClr val="8DA9C4"/>
+                        <a:srgbClr val="A9B8CC"/>
                       </a:solidFill>
                       <a:prstDash val="solid"/>
                       <a:round/>
@@ -9268,7 +9404,7 @@
                     </a:lnR>
                     <a:lnT w="9525" cap="flat" cmpd="sng" algn="ctr">
                       <a:solidFill>
-                        <a:srgbClr val="8DA9C4"/>
+                        <a:srgbClr val="A9B8CC"/>
                       </a:solidFill>
                       <a:prstDash val="solid"/>
                       <a:round/>
@@ -9277,7 +9413,7 @@
                     </a:lnT>
                     <a:lnB w="9525" cap="flat" cmpd="sng" algn="ctr">
                       <a:solidFill>
-                        <a:srgbClr val="8DA9C4"/>
+                        <a:srgbClr val="A9B8CC"/>
                       </a:solidFill>
                       <a:prstDash val="solid"/>
                       <a:round/>
@@ -9308,7 +9444,7 @@
                   <a:tcPr marL="91440" marR="91440" marT="45720" marB="45720" anchor="ctr">
                     <a:lnL w="9525" cap="flat" cmpd="sng" algn="ctr">
                       <a:solidFill>
-                        <a:srgbClr val="8DA9C4"/>
+                        <a:srgbClr val="A9B8CC"/>
                       </a:solidFill>
                       <a:prstDash val="solid"/>
                       <a:round/>
@@ -9317,7 +9453,7 @@
                     </a:lnL>
                     <a:lnR w="9525" cap="flat" cmpd="sng" algn="ctr">
                       <a:solidFill>
-                        <a:srgbClr val="8DA9C4"/>
+                        <a:srgbClr val="A9B8CC"/>
                       </a:solidFill>
                       <a:prstDash val="solid"/>
                       <a:round/>
@@ -9326,7 +9462,7 @@
                     </a:lnR>
                     <a:lnT w="9525" cap="flat" cmpd="sng" algn="ctr">
                       <a:solidFill>
-                        <a:srgbClr val="8DA9C4"/>
+                        <a:srgbClr val="A9B8CC"/>
                       </a:solidFill>
                       <a:prstDash val="solid"/>
                       <a:round/>
@@ -9335,7 +9471,7 @@
                     </a:lnT>
                     <a:lnB w="9525" cap="flat" cmpd="sng" algn="ctr">
                       <a:solidFill>
-                        <a:srgbClr val="8DA9C4"/>
+                        <a:srgbClr val="A9B8CC"/>
                       </a:solidFill>
                       <a:prstDash val="solid"/>
                       <a:round/>
@@ -9368,7 +9504,7 @@
                   <a:tcPr marL="91440" marR="91440" marT="45720" marB="45720" anchor="ctr">
                     <a:lnL w="9525" cap="flat" cmpd="sng" algn="ctr">
                       <a:solidFill>
-                        <a:srgbClr val="8DA9C4"/>
+                        <a:srgbClr val="A9B8CC"/>
                       </a:solidFill>
                       <a:prstDash val="solid"/>
                       <a:round/>
@@ -9377,7 +9513,7 @@
                     </a:lnL>
                     <a:lnR w="9525" cap="flat" cmpd="sng" algn="ctr">
                       <a:solidFill>
-                        <a:srgbClr val="8DA9C4"/>
+                        <a:srgbClr val="A9B8CC"/>
                       </a:solidFill>
                       <a:prstDash val="solid"/>
                       <a:round/>
@@ -9386,7 +9522,7 @@
                     </a:lnR>
                     <a:lnT w="9525" cap="flat" cmpd="sng" algn="ctr">
                       <a:solidFill>
-                        <a:srgbClr val="8DA9C4"/>
+                        <a:srgbClr val="A9B8CC"/>
                       </a:solidFill>
                       <a:prstDash val="solid"/>
                       <a:round/>
@@ -9395,7 +9531,7 @@
                     </a:lnT>
                     <a:lnB w="9525" cap="flat" cmpd="sng" algn="ctr">
                       <a:solidFill>
-                        <a:srgbClr val="8DA9C4"/>
+                        <a:srgbClr val="A9B8CC"/>
                       </a:solidFill>
                       <a:prstDash val="solid"/>
                       <a:round/>
@@ -9426,7 +9562,7 @@
                   <a:tcPr marL="91440" marR="91440" marT="45720" marB="45720" anchor="ctr">
                     <a:lnL w="9525" cap="flat" cmpd="sng" algn="ctr">
                       <a:solidFill>
-                        <a:srgbClr val="8DA9C4"/>
+                        <a:srgbClr val="A9B8CC"/>
                       </a:solidFill>
                       <a:prstDash val="solid"/>
                       <a:round/>
@@ -9435,7 +9571,7 @@
                     </a:lnL>
                     <a:lnR w="9525" cap="flat" cmpd="sng" algn="ctr">
                       <a:solidFill>
-                        <a:srgbClr val="8DA9C4"/>
+                        <a:srgbClr val="A9B8CC"/>
                       </a:solidFill>
                       <a:prstDash val="solid"/>
                       <a:round/>
@@ -9444,7 +9580,7 @@
                     </a:lnR>
                     <a:lnT w="9525" cap="flat" cmpd="sng" algn="ctr">
                       <a:solidFill>
-                        <a:srgbClr val="8DA9C4"/>
+                        <a:srgbClr val="A9B8CC"/>
                       </a:solidFill>
                       <a:prstDash val="solid"/>
                       <a:round/>
@@ -9453,7 +9589,7 @@
                     </a:lnT>
                     <a:lnB w="9525" cap="flat" cmpd="sng" algn="ctr">
                       <a:solidFill>
-                        <a:srgbClr val="8DA9C4"/>
+                        <a:srgbClr val="A9B8CC"/>
                       </a:solidFill>
                       <a:prstDash val="solid"/>
                       <a:round/>
@@ -9484,7 +9620,7 @@
                   <a:tcPr marL="91440" marR="91440" marT="45720" marB="45720" anchor="ctr">
                     <a:lnL w="9525" cap="flat" cmpd="sng" algn="ctr">
                       <a:solidFill>
-                        <a:srgbClr val="8DA9C4"/>
+                        <a:srgbClr val="A9B8CC"/>
                       </a:solidFill>
                       <a:prstDash val="solid"/>
                       <a:round/>
@@ -9493,7 +9629,7 @@
                     </a:lnL>
                     <a:lnR w="9525" cap="flat" cmpd="sng" algn="ctr">
                       <a:solidFill>
-                        <a:srgbClr val="8DA9C4"/>
+                        <a:srgbClr val="A9B8CC"/>
                       </a:solidFill>
                       <a:prstDash val="solid"/>
                       <a:round/>
@@ -9502,7 +9638,7 @@
                     </a:lnR>
                     <a:lnT w="9525" cap="flat" cmpd="sng" algn="ctr">
                       <a:solidFill>
-                        <a:srgbClr val="8DA9C4"/>
+                        <a:srgbClr val="A9B8CC"/>
                       </a:solidFill>
                       <a:prstDash val="solid"/>
                       <a:round/>
@@ -9511,7 +9647,7 @@
                     </a:lnT>
                     <a:lnB w="9525" cap="flat" cmpd="sng" algn="ctr">
                       <a:solidFill>
-                        <a:srgbClr val="8DA9C4"/>
+                        <a:srgbClr val="A9B8CC"/>
                       </a:solidFill>
                       <a:prstDash val="solid"/>
                       <a:round/>
@@ -9527,7 +9663,7 @@
       </p:graphicFrame>
       <p:sp>
         <p:nvSpPr>
-          <p:cNvPr id="4" name="t71"/>
+          <p:cNvPr id="4" name="t74"/>
           <p:cNvSpPr txBox="1"/>
           <p:nvPr/>
         </p:nvSpPr>
@@ -9563,7 +9699,7 @@
       </p:sp>
       <p:sp>
         <p:nvSpPr>
-          <p:cNvPr id="5" name="t72"/>
+          <p:cNvPr id="5" name="t75"/>
           <p:cNvSpPr txBox="1"/>
           <p:nvPr/>
         </p:nvSpPr>
@@ -9672,7 +9808,7 @@
       </p:sp>
       <p:sp>
         <p:nvSpPr>
-          <p:cNvPr id="6" name="tk73"/>
+          <p:cNvPr id="6" name="tk76"/>
           <p:cNvSpPr/>
           <p:nvPr/>
         </p:nvSpPr>
@@ -9699,7 +9835,7 @@
       </p:sp>
       <p:sp>
         <p:nvSpPr>
-          <p:cNvPr id="7" name="t74"/>
+          <p:cNvPr id="7" name="t77"/>
           <p:cNvSpPr txBox="1"/>
           <p:nvPr/>
         </p:nvSpPr>
@@ -9816,10 +9952,10 @@
       </p:grpSpPr>
       <p:sp>
         <p:nvSpPr>
-          <p:cNvPr id="2" name="Text 0"/>
+          <p:cNvPr id="2" name="Text 3"/>
           <p:cNvSpPr/>
           <p:nvPr>
-            <p:ph idx="100" type="title" hasCustomPrompt="1"/>
+            <p:ph idx="103" type="title" hasCustomPrompt="1"/>
           </p:nvPr>
         </p:nvSpPr>
         <p:spPr>
@@ -9854,7 +9990,7 @@
       </p:sp>
       <p:pic>
         <p:nvPicPr>
-          <p:cNvPr id="3" name="img75" descr="/Users/seanbowman/Documents/MIT/Fall26/6.s974/repo/slides/../prototype/results/figures/gui_screenshot.png">    </p:cNvPr>
+          <p:cNvPr id="3" name="img78" descr="/Users/seanbowman/Documents/MIT/Fall26/6.s974/repo/slides/../prototype/results/figures/gui_screenshot.png">    </p:cNvPr>
           <p:cNvPicPr>
             <a:picLocks noChangeAspect="1"/>
           </p:cNvPicPr>
@@ -9878,7 +10014,7 @@
       </p:pic>
       <p:sp>
         <p:nvSpPr>
-          <p:cNvPr id="4" name="t76"/>
+          <p:cNvPr id="4" name="t79"/>
           <p:cNvSpPr txBox="1"/>
           <p:nvPr/>
         </p:nvSpPr>
@@ -9994,7 +10130,7 @@
             <a:r>
               <a:rPr lang="en-US" sz="1600" b="1" dirty="0">
                 <a:solidFill>
-                  <a:schemeClr val="accent3"/>
+                  <a:srgbClr val="E8A33D"/>
                 </a:solidFill>
               </a:rPr>
               <a:t>Orange ring </a:t>
@@ -10115,10 +10251,10 @@
       </p:grpSpPr>
       <p:sp>
         <p:nvSpPr>
-          <p:cNvPr id="2" name="Text 0"/>
+          <p:cNvPr id="2" name="Text 3"/>
           <p:cNvSpPr/>
           <p:nvPr>
-            <p:ph idx="100" type="title" hasCustomPrompt="1"/>
+            <p:ph idx="103" type="title" hasCustomPrompt="1"/>
           </p:nvPr>
         </p:nvSpPr>
         <p:spPr>
@@ -10153,7 +10289,7 @@
       </p:sp>
       <p:pic>
         <p:nvPicPr>
-          <p:cNvPr id="3" name="img77" descr="/Users/seanbowman/Documents/MIT/Fall26/6.s974/repo/slides/../prototype/results/figures/frontier.png">    </p:cNvPr>
+          <p:cNvPr id="3" name="img80" descr="/Users/seanbowman/Documents/MIT/Fall26/6.s974/repo/slides/../prototype/results/figures/frontier.png">    </p:cNvPr>
           <p:cNvPicPr>
             <a:picLocks noChangeAspect="1"/>
           </p:cNvPicPr>
@@ -10226,7 +10362,7 @@
                   <a:tcPr marL="91440" marR="91440" marT="45720" marB="45720" anchor="ctr">
                     <a:lnL w="6350" cap="flat" cmpd="sng" algn="ctr">
                       <a:solidFill>
-                        <a:srgbClr val="8DA9C4"/>
+                        <a:srgbClr val="A9B8CC"/>
                       </a:solidFill>
                       <a:prstDash val="solid"/>
                       <a:round/>
@@ -10235,7 +10371,7 @@
                     </a:lnL>
                     <a:lnR w="6350" cap="flat" cmpd="sng" algn="ctr">
                       <a:solidFill>
-                        <a:srgbClr val="8DA9C4"/>
+                        <a:srgbClr val="A9B8CC"/>
                       </a:solidFill>
                       <a:prstDash val="solid"/>
                       <a:round/>
@@ -10244,7 +10380,7 @@
                     </a:lnR>
                     <a:lnT w="6350" cap="flat" cmpd="sng" algn="ctr">
                       <a:solidFill>
-                        <a:srgbClr val="8DA9C4"/>
+                        <a:srgbClr val="A9B8CC"/>
                       </a:solidFill>
                       <a:prstDash val="solid"/>
                       <a:round/>
@@ -10253,7 +10389,7 @@
                     </a:lnT>
                     <a:lnB w="6350" cap="flat" cmpd="sng" algn="ctr">
                       <a:solidFill>
-                        <a:srgbClr val="8DA9C4"/>
+                        <a:srgbClr val="A9B8CC"/>
                       </a:solidFill>
                       <a:prstDash val="solid"/>
                       <a:round/>
@@ -10287,7 +10423,7 @@
                   <a:tcPr marL="91440" marR="91440" marT="45720" marB="45720" anchor="ctr">
                     <a:lnL w="6350" cap="flat" cmpd="sng" algn="ctr">
                       <a:solidFill>
-                        <a:srgbClr val="8DA9C4"/>
+                        <a:srgbClr val="A9B8CC"/>
                       </a:solidFill>
                       <a:prstDash val="solid"/>
                       <a:round/>
@@ -10296,7 +10432,7 @@
                     </a:lnL>
                     <a:lnR w="6350" cap="flat" cmpd="sng" algn="ctr">
                       <a:solidFill>
-                        <a:srgbClr val="8DA9C4"/>
+                        <a:srgbClr val="A9B8CC"/>
                       </a:solidFill>
                       <a:prstDash val="solid"/>
                       <a:round/>
@@ -10305,7 +10441,7 @@
                     </a:lnR>
                     <a:lnT w="6350" cap="flat" cmpd="sng" algn="ctr">
                       <a:solidFill>
-                        <a:srgbClr val="8DA9C4"/>
+                        <a:srgbClr val="A9B8CC"/>
                       </a:solidFill>
                       <a:prstDash val="solid"/>
                       <a:round/>
@@ -10314,7 +10450,7 @@
                     </a:lnT>
                     <a:lnB w="6350" cap="flat" cmpd="sng" algn="ctr">
                       <a:solidFill>
-                        <a:srgbClr val="8DA9C4"/>
+                        <a:srgbClr val="A9B8CC"/>
                       </a:solidFill>
                       <a:prstDash val="solid"/>
                       <a:round/>
@@ -10348,7 +10484,7 @@
                   <a:tcPr marL="91440" marR="91440" marT="45720" marB="45720" anchor="ctr">
                     <a:lnL w="6350" cap="flat" cmpd="sng" algn="ctr">
                       <a:solidFill>
-                        <a:srgbClr val="8DA9C4"/>
+                        <a:srgbClr val="A9B8CC"/>
                       </a:solidFill>
                       <a:prstDash val="solid"/>
                       <a:round/>
@@ -10357,7 +10493,7 @@
                     </a:lnL>
                     <a:lnR w="6350" cap="flat" cmpd="sng" algn="ctr">
                       <a:solidFill>
-                        <a:srgbClr val="8DA9C4"/>
+                        <a:srgbClr val="A9B8CC"/>
                       </a:solidFill>
                       <a:prstDash val="solid"/>
                       <a:round/>
@@ -10366,7 +10502,7 @@
                     </a:lnR>
                     <a:lnT w="6350" cap="flat" cmpd="sng" algn="ctr">
                       <a:solidFill>
-                        <a:srgbClr val="8DA9C4"/>
+                        <a:srgbClr val="A9B8CC"/>
                       </a:solidFill>
                       <a:prstDash val="solid"/>
                       <a:round/>
@@ -10375,7 +10511,7 @@
                     </a:lnT>
                     <a:lnB w="6350" cap="flat" cmpd="sng" algn="ctr">
                       <a:solidFill>
-                        <a:srgbClr val="8DA9C4"/>
+                        <a:srgbClr val="A9B8CC"/>
                       </a:solidFill>
                       <a:prstDash val="solid"/>
                       <a:round/>
@@ -10409,7 +10545,7 @@
                   <a:tcPr marL="91440" marR="91440" marT="45720" marB="45720" anchor="ctr">
                     <a:lnL w="6350" cap="flat" cmpd="sng" algn="ctr">
                       <a:solidFill>
-                        <a:srgbClr val="8DA9C4"/>
+                        <a:srgbClr val="A9B8CC"/>
                       </a:solidFill>
                       <a:prstDash val="solid"/>
                       <a:round/>
@@ -10418,7 +10554,7 @@
                     </a:lnL>
                     <a:lnR w="6350" cap="flat" cmpd="sng" algn="ctr">
                       <a:solidFill>
-                        <a:srgbClr val="8DA9C4"/>
+                        <a:srgbClr val="A9B8CC"/>
                       </a:solidFill>
                       <a:prstDash val="solid"/>
                       <a:round/>
@@ -10427,7 +10563,7 @@
                     </a:lnR>
                     <a:lnT w="6350" cap="flat" cmpd="sng" algn="ctr">
                       <a:solidFill>
-                        <a:srgbClr val="8DA9C4"/>
+                        <a:srgbClr val="A9B8CC"/>
                       </a:solidFill>
                       <a:prstDash val="solid"/>
                       <a:round/>
@@ -10436,7 +10572,7 @@
                     </a:lnT>
                     <a:lnB w="6350" cap="flat" cmpd="sng" algn="ctr">
                       <a:solidFill>
-                        <a:srgbClr val="8DA9C4"/>
+                        <a:srgbClr val="A9B8CC"/>
                       </a:solidFill>
                       <a:prstDash val="solid"/>
                       <a:round/>
@@ -10472,7 +10608,7 @@
                   <a:tcPr marL="91440" marR="91440" marT="45720" marB="45720" anchor="ctr">
                     <a:lnL w="6350" cap="flat" cmpd="sng" algn="ctr">
                       <a:solidFill>
-                        <a:srgbClr val="8DA9C4"/>
+                        <a:srgbClr val="A9B8CC"/>
                       </a:solidFill>
                       <a:prstDash val="solid"/>
                       <a:round/>
@@ -10481,7 +10617,7 @@
                     </a:lnL>
                     <a:lnR w="6350" cap="flat" cmpd="sng" algn="ctr">
                       <a:solidFill>
-                        <a:srgbClr val="8DA9C4"/>
+                        <a:srgbClr val="A9B8CC"/>
                       </a:solidFill>
                       <a:prstDash val="solid"/>
                       <a:round/>
@@ -10490,7 +10626,7 @@
                     </a:lnR>
                     <a:lnT w="6350" cap="flat" cmpd="sng" algn="ctr">
                       <a:solidFill>
-                        <a:srgbClr val="8DA9C4"/>
+                        <a:srgbClr val="A9B8CC"/>
                       </a:solidFill>
                       <a:prstDash val="solid"/>
                       <a:round/>
@@ -10499,7 +10635,7 @@
                     </a:lnT>
                     <a:lnB w="6350" cap="flat" cmpd="sng" algn="ctr">
                       <a:solidFill>
-                        <a:srgbClr val="8DA9C4"/>
+                        <a:srgbClr val="A9B8CC"/>
                       </a:solidFill>
                       <a:prstDash val="solid"/>
                       <a:round/>
@@ -10544,7 +10680,7 @@
                   <a:tcPr marL="91440" marR="91440" marT="45720" marB="45720" anchor="ctr">
                     <a:lnL w="6350" cap="flat" cmpd="sng" algn="ctr">
                       <a:solidFill>
-                        <a:srgbClr val="8DA9C4"/>
+                        <a:srgbClr val="A9B8CC"/>
                       </a:solidFill>
                       <a:prstDash val="solid"/>
                       <a:round/>
@@ -10553,7 +10689,7 @@
                     </a:lnL>
                     <a:lnR w="6350" cap="flat" cmpd="sng" algn="ctr">
                       <a:solidFill>
-                        <a:srgbClr val="8DA9C4"/>
+                        <a:srgbClr val="A9B8CC"/>
                       </a:solidFill>
                       <a:prstDash val="solid"/>
                       <a:round/>
@@ -10562,7 +10698,7 @@
                     </a:lnR>
                     <a:lnT w="6350" cap="flat" cmpd="sng" algn="ctr">
                       <a:solidFill>
-                        <a:srgbClr val="8DA9C4"/>
+                        <a:srgbClr val="A9B8CC"/>
                       </a:solidFill>
                       <a:prstDash val="solid"/>
                       <a:round/>
@@ -10571,7 +10707,7 @@
                     </a:lnT>
                     <a:lnB w="6350" cap="flat" cmpd="sng" algn="ctr">
                       <a:solidFill>
-                        <a:srgbClr val="8DA9C4"/>
+                        <a:srgbClr val="A9B8CC"/>
                       </a:solidFill>
                       <a:prstDash val="solid"/>
                       <a:round/>
@@ -10616,7 +10752,7 @@
                   <a:tcPr marL="91440" marR="91440" marT="45720" marB="45720" anchor="ctr">
                     <a:lnL w="6350" cap="flat" cmpd="sng" algn="ctr">
                       <a:solidFill>
-                        <a:srgbClr val="8DA9C4"/>
+                        <a:srgbClr val="A9B8CC"/>
                       </a:solidFill>
                       <a:prstDash val="solid"/>
                       <a:round/>
@@ -10625,7 +10761,7 @@
                     </a:lnL>
                     <a:lnR w="6350" cap="flat" cmpd="sng" algn="ctr">
                       <a:solidFill>
-                        <a:srgbClr val="8DA9C4"/>
+                        <a:srgbClr val="A9B8CC"/>
                       </a:solidFill>
                       <a:prstDash val="solid"/>
                       <a:round/>
@@ -10634,7 +10770,7 @@
                     </a:lnR>
                     <a:lnT w="6350" cap="flat" cmpd="sng" algn="ctr">
                       <a:solidFill>
-                        <a:srgbClr val="8DA9C4"/>
+                        <a:srgbClr val="A9B8CC"/>
                       </a:solidFill>
                       <a:prstDash val="solid"/>
                       <a:round/>
@@ -10643,7 +10779,7 @@
                     </a:lnT>
                     <a:lnB w="6350" cap="flat" cmpd="sng" algn="ctr">
                       <a:solidFill>
-                        <a:srgbClr val="8DA9C4"/>
+                        <a:srgbClr val="A9B8CC"/>
                       </a:solidFill>
                       <a:prstDash val="solid"/>
                       <a:round/>
@@ -10688,7 +10824,7 @@
                   <a:tcPr marL="91440" marR="91440" marT="45720" marB="45720" anchor="ctr">
                     <a:lnL w="6350" cap="flat" cmpd="sng" algn="ctr">
                       <a:solidFill>
-                        <a:srgbClr val="8DA9C4"/>
+                        <a:srgbClr val="A9B8CC"/>
                       </a:solidFill>
                       <a:prstDash val="solid"/>
                       <a:round/>
@@ -10697,7 +10833,7 @@
                     </a:lnL>
                     <a:lnR w="6350" cap="flat" cmpd="sng" algn="ctr">
                       <a:solidFill>
-                        <a:srgbClr val="8DA9C4"/>
+                        <a:srgbClr val="A9B8CC"/>
                       </a:solidFill>
                       <a:prstDash val="solid"/>
                       <a:round/>
@@ -10706,7 +10842,7 @@
                     </a:lnR>
                     <a:lnT w="6350" cap="flat" cmpd="sng" algn="ctr">
                       <a:solidFill>
-                        <a:srgbClr val="8DA9C4"/>
+                        <a:srgbClr val="A9B8CC"/>
                       </a:solidFill>
                       <a:prstDash val="solid"/>
                       <a:round/>
@@ -10715,7 +10851,7 @@
                     </a:lnT>
                     <a:lnB w="6350" cap="flat" cmpd="sng" algn="ctr">
                       <a:solidFill>
-                        <a:srgbClr val="8DA9C4"/>
+                        <a:srgbClr val="A9B8CC"/>
                       </a:solidFill>
                       <a:prstDash val="solid"/>
                       <a:round/>
@@ -10748,7 +10884,7 @@
                   <a:tcPr marL="91440" marR="91440" marT="45720" marB="45720" anchor="ctr">
                     <a:lnL w="6350" cap="flat" cmpd="sng" algn="ctr">
                       <a:solidFill>
-                        <a:srgbClr val="8DA9C4"/>
+                        <a:srgbClr val="A9B8CC"/>
                       </a:solidFill>
                       <a:prstDash val="solid"/>
                       <a:round/>
@@ -10757,7 +10893,7 @@
                     </a:lnL>
                     <a:lnR w="6350" cap="flat" cmpd="sng" algn="ctr">
                       <a:solidFill>
-                        <a:srgbClr val="8DA9C4"/>
+                        <a:srgbClr val="A9B8CC"/>
                       </a:solidFill>
                       <a:prstDash val="solid"/>
                       <a:round/>
@@ -10766,7 +10902,7 @@
                     </a:lnR>
                     <a:lnT w="6350" cap="flat" cmpd="sng" algn="ctr">
                       <a:solidFill>
-                        <a:srgbClr val="8DA9C4"/>
+                        <a:srgbClr val="A9B8CC"/>
                       </a:solidFill>
                       <a:prstDash val="solid"/>
                       <a:round/>
@@ -10775,7 +10911,7 @@
                     </a:lnT>
                     <a:lnB w="6350" cap="flat" cmpd="sng" algn="ctr">
                       <a:solidFill>
-                        <a:srgbClr val="8DA9C4"/>
+                        <a:srgbClr val="A9B8CC"/>
                       </a:solidFill>
                       <a:prstDash val="solid"/>
                       <a:round/>
@@ -10820,7 +10956,7 @@
                   <a:tcPr marL="91440" marR="91440" marT="45720" marB="45720" anchor="ctr">
                     <a:lnL w="6350" cap="flat" cmpd="sng" algn="ctr">
                       <a:solidFill>
-                        <a:srgbClr val="8DA9C4"/>
+                        <a:srgbClr val="A9B8CC"/>
                       </a:solidFill>
                       <a:prstDash val="solid"/>
                       <a:round/>
@@ -10829,7 +10965,7 @@
                     </a:lnL>
                     <a:lnR w="6350" cap="flat" cmpd="sng" algn="ctr">
                       <a:solidFill>
-                        <a:srgbClr val="8DA9C4"/>
+                        <a:srgbClr val="A9B8CC"/>
                       </a:solidFill>
                       <a:prstDash val="solid"/>
                       <a:round/>
@@ -10838,7 +10974,7 @@
                     </a:lnR>
                     <a:lnT w="6350" cap="flat" cmpd="sng" algn="ctr">
                       <a:solidFill>
-                        <a:srgbClr val="8DA9C4"/>
+                        <a:srgbClr val="A9B8CC"/>
                       </a:solidFill>
                       <a:prstDash val="solid"/>
                       <a:round/>
@@ -10847,7 +10983,7 @@
                     </a:lnT>
                     <a:lnB w="6350" cap="flat" cmpd="sng" algn="ctr">
                       <a:solidFill>
-                        <a:srgbClr val="8DA9C4"/>
+                        <a:srgbClr val="A9B8CC"/>
                       </a:solidFill>
                       <a:prstDash val="solid"/>
                       <a:round/>
@@ -10892,7 +11028,7 @@
                   <a:tcPr marL="91440" marR="91440" marT="45720" marB="45720" anchor="ctr">
                     <a:lnL w="6350" cap="flat" cmpd="sng" algn="ctr">
                       <a:solidFill>
-                        <a:srgbClr val="8DA9C4"/>
+                        <a:srgbClr val="A9B8CC"/>
                       </a:solidFill>
                       <a:prstDash val="solid"/>
                       <a:round/>
@@ -10901,7 +11037,7 @@
                     </a:lnL>
                     <a:lnR w="6350" cap="flat" cmpd="sng" algn="ctr">
                       <a:solidFill>
-                        <a:srgbClr val="8DA9C4"/>
+                        <a:srgbClr val="A9B8CC"/>
                       </a:solidFill>
                       <a:prstDash val="solid"/>
                       <a:round/>
@@ -10910,7 +11046,7 @@
                     </a:lnR>
                     <a:lnT w="6350" cap="flat" cmpd="sng" algn="ctr">
                       <a:solidFill>
-                        <a:srgbClr val="8DA9C4"/>
+                        <a:srgbClr val="A9B8CC"/>
                       </a:solidFill>
                       <a:prstDash val="solid"/>
                       <a:round/>
@@ -10919,7 +11055,7 @@
                     </a:lnT>
                     <a:lnB w="6350" cap="flat" cmpd="sng" algn="ctr">
                       <a:solidFill>
-                        <a:srgbClr val="8DA9C4"/>
+                        <a:srgbClr val="A9B8CC"/>
                       </a:solidFill>
                       <a:prstDash val="solid"/>
                       <a:round/>
@@ -10964,7 +11100,7 @@
                   <a:tcPr marL="91440" marR="91440" marT="45720" marB="45720" anchor="ctr">
                     <a:lnL w="6350" cap="flat" cmpd="sng" algn="ctr">
                       <a:solidFill>
-                        <a:srgbClr val="8DA9C4"/>
+                        <a:srgbClr val="A9B8CC"/>
                       </a:solidFill>
                       <a:prstDash val="solid"/>
                       <a:round/>
@@ -10973,7 +11109,7 @@
                     </a:lnL>
                     <a:lnR w="6350" cap="flat" cmpd="sng" algn="ctr">
                       <a:solidFill>
-                        <a:srgbClr val="8DA9C4"/>
+                        <a:srgbClr val="A9B8CC"/>
                       </a:solidFill>
                       <a:prstDash val="solid"/>
                       <a:round/>
@@ -10982,7 +11118,7 @@
                     </a:lnR>
                     <a:lnT w="6350" cap="flat" cmpd="sng" algn="ctr">
                       <a:solidFill>
-                        <a:srgbClr val="8DA9C4"/>
+                        <a:srgbClr val="A9B8CC"/>
                       </a:solidFill>
                       <a:prstDash val="solid"/>
                       <a:round/>
@@ -10991,7 +11127,7 @@
                     </a:lnT>
                     <a:lnB w="6350" cap="flat" cmpd="sng" algn="ctr">
                       <a:solidFill>
-                        <a:srgbClr val="8DA9C4"/>
+                        <a:srgbClr val="A9B8CC"/>
                       </a:solidFill>
                       <a:prstDash val="solid"/>
                       <a:round/>
@@ -11024,7 +11160,7 @@
                   <a:tcPr marL="91440" marR="91440" marT="45720" marB="45720" anchor="ctr">
                     <a:lnL w="6350" cap="flat" cmpd="sng" algn="ctr">
                       <a:solidFill>
-                        <a:srgbClr val="8DA9C4"/>
+                        <a:srgbClr val="A9B8CC"/>
                       </a:solidFill>
                       <a:prstDash val="solid"/>
                       <a:round/>
@@ -11033,7 +11169,7 @@
                     </a:lnL>
                     <a:lnR w="6350" cap="flat" cmpd="sng" algn="ctr">
                       <a:solidFill>
-                        <a:srgbClr val="8DA9C4"/>
+                        <a:srgbClr val="A9B8CC"/>
                       </a:solidFill>
                       <a:prstDash val="solid"/>
                       <a:round/>
@@ -11042,7 +11178,7 @@
                     </a:lnR>
                     <a:lnT w="6350" cap="flat" cmpd="sng" algn="ctr">
                       <a:solidFill>
-                        <a:srgbClr val="8DA9C4"/>
+                        <a:srgbClr val="A9B8CC"/>
                       </a:solidFill>
                       <a:prstDash val="solid"/>
                       <a:round/>
@@ -11051,7 +11187,7 @@
                     </a:lnT>
                     <a:lnB w="6350" cap="flat" cmpd="sng" algn="ctr">
                       <a:solidFill>
-                        <a:srgbClr val="8DA9C4"/>
+                        <a:srgbClr val="A9B8CC"/>
                       </a:solidFill>
                       <a:prstDash val="solid"/>
                       <a:round/>
@@ -11096,7 +11232,7 @@
                   <a:tcPr marL="91440" marR="91440" marT="45720" marB="45720" anchor="ctr">
                     <a:lnL w="6350" cap="flat" cmpd="sng" algn="ctr">
                       <a:solidFill>
-                        <a:srgbClr val="8DA9C4"/>
+                        <a:srgbClr val="A9B8CC"/>
                       </a:solidFill>
                       <a:prstDash val="solid"/>
                       <a:round/>
@@ -11105,7 +11241,7 @@
                     </a:lnL>
                     <a:lnR w="6350" cap="flat" cmpd="sng" algn="ctr">
                       <a:solidFill>
-                        <a:srgbClr val="8DA9C4"/>
+                        <a:srgbClr val="A9B8CC"/>
                       </a:solidFill>
                       <a:prstDash val="solid"/>
                       <a:round/>
@@ -11114,7 +11250,7 @@
                     </a:lnR>
                     <a:lnT w="6350" cap="flat" cmpd="sng" algn="ctr">
                       <a:solidFill>
-                        <a:srgbClr val="8DA9C4"/>
+                        <a:srgbClr val="A9B8CC"/>
                       </a:solidFill>
                       <a:prstDash val="solid"/>
                       <a:round/>
@@ -11123,7 +11259,7 @@
                     </a:lnT>
                     <a:lnB w="6350" cap="flat" cmpd="sng" algn="ctr">
                       <a:solidFill>
-                        <a:srgbClr val="8DA9C4"/>
+                        <a:srgbClr val="A9B8CC"/>
                       </a:solidFill>
                       <a:prstDash val="solid"/>
                       <a:round/>
@@ -11168,7 +11304,7 @@
                   <a:tcPr marL="91440" marR="91440" marT="45720" marB="45720" anchor="ctr">
                     <a:lnL w="6350" cap="flat" cmpd="sng" algn="ctr">
                       <a:solidFill>
-                        <a:srgbClr val="8DA9C4"/>
+                        <a:srgbClr val="A9B8CC"/>
                       </a:solidFill>
                       <a:prstDash val="solid"/>
                       <a:round/>
@@ -11177,7 +11313,7 @@
                     </a:lnL>
                     <a:lnR w="6350" cap="flat" cmpd="sng" algn="ctr">
                       <a:solidFill>
-                        <a:srgbClr val="8DA9C4"/>
+                        <a:srgbClr val="A9B8CC"/>
                       </a:solidFill>
                       <a:prstDash val="solid"/>
                       <a:round/>
@@ -11186,7 +11322,7 @@
                     </a:lnR>
                     <a:lnT w="6350" cap="flat" cmpd="sng" algn="ctr">
                       <a:solidFill>
-                        <a:srgbClr val="8DA9C4"/>
+                        <a:srgbClr val="A9B8CC"/>
                       </a:solidFill>
                       <a:prstDash val="solid"/>
                       <a:round/>
@@ -11195,7 +11331,7 @@
                     </a:lnT>
                     <a:lnB w="6350" cap="flat" cmpd="sng" algn="ctr">
                       <a:solidFill>
-                        <a:srgbClr val="8DA9C4"/>
+                        <a:srgbClr val="A9B8CC"/>
                       </a:solidFill>
                       <a:prstDash val="solid"/>
                       <a:round/>
@@ -11240,7 +11376,7 @@
                   <a:tcPr marL="91440" marR="91440" marT="45720" marB="45720" anchor="ctr">
                     <a:lnL w="6350" cap="flat" cmpd="sng" algn="ctr">
                       <a:solidFill>
-                        <a:srgbClr val="8DA9C4"/>
+                        <a:srgbClr val="A9B8CC"/>
                       </a:solidFill>
                       <a:prstDash val="solid"/>
                       <a:round/>
@@ -11249,7 +11385,7 @@
                     </a:lnL>
                     <a:lnR w="6350" cap="flat" cmpd="sng" algn="ctr">
                       <a:solidFill>
-                        <a:srgbClr val="8DA9C4"/>
+                        <a:srgbClr val="A9B8CC"/>
                       </a:solidFill>
                       <a:prstDash val="solid"/>
                       <a:round/>
@@ -11258,7 +11394,7 @@
                     </a:lnR>
                     <a:lnT w="6350" cap="flat" cmpd="sng" algn="ctr">
                       <a:solidFill>
-                        <a:srgbClr val="8DA9C4"/>
+                        <a:srgbClr val="A9B8CC"/>
                       </a:solidFill>
                       <a:prstDash val="solid"/>
                       <a:round/>
@@ -11267,7 +11403,7 @@
                     </a:lnT>
                     <a:lnB w="6350" cap="flat" cmpd="sng" algn="ctr">
                       <a:solidFill>
-                        <a:srgbClr val="8DA9C4"/>
+                        <a:srgbClr val="A9B8CC"/>
                       </a:solidFill>
                       <a:prstDash val="solid"/>
                       <a:round/>
@@ -11283,7 +11419,7 @@
       </p:graphicFrame>
       <p:sp>
         <p:nvSpPr>
-          <p:cNvPr id="5" name="t79"/>
+          <p:cNvPr id="5" name="t82"/>
           <p:cNvSpPr txBox="1"/>
           <p:nvPr/>
         </p:nvSpPr>
@@ -11311,7 +11447,7 @@
                   <a:schemeClr val="accent5"/>
                 </a:solidFill>
               </a:rPr>
-              <a:t>Risk-budget game. Each side picks ε. Payoffs (Blue, Red) and war rate. Red bold = the only equilibrium.</a:t>
+              <a:t>Risk-budget game. Each side picks ε. Payoffs (Blue, Red) and war rate. Gold bold = the only equilibrium.</a:t>
             </a:r>
             <a:endParaRPr lang="en-US" sz="1200" dirty="0"/>
           </a:p>
@@ -11319,7 +11455,7 @@
       </p:sp>
       <p:sp>
         <p:nvSpPr>
-          <p:cNvPr id="6" name="t80"/>
+          <p:cNvPr id="6" name="t83"/>
           <p:cNvSpPr txBox="1"/>
           <p:nvPr/>
         </p:nvSpPr>
@@ -11355,7 +11491,7 @@
       </p:sp>
       <p:sp>
         <p:nvSpPr>
-          <p:cNvPr id="7" name="tk81"/>
+          <p:cNvPr id="7" name="tk84"/>
           <p:cNvSpPr/>
           <p:nvPr/>
         </p:nvSpPr>
@@ -11382,7 +11518,7 @@
       </p:sp>
       <p:sp>
         <p:nvSpPr>
-          <p:cNvPr id="8" name="t82"/>
+          <p:cNvPr id="8" name="t85"/>
           <p:cNvSpPr txBox="1"/>
           <p:nvPr/>
         </p:nvSpPr>
@@ -11483,47 +11619,47 @@
 <file path=ppt/theme/theme1.xml><?xml version="1.0" encoding="utf-8"?>
 <a:theme xmlns:a="http://schemas.openxmlformats.org/drawingml/2006/main" name="Office Theme">
   <a:themeElements>
-    <a:clrScheme name="Gray Zone">
+    <a:clrScheme name="Navy and Gold">
       <a:dk1>
-        <a:srgbClr val="1B2430"/>
+        <a:srgbClr val="1A2233"/>
       </a:dk1>
       <a:lt1>
         <a:srgbClr val="FFFFFF"/>
       </a:lt1>
       <a:dk2>
-        <a:srgbClr val="0B2545"/>
+        <a:srgbClr val="0B1F3A"/>
       </a:dk2>
       <a:lt2>
-        <a:srgbClr val="EEF3F8"/>
+        <a:srgbClr val="F6F1E2"/>
       </a:lt2>
       <a:accent1>
-        <a:srgbClr val="1F4E9C"/>
+        <a:srgbClr val="1D3E72"/>
       </a:accent1>
       <a:accent2>
-        <a:srgbClr val="B23A48"/>
+        <a:srgbClr val="A97C14"/>
       </a:accent2>
       <a:accent3>
-        <a:srgbClr val="E8A33D"/>
+        <a:srgbClr val="D4AF37"/>
       </a:accent3>
       <a:accent4>
-        <a:srgbClr val="13807A"/>
+        <a:srgbClr val="B8901E"/>
       </a:accent4>
       <a:accent5>
-        <a:srgbClr val="6B7A8F"/>
+        <a:srgbClr val="5E6B7D"/>
       </a:accent5>
       <a:accent6>
-        <a:srgbClr val="8DA9C4"/>
+        <a:srgbClr val="A9B8CC"/>
       </a:accent6>
       <a:hlink>
-        <a:srgbClr val="1F4E9C"/>
+        <a:srgbClr val="1D3E72"/>
       </a:hlink>
       <a:folHlink>
-        <a:srgbClr val="6B7A8F"/>
+        <a:srgbClr val="5E6B7D"/>
       </a:folHlink>
     </a:clrScheme>
     <a:fontScheme name="Office">
       <a:majorFont>
-        <a:latin typeface="Cambria"/>
+        <a:latin typeface="Franklin Gothic Medium"/>
         <a:ea typeface=""/>
         <a:cs typeface=""/>
         <a:font script="Jpan" typeface="游ゴシック Light"/>
@@ -11575,7 +11711,7 @@
         <a:font script="Tfng" typeface="Ebrima"/>
       </a:majorFont>
       <a:minorFont>
-        <a:latin typeface="Calibri"/>
+        <a:latin typeface="Franklin Gothic Book"/>
         <a:ea typeface=""/>
         <a:cs typeface=""/>
         <a:font script="Jpan" typeface="游ゴシック"/>

</xml_diff>

<commit_message>
Workshop 1 slides: add program demo slide after the prototype
</commit_message>
<xml_diff>
--- a/deliverables/02-workshop1-slides.pptx
+++ b/deliverables/02-workshop1-slides.pptx
@@ -20,9 +20,10 @@
     <p:sldId id="268" r:id="rId14"/>
     <p:sldId id="269" r:id="rId15"/>
     <p:sldId id="270" r:id="rId16"/>
+    <p:sldId id="271" r:id="rId17"/>
   </p:sldIdLst>
   <p:notesMasterIdLst>
-    <p:notesMasterId r:id="rId17"/>
+    <p:notesMasterId r:id="rId18"/>
   </p:notesMasterIdLst>
   <p:sldSz cx="12192000" cy="6858000"/>
   <p:notesSz cx="6858000" cy="12192000"/>
@@ -121,7 +122,7 @@
   <p:extLst>
     <p:ext uri="{521415D9-36F7-43E2-AB2F-B90AF26B5E84}">
       <p14:sectionLst xmlns:p14="http://schemas.microsoft.com/office/powerpoint/2010/main">
-        <p14:section name="Introduction" id="{9282d63c-ed2b-f63d-cdc8-2f97a052cbf6}">
+        <p14:section name="Introduction" id="{43a48f78-97c9-6f73-faf6-5627464f887b}">
           <p14:sldIdLst>
             <p14:sldId id="256"/>
             <p14:sldId id="257"/>
@@ -129,7 +130,7 @@
             <p14:sldId id="259"/>
           </p14:sldIdLst>
         </p14:section>
-        <p14:section name="Model" id="{bd25269f-1661-4f5a-6aa7-da3c3eb4c495}">
+        <p14:section name="Model" id="{46c9c7fc-40ff-c08f-74a9-bbb5e6ab5fc3}">
           <p14:sldIdLst>
             <p14:sldId id="260"/>
             <p14:sldId id="261"/>
@@ -137,7 +138,7 @@
             <p14:sldId id="263"/>
           </p14:sldIdLst>
         </p14:section>
-        <p14:section name="Results" id="{c9a10fd5-12cc-2eff-cda1-59fcefc87e8b}">
+        <p14:section name="Results" id="{1d3dac37-955d-f611-d1f5-aa9497c44bba}">
           <p14:sldIdLst>
             <p14:sldId id="264"/>
             <p14:sldId id="265"/>
@@ -145,11 +146,12 @@
             <p14:sldId id="267"/>
             <p14:sldId id="268"/>
             <p14:sldId id="269"/>
+            <p14:sldId id="270"/>
           </p14:sldIdLst>
         </p14:section>
-        <p14:section name="Next steps" id="{c7e1926f-d155-18ea-6059-dcf88aca54a2}">
+        <p14:section name="Next steps" id="{56d3b02a-f80f-d046-706a-d461cd78d7e6}">
           <p14:sldIdLst>
-            <p14:sldId id="270"/>
+            <p14:sldId id="271"/>
           </p14:sldIdLst>
         </p14:section>
       </p14:sectionLst>
@@ -1470,7 +1472,7 @@
           <a:p>
             <a:r>
               <a:rPr lang="en-US" dirty="0"/>
-              <a:t>(~60 s) On the left, Blue loosens its risk budget while Red stays moderate. Control rises fast up to about 0.15, then flattens, while war risk keeps rising. On the right, both sides choose a budget. Aggressive is the best reply to anything, for both, so the only equilibrium is aggressive-aggressive, with the highest war rate, 34%. Both would do better at moderate-moderate. Blue gets −144 instead of −151, Red gets 101 instead of 39, and war falls to 20%. That is a prisoner's dilemma. Restraint has to come from repetition or coordination, as in the previous example.</a:t>
+              <a:t>Live demo of the prototype. Switch to the GUI window.</a:t>
             </a:r>
             <a:endParaRPr lang="en-US" dirty="0"/>
           </a:p>
@@ -1558,7 +1560,7 @@
           <a:p>
             <a:r>
               <a:rPr lang="en-US" dirty="0"/>
-              <a:t>(~60 s) Each Blue policy plays three Red policies, 200 games each. The bar is Blue's payoff against its worst opponent. The Nash equilibrium plan has the best worst case, and half the war rate of the MIP best response. Best responses do well against weak opponents but escalate. The safety-first plan is cautious but gives up control. Differences under about 20 points are ties.</a:t>
+              <a:t>(~60 s) On the left, Blue loosens its risk budget while Red stays moderate. Control rises fast up to about 0.15, then flattens, while war risk keeps rising. On the right, both sides choose a budget. Aggressive is the best reply to anything, for both, so the only equilibrium is aggressive-aggressive, with the highest war rate, 34%. Both would do better at moderate-moderate. Blue gets −144 instead of −151, Red gets 101 instead of 39, and war falls to 20%. That is a prisoner's dilemma. Restraint has to come from repetition or coordination, as in the previous example.</a:t>
             </a:r>
             <a:endParaRPr lang="en-US" dirty="0"/>
           </a:p>
@@ -1646,7 +1648,7 @@
           <a:p>
             <a:r>
               <a:rPr lang="en-US" dirty="0"/>
-              <a:t>(~70 s) Robustness here means two numbers, expected payoff over the four weather scenarios, and worst case. On the left, the policy ranking does not change across weather. The top two plans stay on top. Bad weather slightly helps Blue here, because rough seas weaken Red's coast-guard hulls. On the right, of the three redesigns, de-escalation measures are best on average and in the worst case, and cut war about four times. We gave them no cost yet, and they also help Red, so it is a joint gain.</a:t>
+              <a:t>(~60 s) Each Blue policy plays three Red policies, 200 games each. The bar is Blue's payoff against its worst opponent. The Nash equilibrium plan has the best worst case, and half the war rate of the MIP best response. Best responses do well against weak opponents but escalate. The safety-first plan is cautious but gives up control. Differences under about 20 points are ties.</a:t>
             </a:r>
             <a:endParaRPr lang="en-US" dirty="0"/>
           </a:p>
@@ -1734,7 +1736,7 @@
           <a:p>
             <a:r>
               <a:rPr lang="en-US" dirty="0"/>
-              <a:t>(~45 s) Be direct about limits. Left is what the runs support. Right is what they do not show. Values are assumptions, policies look one turn ahead, the war rate depends heavily on a few parameters, and the de-escalation result is partly built in. Sensitivity analysis on V, h, W and mu is the first item for Workshop 2.</a:t>
+              <a:t>(~70 s) Robustness here means two numbers, expected payoff over the four weather scenarios, and worst case. On the left, the policy ranking does not change across weather. The top two plans stay on top. Bad weather slightly helps Blue here, because rough seas weaken Red's coast-guard hulls. On the right, of the three redesigns, de-escalation measures are best on average and in the worst case, and cut war about four times. We gave them no cost yet, and they also help Red, so it is a joint gain.</a:t>
             </a:r>
             <a:endParaRPr lang="en-US" dirty="0"/>
           </a:p>
@@ -1822,7 +1824,7 @@
           <a:p>
             <a:r>
               <a:rPr lang="en-US" dirty="0"/>
-              <a:t>(~45 s) Workshop 2 plan. First the model. Bayesian beliefs, multi-period best response, sensitivity analysis on V, h, W and mu, calendar-based weather from real data, and a movement budget reformulated with considerations for oilers. Then learning. Does a Red agent that learns from repeated play converge, drift toward restraint, or exploit rule-based Blue? Then attacks and defenses. A coast guard blockade at Scarborough and Second Thomas Shoal, jamming, and false contacts are already coded, and we will add a Red attacker that reacts to Blue's posture and test randomized patrols, D1 and D2 as defenses. Last, the designs and their combinations under attack and a long typhoon, with a cost for D3. Thank you. We are happy to take questions.</a:t>
+              <a:t>(~45 s) Be direct about limits. Left is what the runs support. Right is what they do not show. Values are assumptions, policies look one turn ahead, the war rate depends heavily on a few parameters, and the de-escalation result is partly built in. Sensitivity analysis on V, h, W and mu is the first item for Workshop 2.</a:t>
             </a:r>
             <a:endParaRPr lang="en-US" dirty="0"/>
           </a:p>
@@ -1846,6 +1848,94 @@
             <a:fld id="{F7021451-1387-4CA6-816F-3879F97B5CBC}" type="slidenum">
               <a:rPr lang="en-US"/>
               <a:t>15</a:t>
+            </a:fld>
+            <a:endParaRPr lang="en-US"/>
+          </a:p>
+        </p:txBody>
+      </p:sp>
+    </p:spTree>
+    <p:extLst>
+      <p:ext uri="{BB962C8B-B14F-4D97-AF65-F5344CB8AC3E}">
+        <p14:creationId xmlns:p14="http://schemas.microsoft.com/office/powerpoint/2010/main" val="1024086991"/>
+      </p:ext>
+    </p:extLst>
+  </p:cSld>
+  <p:clrMapOvr>
+    <a:masterClrMapping/>
+  </p:clrMapOvr>
+</p:notes>
+</file>
+
+<file path=ppt/notesSlides/notesSlide16.xml><?xml version="1.0" encoding="utf-8"?>
+<p:notes xmlns:a="http://schemas.openxmlformats.org/drawingml/2006/main" xmlns:r="http://schemas.openxmlformats.org/officeDocument/2006/relationships" xmlns:p="http://schemas.openxmlformats.org/presentationml/2006/main">
+  <p:cSld>
+    <p:spTree>
+      <p:nvGrpSpPr>
+        <p:cNvPr id="1" name=""/>
+        <p:cNvGrpSpPr/>
+        <p:nvPr/>
+      </p:nvGrpSpPr>
+      <p:grpSpPr>
+        <a:xfrm>
+          <a:off x="0" y="0"/>
+          <a:ext cx="0" cy="0"/>
+          <a:chOff x="0" y="0"/>
+          <a:chExt cx="0" cy="0"/>
+        </a:xfrm>
+      </p:grpSpPr>
+      <p:sp>
+        <p:nvSpPr>
+          <p:cNvPr id="2" name="Slide Image Placeholder 1"/>
+          <p:cNvSpPr>
+            <a:spLocks noGrp="1" noRot="1" noChangeAspect="1"/>
+          </p:cNvSpPr>
+          <p:nvPr>
+            <p:ph type="sldImg"/>
+          </p:nvPr>
+        </p:nvSpPr>
+        <p:spPr/>
+      </p:sp>
+      <p:sp>
+        <p:nvSpPr>
+          <p:cNvPr id="3" name="Notes Placeholder 2"/>
+          <p:cNvSpPr>
+            <a:spLocks noGrp="1"/>
+          </p:cNvSpPr>
+          <p:nvPr>
+            <p:ph type="body" idx="1"/>
+          </p:nvPr>
+        </p:nvSpPr>
+        <p:spPr/>
+        <p:txBody>
+          <a:bodyPr/>
+          <a:lstStyle/>
+          <a:p>
+            <a:r>
+              <a:rPr lang="en-US" dirty="0"/>
+              <a:t>(~45 s) Workshop 2 plan. First the model. Bayesian beliefs, multi-period best response, sensitivity analysis on V, h, W and mu, calendar-based weather from real data, and a movement budget reformulated with considerations for oilers. Then learning. Does a Red agent that learns from repeated play converge, drift toward restraint, or exploit rule-based Blue? Then attacks and defenses. A coast guard blockade at Scarborough and Second Thomas Shoal, jamming, and false contacts are already coded, and we will add a Red attacker that reacts to Blue's posture and test randomized patrols, D1 and D2 as defenses. Last, the designs and their combinations under attack and a long typhoon, with a cost for D3. Thank you. We are happy to take questions.</a:t>
+            </a:r>
+            <a:endParaRPr lang="en-US" dirty="0"/>
+          </a:p>
+        </p:txBody>
+      </p:sp>
+      <p:sp>
+        <p:nvSpPr>
+          <p:cNvPr id="4" name="Slide Number Placeholder 3"/>
+          <p:cNvSpPr>
+            <a:spLocks noGrp="1"/>
+          </p:cNvSpPr>
+          <p:nvPr>
+            <p:ph type="sldNum" sz="quarter" idx="10"/>
+          </p:nvPr>
+        </p:nvSpPr>
+        <p:spPr/>
+        <p:txBody>
+          <a:bodyPr/>
+          <a:lstStyle/>
+          <a:p>
+            <a:fld id="{F7021451-1387-4CA6-816F-3879F97B5CBC}" type="slidenum">
+              <a:rPr lang="en-US"/>
+              <a:t>16</a:t>
             </a:fld>
             <a:endParaRPr lang="en-US"/>
           </a:p>
@@ -3784,6 +3874,114 @@
                   <a:schemeClr val="tx2"/>
                 </a:solidFill>
               </a:rPr>
+              <a:t>Program demo</a:t>
+            </a:r>
+            <a:endParaRPr lang="en-US" sz="2800" dirty="0"/>
+          </a:p>
+        </p:txBody>
+      </p:sp>
+      <p:sp>
+        <p:nvSpPr>
+          <p:cNvPr id="25" name="Slide Number Placeholder 0"/>
+          <p:cNvSpPr>
+            <a:spLocks noGrp="1"/>
+          </p:cNvSpPr>
+          <p:nvPr>
+            <p:ph type="sldNum" sz="quarter" idx="4294967295"/>
+          </p:nvPr>
+        </p:nvSpPr>
+        <p:spPr>
+          <a:xfrm>
+            <a:off x="11338560" y="6400800"/>
+            <a:ext cx="548640" cy="274320"/>
+          </a:xfrm>
+          <a:prstGeom prst="rect">
+            <a:avLst/>
+          </a:prstGeom>
+          <a:extLst>
+            <a:ext uri="{C572A759-6A51-4108-AA02-DFA0A04FC94B}">
+              <ma14:wrappingTextBoxFlag xmlns:ma14="http://schemas.microsoft.com/office/mac/drawingml/2011/main" val="0"/>
+            </a:ext>
+          </a:extLst>
+        </p:spPr>
+        <p:txBody>
+          <a:bodyPr/>
+          <a:lstStyle>
+            <a:lvl1pPr>
+              <a:defRPr sz="1000">
+                <a:solidFill>
+                  <a:schemeClr val="accent5"/>
+                </a:solidFill>
+              </a:defRPr>
+            </a:lvl1pPr>
+          </a:lstStyle>
+          <a:p>
+            <a:pPr algn="l"/>
+            <a:fld id="{F7021451-1387-4CA6-816F-3879F97B5CBC}" type="slidenum">
+              <a:rPr b="0" lang="en-US"/>
+              <a:t>11</a:t>
+            </a:fld>
+            <a:endParaRPr lang="en-US"/>
+          </a:p>
+        </p:txBody>
+      </p:sp>
+    </p:spTree>
+  </p:cSld>
+  <p:clrMapOvr>
+    <a:masterClrMapping/>
+  </p:clrMapOvr>
+</p:sld>
+</file>
+
+<file path=ppt/slides/slide12.xml><?xml version="1.0" encoding="utf-8"?>
+<p:sld xmlns:a="http://schemas.openxmlformats.org/drawingml/2006/main" xmlns:r="http://schemas.openxmlformats.org/officeDocument/2006/relationships" xmlns:p="http://schemas.openxmlformats.org/presentationml/2006/main">
+  <p:cSld name="Slide 12">
+    <p:spTree>
+      <p:nvGrpSpPr>
+        <p:cNvPr id="1" name=""/>
+        <p:cNvGrpSpPr/>
+        <p:nvPr/>
+      </p:nvGrpSpPr>
+      <p:grpSpPr>
+        <a:xfrm>
+          <a:off x="0" y="0"/>
+          <a:ext cx="0" cy="0"/>
+          <a:chOff x="0" y="0"/>
+          <a:chExt cx="0" cy="0"/>
+        </a:xfrm>
+      </p:grpSpPr>
+      <p:sp>
+        <p:nvSpPr>
+          <p:cNvPr id="2" name="Text 3"/>
+          <p:cNvSpPr/>
+          <p:nvPr>
+            <p:ph idx="103" type="title" hasCustomPrompt="1"/>
+          </p:nvPr>
+        </p:nvSpPr>
+        <p:spPr>
+          <a:xfrm>
+            <a:off x="548640" y="320040"/>
+            <a:ext cx="11064240" cy="731520"/>
+          </a:xfrm>
+          <a:prstGeom prst="rect">
+            <a:avLst/>
+          </a:prstGeom>
+          <a:noFill/>
+          <a:ln/>
+        </p:spPr>
+        <p:txBody>
+          <a:bodyPr wrap="square" rtlCol="0" anchor="ctr"/>
+          <a:lstStyle/>
+          <a:p>
+            <a:pPr indent="0" marL="0">
+              <a:buNone/>
+            </a:pPr>
+            <a:r>
+              <a:rPr lang="en-US" sz="2800" b="1" dirty="0">
+                <a:solidFill>
+                  <a:schemeClr val="tx2"/>
+                </a:solidFill>
+              </a:rPr>
               <a:t>RQ1: more risk buys control, up to a point</a:t>
             </a:r>
             <a:endParaRPr lang="en-US" sz="2800" dirty="0"/>
@@ -3816,7 +4014,7 @@
       </p:pic>
       <p:graphicFrame>
         <p:nvGraphicFramePr>
-          <p:cNvPr id="12" name="riskgame"/>
+          <p:cNvPr id="13" name="riskgame"/>
           <p:cNvGraphicFramePr>
             <a:graphicFrameLocks noGrp="1"/>
           </p:cNvGraphicFramePr>
@@ -5105,268 +5303,6 @@
             <a:pPr algn="l"/>
             <a:fld id="{F7021451-1387-4CA6-816F-3879F97B5CBC}" type="slidenum">
               <a:rPr b="0" lang="en-US"/>
-              <a:t>11</a:t>
-            </a:fld>
-            <a:endParaRPr lang="en-US"/>
-          </a:p>
-        </p:txBody>
-      </p:sp>
-    </p:spTree>
-  </p:cSld>
-  <p:clrMapOvr>
-    <a:masterClrMapping/>
-  </p:clrMapOvr>
-</p:sld>
-</file>
-
-<file path=ppt/slides/slide12.xml><?xml version="1.0" encoding="utf-8"?>
-<p:sld xmlns:a="http://schemas.openxmlformats.org/drawingml/2006/main" xmlns:r="http://schemas.openxmlformats.org/officeDocument/2006/relationships" xmlns:p="http://schemas.openxmlformats.org/presentationml/2006/main">
-  <p:cSld name="Slide 12">
-    <p:spTree>
-      <p:nvGrpSpPr>
-        <p:cNvPr id="1" name=""/>
-        <p:cNvGrpSpPr/>
-        <p:nvPr/>
-      </p:nvGrpSpPr>
-      <p:grpSpPr>
-        <a:xfrm>
-          <a:off x="0" y="0"/>
-          <a:ext cx="0" cy="0"/>
-          <a:chOff x="0" y="0"/>
-          <a:chExt cx="0" cy="0"/>
-        </a:xfrm>
-      </p:grpSpPr>
-      <p:sp>
-        <p:nvSpPr>
-          <p:cNvPr id="2" name="Text 3"/>
-          <p:cNvSpPr/>
-          <p:nvPr>
-            <p:ph idx="103" type="title" hasCustomPrompt="1"/>
-          </p:nvPr>
-        </p:nvSpPr>
-        <p:spPr>
-          <a:xfrm>
-            <a:off x="548640" y="320040"/>
-            <a:ext cx="11064240" cy="731520"/>
-          </a:xfrm>
-          <a:prstGeom prst="rect">
-            <a:avLst/>
-          </a:prstGeom>
-          <a:noFill/>
-          <a:ln/>
-        </p:spPr>
-        <p:txBody>
-          <a:bodyPr wrap="square" rtlCol="0" anchor="ctr"/>
-          <a:lstStyle/>
-          <a:p>
-            <a:pPr indent="0" marL="0">
-              <a:buNone/>
-            </a:pPr>
-            <a:r>
-              <a:rPr lang="en-US" sz="2800" b="1" dirty="0">
-                <a:solidFill>
-                  <a:schemeClr val="tx2"/>
-                </a:solidFill>
-              </a:rPr>
-              <a:t>RQ2: the Nash equilibrium plan is the safest bet against any Red</a:t>
-            </a:r>
-            <a:endParaRPr lang="en-US" sz="2800" dirty="0"/>
-          </a:p>
-        </p:txBody>
-      </p:sp>
-      <p:graphicFrame>
-        <p:nvGraphicFramePr>
-          <p:cNvPr id="3" name="rq2chart" descr=""/>
-          <p:cNvGraphicFramePr/>
-          <p:nvPr/>
-        </p:nvGraphicFramePr>
-        <p:xfrm>
-          <a:off x="548640" y="1234440"/>
-          <a:ext cx="6583680" cy="4297680"/>
-        </p:xfrm>
-        <a:graphic xmlns:a="http://schemas.openxmlformats.org/drawingml/2006/main">
-          <a:graphicData uri="http://schemas.openxmlformats.org/drawingml/2006/chart">
-            <c:chart xmlns:c="http://schemas.openxmlformats.org/drawingml/2006/chart" r:id="rId1"/>
-          </a:graphicData>
-        </a:graphic>
-      </p:graphicFrame>
-      <p:sp>
-        <p:nvSpPr>
-          <p:cNvPr id="4" name="t120"/>
-          <p:cNvSpPr txBox="1"/>
-          <p:nvPr/>
-        </p:nvSpPr>
-        <p:spPr>
-          <a:xfrm>
-            <a:off x="7406640" y="1325880"/>
-            <a:ext cx="4206240" cy="4297680"/>
-          </a:xfrm>
-          <a:prstGeom prst="rect">
-            <a:avLst/>
-          </a:prstGeom>
-          <a:noFill/>
-          <a:ln/>
-        </p:spPr>
-        <p:txBody>
-          <a:bodyPr wrap="square" lIns="0" tIns="0" rIns="0" bIns="0" rtlCol="0" anchor="t"/>
-          <a:lstStyle/>
-          <a:p>
-            <a:pPr marL="342900" indent="-342900">
-              <a:spcAft>
-                <a:spcPts val="600"/>
-              </a:spcAft>
-              <a:buSzPct val="100000"/>
-              <a:buChar char="•"/>
-            </a:pPr>
-            <a:r>
-              <a:rPr lang="en-US" sz="1600" b="1" dirty="0">
-                <a:solidFill>
-                  <a:schemeClr val="accent4"/>
-                </a:solidFill>
-              </a:rPr>
-              <a:t>Nash equilibrium plan </a:t>
-            </a:r>
-            <a:pPr indent="0" marL="0">
-              <a:buNone/>
-            </a:pPr>
-            <a:r>
-              <a:rPr lang="en-US" sz="1600" dirty="0">
-                <a:solidFill>
-                  <a:schemeClr val="tx1"/>
-                </a:solidFill>
-              </a:rPr>
-              <a:t>has the best worst case (−116) and half the war rate of the MIP best response against the same opponent (10% vs 20%).</a:t>
-            </a:r>
-            <a:endParaRPr lang="en-US" sz="1600" dirty="0"/>
-          </a:p>
-          <a:p>
-            <a:pPr marL="342900" indent="-342900">
-              <a:spcAft>
-                <a:spcPts val="600"/>
-              </a:spcAft>
-              <a:buSzPct val="100000"/>
-              <a:buChar char="•"/>
-            </a:pPr>
-            <a:r>
-              <a:rPr lang="en-US" sz="1600" b="1" dirty="0">
-                <a:solidFill>
-                  <a:schemeClr val="accent1"/>
-                </a:solidFill>
-              </a:rPr>
-              <a:t>Best responses </a:t>
-            </a:r>
-            <a:pPr indent="0" marL="0">
-              <a:buNone/>
-            </a:pPr>
-            <a:r>
-              <a:rPr lang="en-US" sz="1600" dirty="0">
-                <a:solidFill>
-                  <a:schemeClr val="tx1"/>
-                </a:solidFill>
-              </a:rPr>
-              <a:t>(quick and MIP) win against weak opponents but escalate more.</a:t>
-            </a:r>
-            <a:endParaRPr lang="en-US" sz="1600" dirty="0"/>
-          </a:p>
-          <a:p>
-            <a:pPr marL="342900" indent="-342900">
-              <a:spcAft>
-                <a:spcPts val="600"/>
-              </a:spcAft>
-              <a:buSzPct val="100000"/>
-              <a:buChar char="•"/>
-            </a:pPr>
-            <a:r>
-              <a:rPr lang="en-US" sz="1600" b="1" dirty="0">
-                <a:solidFill>
-                  <a:schemeClr val="tx1"/>
-                </a:solidFill>
-              </a:rPr>
-              <a:t>Safety-first plan </a:t>
-            </a:r>
-            <a:pPr indent="0" marL="0">
-              <a:buNone/>
-            </a:pPr>
-            <a:r>
-              <a:rPr lang="en-US" sz="1600" dirty="0">
-                <a:solidFill>
-                  <a:schemeClr val="tx1"/>
-                </a:solidFill>
-              </a:rPr>
-              <a:t>is the most cautious (war ≤ 8%) but gives up the most control.</a:t>
-            </a:r>
-            <a:endParaRPr lang="en-US" sz="1600" dirty="0"/>
-          </a:p>
-          <a:p>
-            <a:pPr marL="342900" indent="-342900">
-              <a:spcAft>
-                <a:spcPts val="600"/>
-              </a:spcAft>
-              <a:buSzPct val="100000"/>
-              <a:buChar char="•"/>
-            </a:pPr>
-            <a:r>
-              <a:rPr lang="en-US" sz="1600" b="1" dirty="0">
-                <a:solidFill>
-                  <a:schemeClr val="tx1"/>
-                </a:solidFill>
-              </a:rPr>
-              <a:t>Quick vs MIP: </a:t>
-            </a:r>
-            <a:pPr indent="0" marL="0">
-              <a:buNone/>
-            </a:pPr>
-            <a:r>
-              <a:rPr lang="en-US" sz="1600" dirty="0">
-                <a:solidFill>
-                  <a:schemeClr val="tx1"/>
-                </a:solidFill>
-              </a:rPr>
-              <a:t>the quick heuristic matches the MIP 67% of the time but breaks the risk budget 14% of the time.</a:t>
-            </a:r>
-            <a:endParaRPr lang="en-US" sz="1600" dirty="0"/>
-          </a:p>
-        </p:txBody>
-      </p:sp>
-      <p:sp>
-        <p:nvSpPr>
-          <p:cNvPr id="25" name="Slide Number Placeholder 0"/>
-          <p:cNvSpPr>
-            <a:spLocks noGrp="1"/>
-          </p:cNvSpPr>
-          <p:nvPr>
-            <p:ph type="sldNum" sz="quarter" idx="4294967295"/>
-          </p:nvPr>
-        </p:nvSpPr>
-        <p:spPr>
-          <a:xfrm>
-            <a:off x="11338560" y="6400800"/>
-            <a:ext cx="548640" cy="274320"/>
-          </a:xfrm>
-          <a:prstGeom prst="rect">
-            <a:avLst/>
-          </a:prstGeom>
-          <a:extLst>
-            <a:ext uri="{C572A759-6A51-4108-AA02-DFA0A04FC94B}">
-              <ma14:wrappingTextBoxFlag xmlns:ma14="http://schemas.microsoft.com/office/mac/drawingml/2011/main" val="0"/>
-            </a:ext>
-          </a:extLst>
-        </p:spPr>
-        <p:txBody>
-          <a:bodyPr/>
-          <a:lstStyle>
-            <a:lvl1pPr>
-              <a:defRPr sz="1000">
-                <a:solidFill>
-                  <a:schemeClr val="accent5"/>
-                </a:solidFill>
-              </a:defRPr>
-            </a:lvl1pPr>
-          </a:lstStyle>
-          <a:p>
-            <a:pPr algn="l"/>
-            <a:fld id="{F7021451-1387-4CA6-816F-3879F97B5CBC}" type="slidenum">
-              <a:rPr b="0" lang="en-US"/>
               <a:t>12</a:t>
             </a:fld>
             <a:endParaRPr lang="en-US"/>
@@ -5430,98 +5366,38 @@
                   <a:schemeClr val="tx2"/>
                 </a:solidFill>
               </a:rPr>
-              <a:t>RQ3: the best strategy holds up in bad weather</a:t>
+              <a:t>RQ2: the Nash equilibrium plan is the safest bet against any Red</a:t>
             </a:r>
             <a:endParaRPr lang="en-US" sz="2800" dirty="0"/>
-          </a:p>
-        </p:txBody>
-      </p:sp>
-      <p:pic>
-        <p:nvPicPr>
-          <p:cNvPr id="3" name="img121" descr="/Users/seanbowman/Documents/MIT/Fall26/6.s974/repo/slides/../prototype/results/figures/weather.png">    </p:cNvPr>
-          <p:cNvPicPr>
-            <a:picLocks noChangeAspect="1"/>
-          </p:cNvPicPr>
-          <p:nvPr/>
-        </p:nvPicPr>
-        <p:blipFill>
-          <a:blip r:embed="rId1"/>
-          <a:stretch>
-            <a:fillRect/>
-          </a:stretch>
-        </p:blipFill>
-        <p:spPr>
-          <a:xfrm>
-            <a:off x="548640" y="1234440"/>
-            <a:ext cx="5394960" cy="3593592"/>
-          </a:xfrm>
-          <a:prstGeom prst="rect">
-            <a:avLst/>
-          </a:prstGeom>
-        </p:spPr>
-      </p:pic>
-      <p:sp>
-        <p:nvSpPr>
-          <p:cNvPr id="4" name="t122"/>
-          <p:cNvSpPr txBox="1"/>
-          <p:nvPr/>
-        </p:nvSpPr>
-        <p:spPr>
-          <a:xfrm>
-            <a:off x="548640" y="4892040"/>
-            <a:ext cx="5394960" cy="685800"/>
-          </a:xfrm>
-          <a:prstGeom prst="rect">
-            <a:avLst/>
-          </a:prstGeom>
-          <a:noFill/>
-          <a:ln/>
-        </p:spPr>
-        <p:txBody>
-          <a:bodyPr wrap="square" lIns="0" tIns="0" rIns="0" bIns="0" rtlCol="0" anchor="ctr"/>
-          <a:lstStyle/>
-          <a:p>
-            <a:pPr indent="0" marL="0">
-              <a:buNone/>
-            </a:pPr>
-            <a:r>
-              <a:rPr lang="en-US" sz="1300" dirty="0">
-                <a:solidFill>
-                  <a:schemeClr val="accent5"/>
-                </a:solidFill>
-              </a:rPr>
-              <a:t>Rough seas weaken Red's coast guard hulls and storms pause operations, so most policies do slightly worse in calm seas. The top two plans stay on top in every scenario.</a:t>
-            </a:r>
-            <a:endParaRPr lang="en-US" sz="1300" dirty="0"/>
           </a:p>
         </p:txBody>
       </p:sp>
       <p:graphicFrame>
         <p:nvGraphicFramePr>
-          <p:cNvPr id="5" name="rq3chart" descr=""/>
+          <p:cNvPr id="3" name="rq2chart" descr=""/>
           <p:cNvGraphicFramePr/>
           <p:nvPr/>
         </p:nvGraphicFramePr>
         <p:xfrm>
-          <a:off x="6217920" y="1234440"/>
-          <a:ext cx="5394960" cy="3291840"/>
+          <a:off x="548640" y="1234440"/>
+          <a:ext cx="6583680" cy="4297680"/>
         </p:xfrm>
         <a:graphic xmlns:a="http://schemas.openxmlformats.org/drawingml/2006/main">
           <a:graphicData uri="http://schemas.openxmlformats.org/drawingml/2006/chart">
-            <c:chart xmlns:c="http://schemas.openxmlformats.org/drawingml/2006/chart" r:id="rId2"/>
+            <c:chart xmlns:c="http://schemas.openxmlformats.org/drawingml/2006/chart" r:id="rId1"/>
           </a:graphicData>
         </a:graphic>
       </p:graphicFrame>
       <p:sp>
         <p:nvSpPr>
-          <p:cNvPr id="6" name="t124"/>
+          <p:cNvPr id="4" name="t120"/>
           <p:cNvSpPr txBox="1"/>
           <p:nvPr/>
         </p:nvSpPr>
         <p:spPr>
           <a:xfrm>
-            <a:off x="6217920" y="4572000"/>
-            <a:ext cx="5394960" cy="365760"/>
+            <a:off x="7406640" y="1325880"/>
+            <a:ext cx="4206240" cy="4297680"/>
           </a:xfrm>
           <a:prstGeom prst="rect">
             <a:avLst/>
@@ -5530,82 +5406,81 @@
           <a:ln/>
         </p:spPr>
         <p:txBody>
-          <a:bodyPr wrap="square" lIns="0" tIns="0" rIns="0" bIns="0" rtlCol="0" anchor="ctr"/>
-          <a:lstStyle/>
-          <a:p>
+          <a:bodyPr wrap="square" lIns="0" tIns="0" rIns="0" bIns="0" rtlCol="0" anchor="t"/>
+          <a:lstStyle/>
+          <a:p>
+            <a:pPr marL="342900" indent="-342900">
+              <a:spcAft>
+                <a:spcPts val="600"/>
+              </a:spcAft>
+              <a:buSzPct val="100000"/>
+              <a:buChar char="•"/>
+            </a:pPr>
+            <a:r>
+              <a:rPr lang="en-US" sz="1600" b="1" dirty="0">
+                <a:solidFill>
+                  <a:schemeClr val="accent4"/>
+                </a:solidFill>
+              </a:rPr>
+              <a:t>Nash equilibrium plan </a:t>
+            </a:r>
             <a:pPr indent="0" marL="0">
               <a:buNone/>
             </a:pPr>
             <a:r>
-              <a:rPr lang="en-US" sz="1300" dirty="0">
-                <a:solidFill>
-                  <a:schemeClr val="accent5"/>
-                </a:solidFill>
-              </a:rPr>
-              <a:t>War rate in normal weather is D0 20%, D1 28%, D2 23%, D3 5%. De-escalation measures were given no cost yet.</a:t>
-            </a:r>
-            <a:endParaRPr lang="en-US" sz="1300" dirty="0"/>
-          </a:p>
-        </p:txBody>
-      </p:sp>
-      <p:sp>
-        <p:nvSpPr>
-          <p:cNvPr id="7" name="tk125"/>
-          <p:cNvSpPr/>
-          <p:nvPr/>
-        </p:nvSpPr>
-        <p:spPr>
-          <a:xfrm>
-            <a:off x="548640" y="5715000"/>
-            <a:ext cx="11064240" cy="594360"/>
-          </a:xfrm>
-          <a:prstGeom prst="roundRect">
-            <a:avLst>
-              <a:gd name="adj" fmla="val 12308"/>
-            </a:avLst>
-          </a:prstGeom>
-          <a:solidFill>
-            <a:schemeClr val="bg2"/>
-          </a:solidFill>
-          <a:ln w="12700">
-            <a:solidFill>
-              <a:schemeClr val="accent1"/>
-            </a:solidFill>
-            <a:prstDash val="solid"/>
-          </a:ln>
-        </p:spPr>
-      </p:sp>
-      <p:sp>
-        <p:nvSpPr>
-          <p:cNvPr id="8" name="t126"/>
-          <p:cNvSpPr txBox="1"/>
-          <p:nvPr/>
-        </p:nvSpPr>
-        <p:spPr>
-          <a:xfrm>
-            <a:off x="777240" y="5760720"/>
-            <a:ext cx="10607040" cy="502920"/>
-          </a:xfrm>
-          <a:prstGeom prst="rect">
-            <a:avLst/>
-          </a:prstGeom>
-          <a:noFill/>
-          <a:ln/>
-        </p:spPr>
-        <p:txBody>
-          <a:bodyPr wrap="square" lIns="0" tIns="0" rIns="0" bIns="0" rtlCol="0" anchor="ctr"/>
-          <a:lstStyle/>
-          <a:p>
+              <a:rPr lang="en-US" sz="1600" dirty="0">
+                <a:solidFill>
+                  <a:schemeClr val="tx1"/>
+                </a:solidFill>
+              </a:rPr>
+              <a:t>has the best worst case (−116) and half the war rate of the MIP best response against the same opponent (10% vs 20%).</a:t>
+            </a:r>
+            <a:endParaRPr lang="en-US" sz="1600" dirty="0"/>
+          </a:p>
+          <a:p>
+            <a:pPr marL="342900" indent="-342900">
+              <a:spcAft>
+                <a:spcPts val="600"/>
+              </a:spcAft>
+              <a:buSzPct val="100000"/>
+              <a:buChar char="•"/>
+            </a:pPr>
+            <a:r>
+              <a:rPr lang="en-US" sz="1600" b="1" dirty="0">
+                <a:solidFill>
+                  <a:schemeClr val="accent1"/>
+                </a:solidFill>
+              </a:rPr>
+              <a:t>Best responses </a:t>
+            </a:r>
             <a:pPr indent="0" marL="0">
               <a:buNone/>
             </a:pPr>
             <a:r>
+              <a:rPr lang="en-US" sz="1600" dirty="0">
+                <a:solidFill>
+                  <a:schemeClr val="tx1"/>
+                </a:solidFill>
+              </a:rPr>
+              <a:t>(quick and MIP) win against weak opponents but escalate more.</a:t>
+            </a:r>
+            <a:endParaRPr lang="en-US" sz="1600" dirty="0"/>
+          </a:p>
+          <a:p>
+            <a:pPr marL="342900" indent="-342900">
+              <a:spcAft>
+                <a:spcPts val="600"/>
+              </a:spcAft>
+              <a:buSzPct val="100000"/>
+              <a:buChar char="•"/>
+            </a:pPr>
+            <a:r>
               <a:rPr lang="en-US" sz="1600" b="1" dirty="0">
                 <a:solidFill>
-                  <a:schemeClr val="accent1"/>
-                </a:solidFill>
-              </a:rPr>
-              <a:t>Takeaway  </a:t>
+                  <a:schemeClr val="tx1"/>
+                </a:solidFill>
+              </a:rPr>
+              <a:t>Safety-first plan </a:t>
             </a:r>
             <a:pPr indent="0" marL="0">
               <a:buNone/>
@@ -5616,7 +5491,36 @@
                   <a:schemeClr val="tx1"/>
                 </a:solidFill>
               </a:rPr>
-              <a:t>The plan that is best on average is also best in the worst weather. De-escalation measures are the best design and cut war about 4×.</a:t>
+              <a:t>is the most cautious (war ≤ 8%) but gives up the most control.</a:t>
+            </a:r>
+            <a:endParaRPr lang="en-US" sz="1600" dirty="0"/>
+          </a:p>
+          <a:p>
+            <a:pPr marL="342900" indent="-342900">
+              <a:spcAft>
+                <a:spcPts val="600"/>
+              </a:spcAft>
+              <a:buSzPct val="100000"/>
+              <a:buChar char="•"/>
+            </a:pPr>
+            <a:r>
+              <a:rPr lang="en-US" sz="1600" b="1" dirty="0">
+                <a:solidFill>
+                  <a:schemeClr val="tx1"/>
+                </a:solidFill>
+              </a:rPr>
+              <a:t>Quick vs MIP: </a:t>
+            </a:r>
+            <a:pPr indent="0" marL="0">
+              <a:buNone/>
+            </a:pPr>
+            <a:r>
+              <a:rPr lang="en-US" sz="1600" dirty="0">
+                <a:solidFill>
+                  <a:schemeClr val="tx1"/>
+                </a:solidFill>
+              </a:rPr>
+              <a:t>the quick heuristic matches the MIP 67% of the time but breaks the risk budget 14% of the time.</a:t>
             </a:r>
             <a:endParaRPr lang="en-US" sz="1600" dirty="0"/>
           </a:p>
@@ -5724,32 +5628,146 @@
                   <a:schemeClr val="tx2"/>
                 </a:solidFill>
               </a:rPr>
-              <a:t>What the evidence does and does not show</a:t>
+              <a:t>RQ3: the best strategy holds up in bad weather</a:t>
             </a:r>
             <a:endParaRPr lang="en-US" sz="2800" dirty="0"/>
           </a:p>
         </p:txBody>
       </p:sp>
-      <p:sp>
-        <p:nvSpPr>
-          <p:cNvPr id="3" name="cv127"/>
+      <p:pic>
+        <p:nvPicPr>
+          <p:cNvPr id="3" name="img121" descr="/Users/seanbowman/Documents/MIT/Fall26/6.s974/repo/slides/../prototype/results/figures/weather.png">    </p:cNvPr>
+          <p:cNvPicPr>
+            <a:picLocks noChangeAspect="1"/>
+          </p:cNvPicPr>
+          <p:nvPr/>
+        </p:nvPicPr>
+        <p:blipFill>
+          <a:blip r:embed="rId1"/>
+          <a:stretch>
+            <a:fillRect/>
+          </a:stretch>
+        </p:blipFill>
+        <p:spPr>
+          <a:xfrm>
+            <a:off x="548640" y="1234440"/>
+            <a:ext cx="5394960" cy="3593592"/>
+          </a:xfrm>
+          <a:prstGeom prst="rect">
+            <a:avLst/>
+          </a:prstGeom>
+        </p:spPr>
+      </p:pic>
+      <p:sp>
+        <p:nvSpPr>
+          <p:cNvPr id="4" name="t122"/>
+          <p:cNvSpPr txBox="1"/>
+          <p:nvPr/>
+        </p:nvSpPr>
+        <p:spPr>
+          <a:xfrm>
+            <a:off x="548640" y="4892040"/>
+            <a:ext cx="5394960" cy="685800"/>
+          </a:xfrm>
+          <a:prstGeom prst="rect">
+            <a:avLst/>
+          </a:prstGeom>
+          <a:noFill/>
+          <a:ln/>
+        </p:spPr>
+        <p:txBody>
+          <a:bodyPr wrap="square" lIns="0" tIns="0" rIns="0" bIns="0" rtlCol="0" anchor="ctr"/>
+          <a:lstStyle/>
+          <a:p>
+            <a:pPr indent="0" marL="0">
+              <a:buNone/>
+            </a:pPr>
+            <a:r>
+              <a:rPr lang="en-US" sz="1300" dirty="0">
+                <a:solidFill>
+                  <a:schemeClr val="accent5"/>
+                </a:solidFill>
+              </a:rPr>
+              <a:t>Rough seas weaken Red's coast guard hulls and storms pause operations, so most policies do slightly worse in calm seas. The top two plans stay on top in every scenario.</a:t>
+            </a:r>
+            <a:endParaRPr lang="en-US" sz="1300" dirty="0"/>
+          </a:p>
+        </p:txBody>
+      </p:sp>
+      <p:graphicFrame>
+        <p:nvGraphicFramePr>
+          <p:cNvPr id="5" name="rq3chart" descr=""/>
+          <p:cNvGraphicFramePr/>
+          <p:nvPr/>
+        </p:nvGraphicFramePr>
+        <p:xfrm>
+          <a:off x="6217920" y="1234440"/>
+          <a:ext cx="5394960" cy="3291840"/>
+        </p:xfrm>
+        <a:graphic xmlns:a="http://schemas.openxmlformats.org/drawingml/2006/main">
+          <a:graphicData uri="http://schemas.openxmlformats.org/drawingml/2006/chart">
+            <c:chart xmlns:c="http://schemas.openxmlformats.org/drawingml/2006/chart" r:id="rId2"/>
+          </a:graphicData>
+        </a:graphic>
+      </p:graphicFrame>
+      <p:sp>
+        <p:nvSpPr>
+          <p:cNvPr id="6" name="t124"/>
+          <p:cNvSpPr txBox="1"/>
+          <p:nvPr/>
+        </p:nvSpPr>
+        <p:spPr>
+          <a:xfrm>
+            <a:off x="6217920" y="4572000"/>
+            <a:ext cx="5394960" cy="365760"/>
+          </a:xfrm>
+          <a:prstGeom prst="rect">
+            <a:avLst/>
+          </a:prstGeom>
+          <a:noFill/>
+          <a:ln/>
+        </p:spPr>
+        <p:txBody>
+          <a:bodyPr wrap="square" lIns="0" tIns="0" rIns="0" bIns="0" rtlCol="0" anchor="ctr"/>
+          <a:lstStyle/>
+          <a:p>
+            <a:pPr indent="0" marL="0">
+              <a:buNone/>
+            </a:pPr>
+            <a:r>
+              <a:rPr lang="en-US" sz="1300" dirty="0">
+                <a:solidFill>
+                  <a:schemeClr val="accent5"/>
+                </a:solidFill>
+              </a:rPr>
+              <a:t>War rate in normal weather is D0 20%, D1 28%, D2 23%, D3 5%. De-escalation measures were given no cost yet.</a:t>
+            </a:r>
+            <a:endParaRPr lang="en-US" sz="1300" dirty="0"/>
+          </a:p>
+        </p:txBody>
+      </p:sp>
+      <p:sp>
+        <p:nvSpPr>
+          <p:cNvPr id="7" name="tk125"/>
           <p:cNvSpPr/>
           <p:nvPr/>
         </p:nvSpPr>
         <p:spPr>
           <a:xfrm>
-            <a:off x="548640" y="1280160"/>
-            <a:ext cx="5394960" cy="548640"/>
-          </a:xfrm>
-          <a:prstGeom prst="rect">
-            <a:avLst/>
+            <a:off x="548640" y="5715000"/>
+            <a:ext cx="11064240" cy="594360"/>
+          </a:xfrm>
+          <a:prstGeom prst="roundRect">
+            <a:avLst>
+              <a:gd name="adj" fmla="val 12308"/>
+            </a:avLst>
           </a:prstGeom>
           <a:solidFill>
-            <a:schemeClr val="accent4"/>
+            <a:schemeClr val="bg2"/>
           </a:solidFill>
           <a:ln w="12700">
             <a:solidFill>
-              <a:schemeClr val="accent4"/>
+              <a:schemeClr val="accent1"/>
             </a:solidFill>
             <a:prstDash val="solid"/>
           </a:ln>
@@ -5757,14 +5775,14 @@
       </p:sp>
       <p:sp>
         <p:nvSpPr>
-          <p:cNvPr id="4" name="t128"/>
+          <p:cNvPr id="8" name="t126"/>
           <p:cNvSpPr txBox="1"/>
           <p:nvPr/>
         </p:nvSpPr>
         <p:spPr>
           <a:xfrm>
-            <a:off x="731520" y="1280160"/>
-            <a:ext cx="5029200" cy="548640"/>
+            <a:off x="777240" y="5760720"/>
+            <a:ext cx="10607040" cy="502920"/>
           </a:xfrm>
           <a:prstGeom prst="rect">
             <a:avLst/>
@@ -5780,44 +5798,15 @@
               <a:buNone/>
             </a:pPr>
             <a:r>
-              <a:rPr lang="en-US" sz="1800" b="1" dirty="0">
-                <a:solidFill>
-                  <a:schemeClr val="bg1"/>
-                </a:solidFill>
-              </a:rPr>
-              <a:t>Supported</a:t>
-            </a:r>
-            <a:endParaRPr lang="en-US" sz="1800" dirty="0"/>
-          </a:p>
-        </p:txBody>
-      </p:sp>
-      <p:sp>
-        <p:nvSpPr>
-          <p:cNvPr id="5" name="t129"/>
-          <p:cNvSpPr txBox="1"/>
-          <p:nvPr/>
-        </p:nvSpPr>
-        <p:spPr>
-          <a:xfrm>
-            <a:off x="640080" y="2011680"/>
-            <a:ext cx="5212080" cy="3566160"/>
-          </a:xfrm>
-          <a:prstGeom prst="rect">
-            <a:avLst/>
-          </a:prstGeom>
-          <a:noFill/>
-          <a:ln/>
-        </p:spPr>
-        <p:txBody>
-          <a:bodyPr wrap="square" lIns="0" tIns="0" rIns="0" bIns="0" rtlCol="0" anchor="t"/>
-          <a:lstStyle/>
-          <a:p>
-            <a:pPr marL="342900" indent="-342900">
-              <a:spcAft>
-                <a:spcPts val="600"/>
-              </a:spcAft>
-              <a:buSzPct val="100000"/>
-              <a:buChar char="•"/>
+              <a:rPr lang="en-US" sz="1600" b="1" dirty="0">
+                <a:solidFill>
+                  <a:schemeClr val="accent1"/>
+                </a:solidFill>
+              </a:rPr>
+              <a:t>Takeaway  </a:t>
+            </a:r>
+            <a:pPr indent="0" marL="0">
+              <a:buNone/>
             </a:pPr>
             <a:r>
               <a:rPr lang="en-US" sz="1600" dirty="0">
@@ -5825,252 +5814,7 @@
                   <a:schemeClr val="tx1"/>
                 </a:solidFill>
               </a:rPr>
-              <a:t>Loosening the risk budget has sharply diminishing returns</a:t>
-            </a:r>
-            <a:endParaRPr lang="en-US" sz="1600" dirty="0"/>
-          </a:p>
-          <a:p>
-            <a:pPr marL="342900" indent="-342900">
-              <a:spcAft>
-                <a:spcPts val="600"/>
-              </a:spcAft>
-              <a:buSzPct val="100000"/>
-              <a:buChar char="•"/>
-            </a:pPr>
-            <a:r>
-              <a:rPr lang="en-US" sz="1600" dirty="0">
-                <a:solidFill>
-                  <a:schemeClr val="tx1"/>
-                </a:solidFill>
-              </a:rPr>
-              <a:t>Left alone, both sides loosen their budgets (prisoner's dilemma)</a:t>
-            </a:r>
-            <a:endParaRPr lang="en-US" sz="1600" dirty="0"/>
-          </a:p>
-          <a:p>
-            <a:pPr marL="342900" indent="-342900">
-              <a:spcAft>
-                <a:spcPts val="600"/>
-              </a:spcAft>
-              <a:buSzPct val="100000"/>
-              <a:buChar char="•"/>
-            </a:pPr>
-            <a:r>
-              <a:rPr lang="en-US" sz="1600" dirty="0">
-                <a:solidFill>
-                  <a:schemeClr val="tx1"/>
-                </a:solidFill>
-              </a:rPr>
-              <a:t>Restraint can be an equilibrium of the repeated game</a:t>
-            </a:r>
-            <a:endParaRPr lang="en-US" sz="1600" dirty="0"/>
-          </a:p>
-          <a:p>
-            <a:pPr marL="342900" indent="-342900">
-              <a:spcAft>
-                <a:spcPts val="600"/>
-              </a:spcAft>
-              <a:buSzPct val="100000"/>
-              <a:buChar char="•"/>
-            </a:pPr>
-            <a:r>
-              <a:rPr lang="en-US" sz="1600" dirty="0">
-                <a:solidFill>
-                  <a:schemeClr val="tx1"/>
-                </a:solidFill>
-              </a:rPr>
-              <a:t>The Nash equilibrium plan is the most robust Blue policy here</a:t>
-            </a:r>
-            <a:endParaRPr lang="en-US" sz="1600" dirty="0"/>
-          </a:p>
-          <a:p>
-            <a:pPr marL="342900" indent="-342900">
-              <a:spcAft>
-                <a:spcPts val="600"/>
-              </a:spcAft>
-              <a:buSzPct val="100000"/>
-              <a:buChar char="•"/>
-            </a:pPr>
-            <a:r>
-              <a:rPr lang="en-US" sz="1600" dirty="0">
-                <a:solidFill>
-                  <a:schemeClr val="tx1"/>
-                </a:solidFill>
-              </a:rPr>
-              <a:t>De-escalation measures are a joint gain under every weather scenario</a:t>
-            </a:r>
-            <a:endParaRPr lang="en-US" sz="1600" dirty="0"/>
-          </a:p>
-        </p:txBody>
-      </p:sp>
-      <p:sp>
-        <p:nvSpPr>
-          <p:cNvPr id="6" name="cv130"/>
-          <p:cNvSpPr/>
-          <p:nvPr/>
-        </p:nvSpPr>
-        <p:spPr>
-          <a:xfrm>
-            <a:off x="6217920" y="1280160"/>
-            <a:ext cx="5394960" cy="548640"/>
-          </a:xfrm>
-          <a:prstGeom prst="rect">
-            <a:avLst/>
-          </a:prstGeom>
-          <a:solidFill>
-            <a:schemeClr val="accent2"/>
-          </a:solidFill>
-          <a:ln w="12700">
-            <a:solidFill>
-              <a:schemeClr val="accent2"/>
-            </a:solidFill>
-            <a:prstDash val="solid"/>
-          </a:ln>
-        </p:spPr>
-      </p:sp>
-      <p:sp>
-        <p:nvSpPr>
-          <p:cNvPr id="7" name="t131"/>
-          <p:cNvSpPr txBox="1"/>
-          <p:nvPr/>
-        </p:nvSpPr>
-        <p:spPr>
-          <a:xfrm>
-            <a:off x="6400800" y="1280160"/>
-            <a:ext cx="5029200" cy="548640"/>
-          </a:xfrm>
-          <a:prstGeom prst="rect">
-            <a:avLst/>
-          </a:prstGeom>
-          <a:noFill/>
-          <a:ln/>
-        </p:spPr>
-        <p:txBody>
-          <a:bodyPr wrap="square" lIns="0" tIns="0" rIns="0" bIns="0" rtlCol="0" anchor="ctr"/>
-          <a:lstStyle/>
-          <a:p>
-            <a:pPr indent="0" marL="0">
-              <a:buNone/>
-            </a:pPr>
-            <a:r>
-              <a:rPr lang="en-US" sz="1800" b="1" dirty="0">
-                <a:solidFill>
-                  <a:schemeClr val="bg1"/>
-                </a:solidFill>
-              </a:rPr>
-              <a:t>Not yet shown</a:t>
-            </a:r>
-            <a:endParaRPr lang="en-US" sz="1800" dirty="0"/>
-          </a:p>
-        </p:txBody>
-      </p:sp>
-      <p:sp>
-        <p:nvSpPr>
-          <p:cNvPr id="8" name="t132"/>
-          <p:cNvSpPr txBox="1"/>
-          <p:nvPr/>
-        </p:nvSpPr>
-        <p:spPr>
-          <a:xfrm>
-            <a:off x="6309360" y="2011680"/>
-            <a:ext cx="5212080" cy="3566160"/>
-          </a:xfrm>
-          <a:prstGeom prst="rect">
-            <a:avLst/>
-          </a:prstGeom>
-          <a:noFill/>
-          <a:ln/>
-        </p:spPr>
-        <p:txBody>
-          <a:bodyPr wrap="square" lIns="0" tIns="0" rIns="0" bIns="0" rtlCol="0" anchor="t"/>
-          <a:lstStyle/>
-          <a:p>
-            <a:pPr marL="342900" indent="-342900">
-              <a:spcAft>
-                <a:spcPts val="600"/>
-              </a:spcAft>
-              <a:buSzPct val="100000"/>
-              <a:buChar char="•"/>
-            </a:pPr>
-            <a:r>
-              <a:rPr lang="en-US" sz="1600" dirty="0">
-                <a:solidFill>
-                  <a:schemeClr val="tx1"/>
-                </a:solidFill>
-              </a:rPr>
-              <a:t>All numbers are assumptions, not calibrated to data</a:t>
-            </a:r>
-            <a:endParaRPr lang="en-US" sz="1600" dirty="0"/>
-          </a:p>
-          <a:p>
-            <a:pPr marL="342900" indent="-342900">
-              <a:spcAft>
-                <a:spcPts val="600"/>
-              </a:spcAft>
-              <a:buSzPct val="100000"/>
-              <a:buChar char="•"/>
-            </a:pPr>
-            <a:r>
-              <a:rPr lang="en-US" sz="1600" dirty="0">
-                <a:solidFill>
-                  <a:schemeClr val="tx1"/>
-                </a:solidFill>
-              </a:rPr>
-              <a:t>Policies look only one period ahead</a:t>
-            </a:r>
-            <a:endParaRPr lang="en-US" sz="1600" dirty="0"/>
-          </a:p>
-          <a:p>
-            <a:pPr marL="342900" indent="-342900">
-              <a:spcAft>
-                <a:spcPts val="600"/>
-              </a:spcAft>
-              <a:buSzPct val="100000"/>
-              <a:buChar char="•"/>
-            </a:pPr>
-            <a:r>
-              <a:rPr lang="en-US" sz="1600" dirty="0">
-                <a:solidFill>
-                  <a:schemeClr val="tx1"/>
-                </a:solidFill>
-              </a:rPr>
-              <a:t>War penalty may be too small. The top-payoff policy also has the most wars</a:t>
-            </a:r>
-            <a:endParaRPr lang="en-US" sz="1600" dirty="0"/>
-          </a:p>
-          <a:p>
-            <a:pPr marL="342900" indent="-342900">
-              <a:spcAft>
-                <a:spcPts val="600"/>
-              </a:spcAft>
-              <a:buSzPct val="100000"/>
-              <a:buChar char="•"/>
-            </a:pPr>
-            <a:r>
-              <a:rPr lang="en-US" sz="1600" dirty="0">
-                <a:solidFill>
-                  <a:schemeClr val="tx1"/>
-                </a:solidFill>
-              </a:rPr>
-              <a:t>De-escalation measures have no cost yet, so part of their win is built in</a:t>
-            </a:r>
-            <a:endParaRPr lang="en-US" sz="1600" dirty="0"/>
-          </a:p>
-          <a:p>
-            <a:pPr marL="342900" indent="-342900">
-              <a:spcAft>
-                <a:spcPts val="600"/>
-              </a:spcAft>
-              <a:buSzPct val="100000"/>
-              <a:buChar char="•"/>
-            </a:pPr>
-            <a:r>
-              <a:rPr lang="en-US" sz="1600" dirty="0">
-                <a:solidFill>
-                  <a:schemeClr val="tx1"/>
-                </a:solidFill>
-              </a:rPr>
-              <a:t>Differences under about 20 payoff points are ties</a:t>
+              <a:t>The plan that is best on average is also best in the worst weather. De-escalation measures are the best design and cut war about 4×.</a:t>
             </a:r>
             <a:endParaRPr lang="en-US" sz="1600" dirty="0"/>
           </a:p>
@@ -6178,6 +5922,460 @@
                   <a:schemeClr val="tx2"/>
                 </a:solidFill>
               </a:rPr>
+              <a:t>What the evidence does and does not show</a:t>
+            </a:r>
+            <a:endParaRPr lang="en-US" sz="2800" dirty="0"/>
+          </a:p>
+        </p:txBody>
+      </p:sp>
+      <p:sp>
+        <p:nvSpPr>
+          <p:cNvPr id="3" name="cv127"/>
+          <p:cNvSpPr/>
+          <p:nvPr/>
+        </p:nvSpPr>
+        <p:spPr>
+          <a:xfrm>
+            <a:off x="548640" y="1280160"/>
+            <a:ext cx="5394960" cy="548640"/>
+          </a:xfrm>
+          <a:prstGeom prst="rect">
+            <a:avLst/>
+          </a:prstGeom>
+          <a:solidFill>
+            <a:schemeClr val="accent4"/>
+          </a:solidFill>
+          <a:ln w="12700">
+            <a:solidFill>
+              <a:schemeClr val="accent4"/>
+            </a:solidFill>
+            <a:prstDash val="solid"/>
+          </a:ln>
+        </p:spPr>
+      </p:sp>
+      <p:sp>
+        <p:nvSpPr>
+          <p:cNvPr id="4" name="t128"/>
+          <p:cNvSpPr txBox="1"/>
+          <p:nvPr/>
+        </p:nvSpPr>
+        <p:spPr>
+          <a:xfrm>
+            <a:off x="731520" y="1280160"/>
+            <a:ext cx="5029200" cy="548640"/>
+          </a:xfrm>
+          <a:prstGeom prst="rect">
+            <a:avLst/>
+          </a:prstGeom>
+          <a:noFill/>
+          <a:ln/>
+        </p:spPr>
+        <p:txBody>
+          <a:bodyPr wrap="square" lIns="0" tIns="0" rIns="0" bIns="0" rtlCol="0" anchor="ctr"/>
+          <a:lstStyle/>
+          <a:p>
+            <a:pPr indent="0" marL="0">
+              <a:buNone/>
+            </a:pPr>
+            <a:r>
+              <a:rPr lang="en-US" sz="1800" b="1" dirty="0">
+                <a:solidFill>
+                  <a:schemeClr val="bg1"/>
+                </a:solidFill>
+              </a:rPr>
+              <a:t>Supported</a:t>
+            </a:r>
+            <a:endParaRPr lang="en-US" sz="1800" dirty="0"/>
+          </a:p>
+        </p:txBody>
+      </p:sp>
+      <p:sp>
+        <p:nvSpPr>
+          <p:cNvPr id="5" name="t129"/>
+          <p:cNvSpPr txBox="1"/>
+          <p:nvPr/>
+        </p:nvSpPr>
+        <p:spPr>
+          <a:xfrm>
+            <a:off x="640080" y="2011680"/>
+            <a:ext cx="5212080" cy="3566160"/>
+          </a:xfrm>
+          <a:prstGeom prst="rect">
+            <a:avLst/>
+          </a:prstGeom>
+          <a:noFill/>
+          <a:ln/>
+        </p:spPr>
+        <p:txBody>
+          <a:bodyPr wrap="square" lIns="0" tIns="0" rIns="0" bIns="0" rtlCol="0" anchor="t"/>
+          <a:lstStyle/>
+          <a:p>
+            <a:pPr marL="342900" indent="-342900">
+              <a:spcAft>
+                <a:spcPts val="600"/>
+              </a:spcAft>
+              <a:buSzPct val="100000"/>
+              <a:buChar char="•"/>
+            </a:pPr>
+            <a:r>
+              <a:rPr lang="en-US" sz="1600" dirty="0">
+                <a:solidFill>
+                  <a:schemeClr val="tx1"/>
+                </a:solidFill>
+              </a:rPr>
+              <a:t>Loosening the risk budget has sharply diminishing returns</a:t>
+            </a:r>
+            <a:endParaRPr lang="en-US" sz="1600" dirty="0"/>
+          </a:p>
+          <a:p>
+            <a:pPr marL="342900" indent="-342900">
+              <a:spcAft>
+                <a:spcPts val="600"/>
+              </a:spcAft>
+              <a:buSzPct val="100000"/>
+              <a:buChar char="•"/>
+            </a:pPr>
+            <a:r>
+              <a:rPr lang="en-US" sz="1600" dirty="0">
+                <a:solidFill>
+                  <a:schemeClr val="tx1"/>
+                </a:solidFill>
+              </a:rPr>
+              <a:t>Left alone, both sides loosen their budgets (prisoner's dilemma)</a:t>
+            </a:r>
+            <a:endParaRPr lang="en-US" sz="1600" dirty="0"/>
+          </a:p>
+          <a:p>
+            <a:pPr marL="342900" indent="-342900">
+              <a:spcAft>
+                <a:spcPts val="600"/>
+              </a:spcAft>
+              <a:buSzPct val="100000"/>
+              <a:buChar char="•"/>
+            </a:pPr>
+            <a:r>
+              <a:rPr lang="en-US" sz="1600" dirty="0">
+                <a:solidFill>
+                  <a:schemeClr val="tx1"/>
+                </a:solidFill>
+              </a:rPr>
+              <a:t>Restraint can be an equilibrium of the repeated game</a:t>
+            </a:r>
+            <a:endParaRPr lang="en-US" sz="1600" dirty="0"/>
+          </a:p>
+          <a:p>
+            <a:pPr marL="342900" indent="-342900">
+              <a:spcAft>
+                <a:spcPts val="600"/>
+              </a:spcAft>
+              <a:buSzPct val="100000"/>
+              <a:buChar char="•"/>
+            </a:pPr>
+            <a:r>
+              <a:rPr lang="en-US" sz="1600" dirty="0">
+                <a:solidFill>
+                  <a:schemeClr val="tx1"/>
+                </a:solidFill>
+              </a:rPr>
+              <a:t>The Nash equilibrium plan is the most robust Blue policy here</a:t>
+            </a:r>
+            <a:endParaRPr lang="en-US" sz="1600" dirty="0"/>
+          </a:p>
+          <a:p>
+            <a:pPr marL="342900" indent="-342900">
+              <a:spcAft>
+                <a:spcPts val="600"/>
+              </a:spcAft>
+              <a:buSzPct val="100000"/>
+              <a:buChar char="•"/>
+            </a:pPr>
+            <a:r>
+              <a:rPr lang="en-US" sz="1600" dirty="0">
+                <a:solidFill>
+                  <a:schemeClr val="tx1"/>
+                </a:solidFill>
+              </a:rPr>
+              <a:t>De-escalation measures are a joint gain under every weather scenario</a:t>
+            </a:r>
+            <a:endParaRPr lang="en-US" sz="1600" dirty="0"/>
+          </a:p>
+        </p:txBody>
+      </p:sp>
+      <p:sp>
+        <p:nvSpPr>
+          <p:cNvPr id="6" name="cv130"/>
+          <p:cNvSpPr/>
+          <p:nvPr/>
+        </p:nvSpPr>
+        <p:spPr>
+          <a:xfrm>
+            <a:off x="6217920" y="1280160"/>
+            <a:ext cx="5394960" cy="548640"/>
+          </a:xfrm>
+          <a:prstGeom prst="rect">
+            <a:avLst/>
+          </a:prstGeom>
+          <a:solidFill>
+            <a:schemeClr val="accent2"/>
+          </a:solidFill>
+          <a:ln w="12700">
+            <a:solidFill>
+              <a:schemeClr val="accent2"/>
+            </a:solidFill>
+            <a:prstDash val="solid"/>
+          </a:ln>
+        </p:spPr>
+      </p:sp>
+      <p:sp>
+        <p:nvSpPr>
+          <p:cNvPr id="7" name="t131"/>
+          <p:cNvSpPr txBox="1"/>
+          <p:nvPr/>
+        </p:nvSpPr>
+        <p:spPr>
+          <a:xfrm>
+            <a:off x="6400800" y="1280160"/>
+            <a:ext cx="5029200" cy="548640"/>
+          </a:xfrm>
+          <a:prstGeom prst="rect">
+            <a:avLst/>
+          </a:prstGeom>
+          <a:noFill/>
+          <a:ln/>
+        </p:spPr>
+        <p:txBody>
+          <a:bodyPr wrap="square" lIns="0" tIns="0" rIns="0" bIns="0" rtlCol="0" anchor="ctr"/>
+          <a:lstStyle/>
+          <a:p>
+            <a:pPr indent="0" marL="0">
+              <a:buNone/>
+            </a:pPr>
+            <a:r>
+              <a:rPr lang="en-US" sz="1800" b="1" dirty="0">
+                <a:solidFill>
+                  <a:schemeClr val="bg1"/>
+                </a:solidFill>
+              </a:rPr>
+              <a:t>Not yet shown</a:t>
+            </a:r>
+            <a:endParaRPr lang="en-US" sz="1800" dirty="0"/>
+          </a:p>
+        </p:txBody>
+      </p:sp>
+      <p:sp>
+        <p:nvSpPr>
+          <p:cNvPr id="8" name="t132"/>
+          <p:cNvSpPr txBox="1"/>
+          <p:nvPr/>
+        </p:nvSpPr>
+        <p:spPr>
+          <a:xfrm>
+            <a:off x="6309360" y="2011680"/>
+            <a:ext cx="5212080" cy="3566160"/>
+          </a:xfrm>
+          <a:prstGeom prst="rect">
+            <a:avLst/>
+          </a:prstGeom>
+          <a:noFill/>
+          <a:ln/>
+        </p:spPr>
+        <p:txBody>
+          <a:bodyPr wrap="square" lIns="0" tIns="0" rIns="0" bIns="0" rtlCol="0" anchor="t"/>
+          <a:lstStyle/>
+          <a:p>
+            <a:pPr marL="342900" indent="-342900">
+              <a:spcAft>
+                <a:spcPts val="600"/>
+              </a:spcAft>
+              <a:buSzPct val="100000"/>
+              <a:buChar char="•"/>
+            </a:pPr>
+            <a:r>
+              <a:rPr lang="en-US" sz="1600" dirty="0">
+                <a:solidFill>
+                  <a:schemeClr val="tx1"/>
+                </a:solidFill>
+              </a:rPr>
+              <a:t>All numbers are assumptions, not calibrated to data</a:t>
+            </a:r>
+            <a:endParaRPr lang="en-US" sz="1600" dirty="0"/>
+          </a:p>
+          <a:p>
+            <a:pPr marL="342900" indent="-342900">
+              <a:spcAft>
+                <a:spcPts val="600"/>
+              </a:spcAft>
+              <a:buSzPct val="100000"/>
+              <a:buChar char="•"/>
+            </a:pPr>
+            <a:r>
+              <a:rPr lang="en-US" sz="1600" dirty="0">
+                <a:solidFill>
+                  <a:schemeClr val="tx1"/>
+                </a:solidFill>
+              </a:rPr>
+              <a:t>Policies look only one period ahead</a:t>
+            </a:r>
+            <a:endParaRPr lang="en-US" sz="1600" dirty="0"/>
+          </a:p>
+          <a:p>
+            <a:pPr marL="342900" indent="-342900">
+              <a:spcAft>
+                <a:spcPts val="600"/>
+              </a:spcAft>
+              <a:buSzPct val="100000"/>
+              <a:buChar char="•"/>
+            </a:pPr>
+            <a:r>
+              <a:rPr lang="en-US" sz="1600" dirty="0">
+                <a:solidFill>
+                  <a:schemeClr val="tx1"/>
+                </a:solidFill>
+              </a:rPr>
+              <a:t>War penalty may be too small. The top-payoff policy also has the most wars</a:t>
+            </a:r>
+            <a:endParaRPr lang="en-US" sz="1600" dirty="0"/>
+          </a:p>
+          <a:p>
+            <a:pPr marL="342900" indent="-342900">
+              <a:spcAft>
+                <a:spcPts val="600"/>
+              </a:spcAft>
+              <a:buSzPct val="100000"/>
+              <a:buChar char="•"/>
+            </a:pPr>
+            <a:r>
+              <a:rPr lang="en-US" sz="1600" dirty="0">
+                <a:solidFill>
+                  <a:schemeClr val="tx1"/>
+                </a:solidFill>
+              </a:rPr>
+              <a:t>De-escalation measures have no cost yet, so part of their win is built in</a:t>
+            </a:r>
+            <a:endParaRPr lang="en-US" sz="1600" dirty="0"/>
+          </a:p>
+          <a:p>
+            <a:pPr marL="342900" indent="-342900">
+              <a:spcAft>
+                <a:spcPts val="600"/>
+              </a:spcAft>
+              <a:buSzPct val="100000"/>
+              <a:buChar char="•"/>
+            </a:pPr>
+            <a:r>
+              <a:rPr lang="en-US" sz="1600" dirty="0">
+                <a:solidFill>
+                  <a:schemeClr val="tx1"/>
+                </a:solidFill>
+              </a:rPr>
+              <a:t>Differences under about 20 payoff points are ties</a:t>
+            </a:r>
+            <a:endParaRPr lang="en-US" sz="1600" dirty="0"/>
+          </a:p>
+        </p:txBody>
+      </p:sp>
+      <p:sp>
+        <p:nvSpPr>
+          <p:cNvPr id="25" name="Slide Number Placeholder 0"/>
+          <p:cNvSpPr>
+            <a:spLocks noGrp="1"/>
+          </p:cNvSpPr>
+          <p:nvPr>
+            <p:ph type="sldNum" sz="quarter" idx="4294967295"/>
+          </p:nvPr>
+        </p:nvSpPr>
+        <p:spPr>
+          <a:xfrm>
+            <a:off x="11338560" y="6400800"/>
+            <a:ext cx="548640" cy="274320"/>
+          </a:xfrm>
+          <a:prstGeom prst="rect">
+            <a:avLst/>
+          </a:prstGeom>
+          <a:extLst>
+            <a:ext uri="{C572A759-6A51-4108-AA02-DFA0A04FC94B}">
+              <ma14:wrappingTextBoxFlag xmlns:ma14="http://schemas.microsoft.com/office/mac/drawingml/2011/main" val="0"/>
+            </a:ext>
+          </a:extLst>
+        </p:spPr>
+        <p:txBody>
+          <a:bodyPr/>
+          <a:lstStyle>
+            <a:lvl1pPr>
+              <a:defRPr sz="1000">
+                <a:solidFill>
+                  <a:schemeClr val="accent5"/>
+                </a:solidFill>
+              </a:defRPr>
+            </a:lvl1pPr>
+          </a:lstStyle>
+          <a:p>
+            <a:pPr algn="l"/>
+            <a:fld id="{F7021451-1387-4CA6-816F-3879F97B5CBC}" type="slidenum">
+              <a:rPr b="0" lang="en-US"/>
+              <a:t>15</a:t>
+            </a:fld>
+            <a:endParaRPr lang="en-US"/>
+          </a:p>
+        </p:txBody>
+      </p:sp>
+    </p:spTree>
+  </p:cSld>
+  <p:clrMapOvr>
+    <a:masterClrMapping/>
+  </p:clrMapOvr>
+</p:sld>
+</file>
+
+<file path=ppt/slides/slide16.xml><?xml version="1.0" encoding="utf-8"?>
+<p:sld xmlns:a="http://schemas.openxmlformats.org/drawingml/2006/main" xmlns:r="http://schemas.openxmlformats.org/officeDocument/2006/relationships" xmlns:p="http://schemas.openxmlformats.org/presentationml/2006/main">
+  <p:cSld name="Slide 16">
+    <p:spTree>
+      <p:nvGrpSpPr>
+        <p:cNvPr id="1" name=""/>
+        <p:cNvGrpSpPr/>
+        <p:nvPr/>
+      </p:nvGrpSpPr>
+      <p:grpSpPr>
+        <a:xfrm>
+          <a:off x="0" y="0"/>
+          <a:ext cx="0" cy="0"/>
+          <a:chOff x="0" y="0"/>
+          <a:chExt cx="0" cy="0"/>
+        </a:xfrm>
+      </p:grpSpPr>
+      <p:sp>
+        <p:nvSpPr>
+          <p:cNvPr id="2" name="Text 3"/>
+          <p:cNvSpPr/>
+          <p:nvPr>
+            <p:ph idx="103" type="title" hasCustomPrompt="1"/>
+          </p:nvPr>
+        </p:nvSpPr>
+        <p:spPr>
+          <a:xfrm>
+            <a:off x="548640" y="320040"/>
+            <a:ext cx="11064240" cy="731520"/>
+          </a:xfrm>
+          <a:prstGeom prst="rect">
+            <a:avLst/>
+          </a:prstGeom>
+          <a:noFill/>
+          <a:ln/>
+        </p:spPr>
+        <p:txBody>
+          <a:bodyPr wrap="square" rtlCol="0" anchor="ctr"/>
+          <a:lstStyle/>
+          <a:p>
+            <a:pPr indent="0" marL="0">
+              <a:buNone/>
+            </a:pPr>
+            <a:r>
+              <a:rPr lang="en-US" sz="2800" b="1" dirty="0">
+                <a:solidFill>
+                  <a:schemeClr val="tx2"/>
+                </a:solidFill>
+              </a:rPr>
               <a:t>Plan for Workshop 2</a:t>
             </a:r>
             <a:endParaRPr lang="en-US" sz="2800" dirty="0"/>
@@ -6809,7 +7007,7 @@
             <a:pPr algn="l"/>
             <a:fld id="{F7021451-1387-4CA6-816F-3879F97B5CBC}" type="slidenum">
               <a:rPr b="0" lang="en-US"/>
-              <a:t>15</a:t>
+              <a:t>16</a:t>
             </a:fld>
             <a:endParaRPr lang="en-US"/>
           </a:p>

</xml_diff>

<commit_message>
Workshop 1 slides: final pass and regenerated PDF
</commit_message>
<xml_diff>
--- a/deliverables/02-workshop1-slides.pptx
+++ b/deliverables/02-workshop1-slides.pptx
@@ -122,7 +122,7 @@
   <p:extLst>
     <p:ext uri="{521415D9-36F7-43E2-AB2F-B90AF26B5E84}">
       <p14:sectionLst xmlns:p14="http://schemas.microsoft.com/office/powerpoint/2010/main">
-        <p14:section name="Introduction" id="{43a48f78-97c9-6f73-faf6-5627464f887b}">
+        <p14:section name="Introduction" id="{e5b1afb8-c85a-83fd-9e01-4a2ff87b1295}">
           <p14:sldIdLst>
             <p14:sldId id="256"/>
             <p14:sldId id="257"/>
@@ -130,7 +130,7 @@
             <p14:sldId id="259"/>
           </p14:sldIdLst>
         </p14:section>
-        <p14:section name="Model" id="{46c9c7fc-40ff-c08f-74a9-bbb5e6ab5fc3}">
+        <p14:section name="Model" id="{2af1e415-f00c-c607-ccb5-0e490e569a10}">
           <p14:sldIdLst>
             <p14:sldId id="260"/>
             <p14:sldId id="261"/>
@@ -138,7 +138,7 @@
             <p14:sldId id="263"/>
           </p14:sldIdLst>
         </p14:section>
-        <p14:section name="Results" id="{1d3dac37-955d-f611-d1f5-aa9497c44bba}">
+        <p14:section name="Results" id="{6090939a-2b4d-19a7-2a85-085cafb2a15b}">
           <p14:sldIdLst>
             <p14:sldId id="264"/>
             <p14:sldId id="265"/>
@@ -149,7 +149,7 @@
             <p14:sldId id="270"/>
           </p14:sldIdLst>
         </p14:section>
-        <p14:section name="Next steps" id="{56d3b02a-f80f-d046-706a-d461cd78d7e6}">
+        <p14:section name="Next steps" id="{7f73bb98-cd61-3cda-b78b-9ddbf846542f}">
           <p14:sldIdLst>
             <p14:sldId id="271"/>
           </p14:sldIdLst>
@@ -6390,16 +6390,21 @@
         </p:nvSpPr>
         <p:spPr>
           <a:xfrm>
-            <a:off x="731520" y="1691640"/>
-            <a:ext cx="457200" cy="457200"/>
-          </a:xfrm>
-          <a:prstGeom prst="ellipse">
+            <a:off x="548640" y="1691640"/>
+            <a:ext cx="2560320" cy="73152"/>
+          </a:xfrm>
+          <a:prstGeom prst="rect">
             <a:avLst/>
           </a:prstGeom>
           <a:solidFill>
             <a:schemeClr val="accent1"/>
           </a:solidFill>
-          <a:ln/>
+          <a:ln w="12700">
+            <a:solidFill>
+              <a:schemeClr val="accent1"/>
+            </a:solidFill>
+            <a:prstDash val="solid"/>
+          </a:ln>
         </p:spPr>
       </p:sp>
       <p:sp>
@@ -6518,16 +6523,21 @@
         </p:nvSpPr>
         <p:spPr>
           <a:xfrm>
-            <a:off x="3520440" y="1691640"/>
-            <a:ext cx="457200" cy="457200"/>
-          </a:xfrm>
-          <a:prstGeom prst="ellipse">
+            <a:off x="3337560" y="1691640"/>
+            <a:ext cx="2560320" cy="73152"/>
+          </a:xfrm>
+          <a:prstGeom prst="rect">
             <a:avLst/>
           </a:prstGeom>
           <a:solidFill>
             <a:schemeClr val="accent1"/>
           </a:solidFill>
-          <a:ln/>
+          <a:ln w="12700">
+            <a:solidFill>
+              <a:schemeClr val="accent1"/>
+            </a:solidFill>
+            <a:prstDash val="solid"/>
+          </a:ln>
         </p:spPr>
       </p:sp>
       <p:sp>
@@ -6646,16 +6656,21 @@
         </p:nvSpPr>
         <p:spPr>
           <a:xfrm>
-            <a:off x="6309360" y="1691640"/>
-            <a:ext cx="457200" cy="457200"/>
-          </a:xfrm>
-          <a:prstGeom prst="ellipse">
+            <a:off x="6126480" y="1691640"/>
+            <a:ext cx="2560320" cy="73152"/>
+          </a:xfrm>
+          <a:prstGeom prst="rect">
             <a:avLst/>
           </a:prstGeom>
           <a:solidFill>
             <a:schemeClr val="accent1"/>
           </a:solidFill>
-          <a:ln/>
+          <a:ln w="12700">
+            <a:solidFill>
+              <a:schemeClr val="accent1"/>
+            </a:solidFill>
+            <a:prstDash val="solid"/>
+          </a:ln>
         </p:spPr>
       </p:sp>
       <p:sp>
@@ -6774,16 +6789,21 @@
         </p:nvSpPr>
         <p:spPr>
           <a:xfrm>
-            <a:off x="9098280" y="1691640"/>
-            <a:ext cx="457200" cy="457200"/>
-          </a:xfrm>
-          <a:prstGeom prst="ellipse">
+            <a:off x="8915400" y="1691640"/>
+            <a:ext cx="2560320" cy="73152"/>
+          </a:xfrm>
+          <a:prstGeom prst="rect">
             <a:avLst/>
           </a:prstGeom>
           <a:solidFill>
             <a:schemeClr val="accent1"/>
           </a:solidFill>
-          <a:ln/>
+          <a:ln w="12700">
+            <a:solidFill>
+              <a:schemeClr val="accent1"/>
+            </a:solidFill>
+            <a:prstDash val="solid"/>
+          </a:ln>
         </p:spPr>
       </p:sp>
       <p:sp>

</xml_diff>

<commit_message>
Workshop 1 slides: merge Tate's strategic context into the background slide
</commit_message>
<xml_diff>
--- a/deliverables/02-workshop1-slides.pptx
+++ b/deliverables/02-workshop1-slides.pptx
@@ -122,7 +122,7 @@
   <p:extLst>
     <p:ext uri="{521415D9-36F7-43E2-AB2F-B90AF26B5E84}">
       <p14:sectionLst xmlns:p14="http://schemas.microsoft.com/office/powerpoint/2010/main">
-        <p14:section name="Introduction" id="{e5b1afb8-c85a-83fd-9e01-4a2ff87b1295}">
+        <p14:section name="Introduction" id="{d1ef6113-83bf-6503-2c8f-85fd2393a233}">
           <p14:sldIdLst>
             <p14:sldId id="256"/>
             <p14:sldId id="257"/>
@@ -130,7 +130,7 @@
             <p14:sldId id="259"/>
           </p14:sldIdLst>
         </p14:section>
-        <p14:section name="Model" id="{2af1e415-f00c-c607-ccb5-0e490e569a10}">
+        <p14:section name="Model" id="{5a821b01-8e63-e16a-d204-7677d013c3f2}">
           <p14:sldIdLst>
             <p14:sldId id="260"/>
             <p14:sldId id="261"/>
@@ -138,7 +138,7 @@
             <p14:sldId id="263"/>
           </p14:sldIdLst>
         </p14:section>
-        <p14:section name="Results" id="{6090939a-2b4d-19a7-2a85-085cafb2a15b}">
+        <p14:section name="Results" id="{c337b3ff-b6de-2ca6-ee66-ecf029f13b0d}">
           <p14:sldIdLst>
             <p14:sldId id="264"/>
             <p14:sldId id="265"/>
@@ -149,7 +149,7 @@
             <p14:sldId id="270"/>
           </p14:sldIdLst>
         </p14:section>
-        <p14:section name="Next steps" id="{7f73bb98-cd61-3cda-b78b-9ddbf846542f}">
+        <p14:section name="Next steps" id="{38be4ed2-ee5e-7eaa-55bd-6965fcf7d359}">
           <p14:sldIdLst>
             <p14:sldId id="271"/>
           </p14:sldIdLst>
@@ -2000,7 +2000,7 @@
           <a:p>
             <a:r>
               <a:rPr lang="en-US" dirty="0"/>
-              <a:t>(~45 s) Why we built this. China presses its maritime claims below the threshold of war, with coast guard and militia hulls backed by navy ships, and the U.S. answers with presence and freedom-of-navigation patrols. Incidents, not shots, drive escalation (Helmus 2024; Green 2017). That contest is hard to study directly. Each side's best move depends on the other's, the risk of war is shared, and real encounters cannot be rerun. Existing models each capture a piece. Wasser and colleagues built a structured gray-zone game, Shieh and colleagues a randomized patrol model, Washburn network interdiction, and Schelling the idea of escalation as shared risk. We combine allocation, evolving control and shared escalation risk in one general-sum game with computational rules, so we can compare strategies and designs across thousands of games.</a:t>
+              <a:t>(~40 s) Why we built this. The South China Sea is a major trade route and a contested region. The U.S. operates there to uphold navigational rights and challenge excessive claims, while China works to turn its claims into sustained control with coast guard and militia hulls backed by navy ships. Most of this happens below the threshold of war. A recent example: on October 20, China said it tracked USS Charleston near Sabina Shoal and accused it of entering without permission, while the U.S. called it routine operations in international waters. Our game captures the tradeoff between presence, control and escalation, with two players, Blue and Red. Real encounters cannot be rerun, so a wargame lets us test strategies safely. Existing models each capture a piece, and we combine them in one general-sum game.</a:t>
             </a:r>
             <a:endParaRPr lang="en-US" dirty="0"/>
           </a:p>
@@ -3583,7 +3583,7 @@
       </p:sp>
       <p:pic>
         <p:nvPicPr>
-          <p:cNvPr id="3" name="img111" descr="/Users/seanbowman/Documents/MIT/Fall26/6.s974/repo/slides/../prototype/results/figures/gui_screenshot.png">    </p:cNvPr>
+          <p:cNvPr id="3" name="img107" descr="/Users/seanbowman/Documents/MIT/Fall26/6.s974/repo/slides/../prototype/results/figures/gui_screenshot.png">    </p:cNvPr>
           <p:cNvPicPr>
             <a:picLocks noChangeAspect="1"/>
           </p:cNvPicPr>
@@ -3607,7 +3607,7 @@
       </p:pic>
       <p:sp>
         <p:nvSpPr>
-          <p:cNvPr id="4" name="t112"/>
+          <p:cNvPr id="4" name="t108"/>
           <p:cNvSpPr txBox="1"/>
           <p:nvPr/>
         </p:nvSpPr>
@@ -3990,7 +3990,7 @@
       </p:sp>
       <p:pic>
         <p:nvPicPr>
-          <p:cNvPr id="3" name="img113" descr="/Users/seanbowman/Documents/MIT/Fall26/6.s974/repo/slides/../prototype/results/figures/frontier.png">    </p:cNvPr>
+          <p:cNvPr id="3" name="img109" descr="/Users/seanbowman/Documents/MIT/Fall26/6.s974/repo/slides/../prototype/results/figures/frontier.png">    </p:cNvPr>
           <p:cNvPicPr>
             <a:picLocks noChangeAspect="1"/>
           </p:cNvPicPr>
@@ -5120,7 +5120,7 @@
       </p:graphicFrame>
       <p:sp>
         <p:nvSpPr>
-          <p:cNvPr id="5" name="t115"/>
+          <p:cNvPr id="5" name="t111"/>
           <p:cNvSpPr txBox="1"/>
           <p:nvPr/>
         </p:nvSpPr>
@@ -5156,7 +5156,7 @@
       </p:sp>
       <p:sp>
         <p:nvSpPr>
-          <p:cNvPr id="6" name="t116"/>
+          <p:cNvPr id="6" name="t112"/>
           <p:cNvSpPr txBox="1"/>
           <p:nvPr/>
         </p:nvSpPr>
@@ -5192,7 +5192,7 @@
       </p:sp>
       <p:sp>
         <p:nvSpPr>
-          <p:cNvPr id="7" name="tk117"/>
+          <p:cNvPr id="7" name="tk113"/>
           <p:cNvSpPr/>
           <p:nvPr/>
         </p:nvSpPr>
@@ -5219,7 +5219,7 @@
       </p:sp>
       <p:sp>
         <p:nvSpPr>
-          <p:cNvPr id="8" name="t118"/>
+          <p:cNvPr id="8" name="t114"/>
           <p:cNvSpPr txBox="1"/>
           <p:nvPr/>
         </p:nvSpPr>
@@ -5390,7 +5390,7 @@
       </p:graphicFrame>
       <p:sp>
         <p:nvSpPr>
-          <p:cNvPr id="4" name="t120"/>
+          <p:cNvPr id="4" name="t116"/>
           <p:cNvSpPr txBox="1"/>
           <p:nvPr/>
         </p:nvSpPr>
@@ -5636,7 +5636,7 @@
       </p:sp>
       <p:pic>
         <p:nvPicPr>
-          <p:cNvPr id="3" name="img121" descr="/Users/seanbowman/Documents/MIT/Fall26/6.s974/repo/slides/../prototype/results/figures/weather.png">    </p:cNvPr>
+          <p:cNvPr id="3" name="img117" descr="/Users/seanbowman/Documents/MIT/Fall26/6.s974/repo/slides/../prototype/results/figures/weather.png">    </p:cNvPr>
           <p:cNvPicPr>
             <a:picLocks noChangeAspect="1"/>
           </p:cNvPicPr>
@@ -5660,7 +5660,7 @@
       </p:pic>
       <p:sp>
         <p:nvSpPr>
-          <p:cNvPr id="4" name="t122"/>
+          <p:cNvPr id="4" name="t118"/>
           <p:cNvSpPr txBox="1"/>
           <p:nvPr/>
         </p:nvSpPr>
@@ -5712,7 +5712,7 @@
       </p:graphicFrame>
       <p:sp>
         <p:nvSpPr>
-          <p:cNvPr id="6" name="t124"/>
+          <p:cNvPr id="6" name="t120"/>
           <p:cNvSpPr txBox="1"/>
           <p:nvPr/>
         </p:nvSpPr>
@@ -5748,7 +5748,7 @@
       </p:sp>
       <p:sp>
         <p:nvSpPr>
-          <p:cNvPr id="7" name="tk125"/>
+          <p:cNvPr id="7" name="tk121"/>
           <p:cNvSpPr/>
           <p:nvPr/>
         </p:nvSpPr>
@@ -5775,7 +5775,7 @@
       </p:sp>
       <p:sp>
         <p:nvSpPr>
-          <p:cNvPr id="8" name="t126"/>
+          <p:cNvPr id="8" name="t122"/>
           <p:cNvSpPr txBox="1"/>
           <p:nvPr/>
         </p:nvSpPr>
@@ -5930,7 +5930,7 @@
       </p:sp>
       <p:sp>
         <p:nvSpPr>
-          <p:cNvPr id="3" name="cv127"/>
+          <p:cNvPr id="3" name="cv123"/>
           <p:cNvSpPr/>
           <p:nvPr/>
         </p:nvSpPr>
@@ -5955,7 +5955,7 @@
       </p:sp>
       <p:sp>
         <p:nvSpPr>
-          <p:cNvPr id="4" name="t128"/>
+          <p:cNvPr id="4" name="t124"/>
           <p:cNvSpPr txBox="1"/>
           <p:nvPr/>
         </p:nvSpPr>
@@ -5991,7 +5991,7 @@
       </p:sp>
       <p:sp>
         <p:nvSpPr>
-          <p:cNvPr id="5" name="t129"/>
+          <p:cNvPr id="5" name="t125"/>
           <p:cNvSpPr txBox="1"/>
           <p:nvPr/>
         </p:nvSpPr>
@@ -6103,7 +6103,7 @@
       </p:sp>
       <p:sp>
         <p:nvSpPr>
-          <p:cNvPr id="6" name="cv130"/>
+          <p:cNvPr id="6" name="cv126"/>
           <p:cNvSpPr/>
           <p:nvPr/>
         </p:nvSpPr>
@@ -6128,7 +6128,7 @@
       </p:sp>
       <p:sp>
         <p:nvSpPr>
-          <p:cNvPr id="7" name="t131"/>
+          <p:cNvPr id="7" name="t127"/>
           <p:cNvSpPr txBox="1"/>
           <p:nvPr/>
         </p:nvSpPr>
@@ -6164,7 +6164,7 @@
       </p:sp>
       <p:sp>
         <p:nvSpPr>
-          <p:cNvPr id="8" name="t132"/>
+          <p:cNvPr id="8" name="t128"/>
           <p:cNvSpPr txBox="1"/>
           <p:nvPr/>
         </p:nvSpPr>
@@ -6384,7 +6384,7 @@
       </p:sp>
       <p:sp>
         <p:nvSpPr>
-          <p:cNvPr id="3" name="tp133"/>
+          <p:cNvPr id="3" name="tp129"/>
           <p:cNvSpPr/>
           <p:nvPr/>
         </p:nvSpPr>
@@ -6409,7 +6409,7 @@
       </p:sp>
       <p:sp>
         <p:nvSpPr>
-          <p:cNvPr id="4" name="t134"/>
+          <p:cNvPr id="4" name="t130"/>
           <p:cNvSpPr txBox="1"/>
           <p:nvPr/>
         </p:nvSpPr>
@@ -6445,7 +6445,7 @@
       </p:sp>
       <p:sp>
         <p:nvSpPr>
-          <p:cNvPr id="5" name="t135"/>
+          <p:cNvPr id="5" name="t131"/>
           <p:cNvSpPr txBox="1"/>
           <p:nvPr/>
         </p:nvSpPr>
@@ -6481,7 +6481,7 @@
       </p:sp>
       <p:sp>
         <p:nvSpPr>
-          <p:cNvPr id="6" name="t136"/>
+          <p:cNvPr id="6" name="t132"/>
           <p:cNvSpPr txBox="1"/>
           <p:nvPr/>
         </p:nvSpPr>
@@ -6517,7 +6517,7 @@
       </p:sp>
       <p:sp>
         <p:nvSpPr>
-          <p:cNvPr id="7" name="tp137"/>
+          <p:cNvPr id="7" name="tp133"/>
           <p:cNvSpPr/>
           <p:nvPr/>
         </p:nvSpPr>
@@ -6542,7 +6542,7 @@
       </p:sp>
       <p:sp>
         <p:nvSpPr>
-          <p:cNvPr id="8" name="t138"/>
+          <p:cNvPr id="8" name="t134"/>
           <p:cNvSpPr txBox="1"/>
           <p:nvPr/>
         </p:nvSpPr>
@@ -6578,7 +6578,7 @@
       </p:sp>
       <p:sp>
         <p:nvSpPr>
-          <p:cNvPr id="9" name="t139"/>
+          <p:cNvPr id="9" name="t135"/>
           <p:cNvSpPr txBox="1"/>
           <p:nvPr/>
         </p:nvSpPr>
@@ -6614,7 +6614,7 @@
       </p:sp>
       <p:sp>
         <p:nvSpPr>
-          <p:cNvPr id="10" name="t140"/>
+          <p:cNvPr id="10" name="t136"/>
           <p:cNvSpPr txBox="1"/>
           <p:nvPr/>
         </p:nvSpPr>
@@ -6650,7 +6650,7 @@
       </p:sp>
       <p:sp>
         <p:nvSpPr>
-          <p:cNvPr id="11" name="tp141"/>
+          <p:cNvPr id="11" name="tp137"/>
           <p:cNvSpPr/>
           <p:nvPr/>
         </p:nvSpPr>
@@ -6675,7 +6675,7 @@
       </p:sp>
       <p:sp>
         <p:nvSpPr>
-          <p:cNvPr id="12" name="t142"/>
+          <p:cNvPr id="12" name="t138"/>
           <p:cNvSpPr txBox="1"/>
           <p:nvPr/>
         </p:nvSpPr>
@@ -6711,7 +6711,7 @@
       </p:sp>
       <p:sp>
         <p:nvSpPr>
-          <p:cNvPr id="13" name="t143"/>
+          <p:cNvPr id="13" name="t139"/>
           <p:cNvSpPr txBox="1"/>
           <p:nvPr/>
         </p:nvSpPr>
@@ -6747,7 +6747,7 @@
       </p:sp>
       <p:sp>
         <p:nvSpPr>
-          <p:cNvPr id="14" name="t144"/>
+          <p:cNvPr id="14" name="t140"/>
           <p:cNvSpPr txBox="1"/>
           <p:nvPr/>
         </p:nvSpPr>
@@ -6783,7 +6783,7 @@
       </p:sp>
       <p:sp>
         <p:nvSpPr>
-          <p:cNvPr id="15" name="tp145"/>
+          <p:cNvPr id="15" name="tp141"/>
           <p:cNvSpPr/>
           <p:nvPr/>
         </p:nvSpPr>
@@ -6808,7 +6808,7 @@
       </p:sp>
       <p:sp>
         <p:nvSpPr>
-          <p:cNvPr id="16" name="t146"/>
+          <p:cNvPr id="16" name="t142"/>
           <p:cNvSpPr txBox="1"/>
           <p:nvPr/>
         </p:nvSpPr>
@@ -6844,7 +6844,7 @@
       </p:sp>
       <p:sp>
         <p:nvSpPr>
-          <p:cNvPr id="17" name="t147"/>
+          <p:cNvPr id="17" name="t143"/>
           <p:cNvSpPr txBox="1"/>
           <p:nvPr/>
         </p:nvSpPr>
@@ -6880,7 +6880,7 @@
       </p:sp>
       <p:sp>
         <p:nvSpPr>
-          <p:cNvPr id="18" name="t148"/>
+          <p:cNvPr id="18" name="t144"/>
           <p:cNvSpPr txBox="1"/>
           <p:nvPr/>
         </p:nvSpPr>
@@ -6916,7 +6916,7 @@
       </p:sp>
       <p:sp>
         <p:nvSpPr>
-          <p:cNvPr id="19" name="tk149"/>
+          <p:cNvPr id="19" name="tk145"/>
           <p:cNvSpPr/>
           <p:nvPr/>
         </p:nvSpPr>
@@ -6943,7 +6943,7 @@
       </p:sp>
       <p:sp>
         <p:nvSpPr>
-          <p:cNvPr id="20" name="t150"/>
+          <p:cNvPr id="20" name="t146"/>
           <p:cNvSpPr txBox="1"/>
           <p:nvPr/>
         </p:nvSpPr>
@@ -7098,14 +7098,191 @@
       </p:sp>
       <p:sp>
         <p:nvSpPr>
-          <p:cNvPr id="3" name="wb4"/>
+          <p:cNvPr id="3" name="t4"/>
+          <p:cNvSpPr txBox="1"/>
+          <p:nvPr/>
+        </p:nvSpPr>
+        <p:spPr>
+          <a:xfrm>
+            <a:off x="548640" y="1280160"/>
+            <a:ext cx="6766560" cy="365760"/>
+          </a:xfrm>
+          <a:prstGeom prst="rect">
+            <a:avLst/>
+          </a:prstGeom>
+          <a:noFill/>
+          <a:ln/>
+        </p:spPr>
+        <p:txBody>
+          <a:bodyPr wrap="square" lIns="0" tIns="0" rIns="0" bIns="0" rtlCol="0" anchor="ctr"/>
+          <a:lstStyle/>
+          <a:p>
+            <a:pPr indent="0" marL="0">
+              <a:buNone/>
+            </a:pPr>
+            <a:r>
+              <a:rPr lang="en-US" sz="1800" b="1" dirty="0">
+                <a:solidFill>
+                  <a:schemeClr val="tx2"/>
+                </a:solidFill>
+              </a:rPr>
+              <a:t>Strategic context</a:t>
+            </a:r>
+            <a:endParaRPr lang="en-US" sz="1800" dirty="0"/>
+          </a:p>
+        </p:txBody>
+      </p:sp>
+      <p:sp>
+        <p:nvSpPr>
+          <p:cNvPr id="4" name="t5"/>
+          <p:cNvSpPr txBox="1"/>
+          <p:nvPr/>
+        </p:nvSpPr>
+        <p:spPr>
+          <a:xfrm>
+            <a:off x="548640" y="1691640"/>
+            <a:ext cx="6766560" cy="3886200"/>
+          </a:xfrm>
+          <a:prstGeom prst="rect">
+            <a:avLst/>
+          </a:prstGeom>
+          <a:noFill/>
+          <a:ln/>
+        </p:spPr>
+        <p:txBody>
+          <a:bodyPr wrap="square" lIns="0" tIns="0" rIns="0" bIns="0" rtlCol="0" anchor="t"/>
+          <a:lstStyle/>
+          <a:p>
+            <a:pPr marL="342900" indent="-342900">
+              <a:spcAft>
+                <a:spcPts val="600"/>
+              </a:spcAft>
+              <a:buSzPct val="100000"/>
+              <a:buChar char="•"/>
+            </a:pPr>
+            <a:r>
+              <a:rPr lang="en-US" sz="1350" dirty="0">
+                <a:solidFill>
+                  <a:schemeClr val="tx1"/>
+                </a:solidFill>
+              </a:rPr>
+              <a:t>The South China Sea is a major maritime trade route and a contested strategic region.</a:t>
+            </a:r>
+            <a:endParaRPr lang="en-US" sz="1350" dirty="0"/>
+          </a:p>
+          <a:p>
+            <a:pPr marL="342900" indent="-342900">
+              <a:spcAft>
+                <a:spcPts val="600"/>
+              </a:spcAft>
+              <a:buSzPct val="100000"/>
+              <a:buChar char="•"/>
+            </a:pPr>
+            <a:r>
+              <a:rPr lang="en-US" sz="1350" dirty="0">
+                <a:solidFill>
+                  <a:schemeClr val="tx1"/>
+                </a:solidFill>
+              </a:rPr>
+              <a:t>The United States conducts naval operations to uphold navigational rights and challenge excessive maritime claims.</a:t>
+            </a:r>
+            <a:endParaRPr lang="en-US" sz="1350" dirty="0"/>
+          </a:p>
+          <a:p>
+            <a:pPr marL="342900" indent="-342900">
+              <a:spcAft>
+                <a:spcPts val="600"/>
+              </a:spcAft>
+              <a:buSzPct val="100000"/>
+              <a:buChar char="•"/>
+            </a:pPr>
+            <a:r>
+              <a:rPr lang="en-US" sz="1350" dirty="0">
+                <a:solidFill>
+                  <a:schemeClr val="tx1"/>
+                </a:solidFill>
+              </a:rPr>
+              <a:t>China seeks to turn its maritime claims into sustained control, with persistent coast guard and militia presence backed by navy ships.</a:t>
+            </a:r>
+            <a:endParaRPr lang="en-US" sz="1350" dirty="0"/>
+          </a:p>
+          <a:p>
+            <a:pPr marL="342900" indent="-342900">
+              <a:spcAft>
+                <a:spcPts val="600"/>
+              </a:spcAft>
+              <a:buSzPct val="100000"/>
+              <a:buChar char="•"/>
+            </a:pPr>
+            <a:r>
+              <a:rPr lang="en-US" sz="1350" dirty="0">
+                <a:solidFill>
+                  <a:schemeClr val="tx1"/>
+                </a:solidFill>
+              </a:rPr>
+              <a:t>Much of this competition takes place below the threshold of war.</a:t>
+            </a:r>
+            <a:endParaRPr lang="en-US" sz="1350" dirty="0"/>
+          </a:p>
+          <a:p>
+            <a:pPr marL="342900" indent="-342900">
+              <a:spcAft>
+                <a:spcPts val="600"/>
+              </a:spcAft>
+              <a:buSzPct val="100000"/>
+              <a:buChar char="•"/>
+            </a:pPr>
+            <a:r>
+              <a:rPr lang="en-US" sz="1350" b="1" dirty="0">
+                <a:solidFill>
+                  <a:schemeClr val="accent2"/>
+                </a:solidFill>
+              </a:rPr>
+              <a:t>Recent example. </a:t>
+            </a:r>
+            <a:pPr indent="0" marL="0">
+              <a:buNone/>
+            </a:pPr>
+            <a:r>
+              <a:rPr lang="en-US" sz="1350" dirty="0">
+                <a:solidFill>
+                  <a:schemeClr val="tx1"/>
+                </a:solidFill>
+              </a:rPr>
+              <a:t>On October 20, China reported monitoring USS Charleston near Sabina Shoal and accused it of entering without authorization. The U.S. described the activity as routine operations in international waters (Reuters).</a:t>
+            </a:r>
+            <a:endParaRPr lang="en-US" sz="1350" dirty="0"/>
+          </a:p>
+          <a:p>
+            <a:pPr marL="342900" indent="-342900">
+              <a:spcAft>
+                <a:spcPts val="600"/>
+              </a:spcAft>
+              <a:buSzPct val="100000"/>
+              <a:buChar char="•"/>
+            </a:pPr>
+            <a:r>
+              <a:rPr lang="en-US" sz="1350" dirty="0">
+                <a:solidFill>
+                  <a:schemeClr val="tx1"/>
+                </a:solidFill>
+              </a:rPr>
+              <a:t>The game captures the resulting tradeoff between presence, control and escalation. Players allocate ships and choose whether to patrol or assert. Stronger presence can improve local control, while confrontational encounters can produce incidents that raise tension across the theater. The model simplifies this regional competition into two players, Blue and Red.</a:t>
+            </a:r>
+            <a:endParaRPr lang="en-US" sz="1350" dirty="0"/>
+          </a:p>
+        </p:txBody>
+      </p:sp>
+      <p:sp>
+        <p:nvSpPr>
+          <p:cNvPr id="5" name="wb6"/>
           <p:cNvSpPr/>
           <p:nvPr/>
         </p:nvSpPr>
         <p:spPr>
           <a:xfrm>
-            <a:off x="548640" y="1325880"/>
-            <a:ext cx="2560320" cy="73152"/>
+            <a:off x="7680960" y="1280160"/>
+            <a:ext cx="64008" cy="1298448"/>
           </a:xfrm>
           <a:prstGeom prst="rect">
             <a:avLst/>
@@ -7123,14 +7300,14 @@
       </p:sp>
       <p:sp>
         <p:nvSpPr>
-          <p:cNvPr id="4" name="t5"/>
+          <p:cNvPr id="6" name="t7"/>
           <p:cNvSpPr txBox="1"/>
           <p:nvPr/>
         </p:nvSpPr>
         <p:spPr>
           <a:xfrm>
-            <a:off x="548640" y="1508760"/>
-            <a:ext cx="2560320" cy="411480"/>
+            <a:off x="7909560" y="1280160"/>
+            <a:ext cx="3703320" cy="1325880"/>
           </a:xfrm>
           <a:prstGeom prst="rect">
             <a:avLst/>
@@ -7139,70 +7316,48 @@
           <a:ln/>
         </p:spPr>
         <p:txBody>
-          <a:bodyPr wrap="square" lIns="0" tIns="0" rIns="0" bIns="0" rtlCol="0" anchor="ctr"/>
+          <a:bodyPr wrap="square" lIns="0" tIns="0" rIns="0" bIns="0" rtlCol="0" anchor="t"/>
           <a:lstStyle/>
           <a:p>
             <a:pPr indent="0" marL="0">
               <a:buNone/>
             </a:pPr>
             <a:r>
-              <a:rPr lang="en-US" sz="1800" b="1" dirty="0">
+              <a:rPr lang="en-US" sz="1500" b="1" dirty="0">
                 <a:solidFill>
                   <a:schemeClr val="tx2"/>
                 </a:solidFill>
               </a:rPr>
-              <a:t>The competition</a:t>
-            </a:r>
-            <a:endParaRPr lang="en-US" sz="1800" dirty="0"/>
-          </a:p>
-        </p:txBody>
-      </p:sp>
-      <p:sp>
-        <p:nvSpPr>
-          <p:cNvPr id="5" name="t6"/>
-          <p:cNvSpPr txBox="1"/>
-          <p:nvPr/>
-        </p:nvSpPr>
-        <p:spPr>
-          <a:xfrm>
-            <a:off x="548640" y="2011680"/>
-            <a:ext cx="2560320" cy="3383280"/>
-          </a:xfrm>
-          <a:prstGeom prst="rect">
-            <a:avLst/>
-          </a:prstGeom>
-          <a:noFill/>
-          <a:ln/>
-        </p:spPr>
-        <p:txBody>
-          <a:bodyPr wrap="square" lIns="0" tIns="0" rIns="0" bIns="0" rtlCol="0" anchor="t"/>
-          <a:lstStyle/>
+              <a:t>Why a wargame</a:t>
+            </a:r>
+            <a:endParaRPr lang="en-US" sz="1600" dirty="0"/>
+          </a:p>
           <a:p>
             <a:pPr indent="0" marL="0">
               <a:buNone/>
             </a:pPr>
             <a:r>
-              <a:rPr lang="en-US" sz="1500" dirty="0">
+              <a:rPr lang="en-US" sz="1250" dirty="0">
                 <a:solidFill>
                   <a:schemeClr val="tx1"/>
                 </a:solidFill>
               </a:rPr>
-              <a:t>China presses its claims with persistent coast guard and militia presence backed by navy ships, while avoiding a conventional military response. The U.S. answers with routine presence and freedom-of-navigation patrols. Incidents, not shots, drive escalation.</a:t>
-            </a:r>
-            <a:endParaRPr lang="en-US" sz="1500" dirty="0"/>
-          </a:p>
-        </p:txBody>
-      </p:sp>
-      <p:sp>
-        <p:nvSpPr>
-          <p:cNvPr id="6" name="wb7"/>
+              <a:t>Each side's best move depends on the other's, and the risk of war is shared. Real encounters cannot be rerun or varied on purpose, so a wargame lets us test strategies and force designs without real risk.</a:t>
+            </a:r>
+            <a:endParaRPr lang="en-US" sz="1600" dirty="0"/>
+          </a:p>
+        </p:txBody>
+      </p:sp>
+      <p:sp>
+        <p:nvSpPr>
+          <p:cNvPr id="7" name="wb8"/>
           <p:cNvSpPr/>
           <p:nvPr/>
         </p:nvSpPr>
         <p:spPr>
           <a:xfrm>
-            <a:off x="3337560" y="1325880"/>
-            <a:ext cx="2560320" cy="73152"/>
+            <a:off x="7680960" y="2743200"/>
+            <a:ext cx="64008" cy="1298448"/>
           </a:xfrm>
           <a:prstGeom prst="rect">
             <a:avLst/>
@@ -7220,14 +7375,14 @@
       </p:sp>
       <p:sp>
         <p:nvSpPr>
-          <p:cNvPr id="7" name="t8"/>
+          <p:cNvPr id="8" name="t9"/>
           <p:cNvSpPr txBox="1"/>
           <p:nvPr/>
         </p:nvSpPr>
         <p:spPr>
           <a:xfrm>
-            <a:off x="3337560" y="1508760"/>
-            <a:ext cx="2560320" cy="411480"/>
+            <a:off x="7909560" y="2743200"/>
+            <a:ext cx="3703320" cy="1325880"/>
           </a:xfrm>
           <a:prstGeom prst="rect">
             <a:avLst/>
@@ -7236,57 +7391,35 @@
           <a:ln/>
         </p:spPr>
         <p:txBody>
-          <a:bodyPr wrap="square" lIns="0" tIns="0" rIns="0" bIns="0" rtlCol="0" anchor="ctr"/>
+          <a:bodyPr wrap="square" lIns="0" tIns="0" rIns="0" bIns="0" rtlCol="0" anchor="t"/>
           <a:lstStyle/>
           <a:p>
             <a:pPr indent="0" marL="0">
               <a:buNone/>
             </a:pPr>
             <a:r>
-              <a:rPr lang="en-US" sz="1800" b="1" dirty="0">
+              <a:rPr lang="en-US" sz="1500" b="1" dirty="0">
                 <a:solidFill>
                   <a:schemeClr val="tx2"/>
                 </a:solidFill>
               </a:rPr>
-              <a:t>Why it is hard to study</a:t>
-            </a:r>
-            <a:endParaRPr lang="en-US" sz="1800" dirty="0"/>
-          </a:p>
-        </p:txBody>
-      </p:sp>
-      <p:sp>
-        <p:nvSpPr>
-          <p:cNvPr id="8" name="t9"/>
-          <p:cNvSpPr txBox="1"/>
-          <p:nvPr/>
-        </p:nvSpPr>
-        <p:spPr>
-          <a:xfrm>
-            <a:off x="3337560" y="2011680"/>
-            <a:ext cx="2560320" cy="3383280"/>
-          </a:xfrm>
-          <a:prstGeom prst="rect">
-            <a:avLst/>
-          </a:prstGeom>
-          <a:noFill/>
-          <a:ln/>
-        </p:spPr>
-        <p:txBody>
-          <a:bodyPr wrap="square" lIns="0" tIns="0" rIns="0" bIns="0" rtlCol="0" anchor="t"/>
-          <a:lstStyle/>
+              <a:t>What models exist</a:t>
+            </a:r>
+            <a:endParaRPr lang="en-US" sz="1600" dirty="0"/>
+          </a:p>
           <a:p>
             <a:pPr indent="0" marL="0">
               <a:buNone/>
             </a:pPr>
             <a:r>
-              <a:rPr lang="en-US" sz="1500" dirty="0">
+              <a:rPr lang="en-US" sz="1250" dirty="0">
                 <a:solidFill>
                   <a:schemeClr val="tx1"/>
                 </a:solidFill>
               </a:rPr>
-              <a:t>Each side's best move depends on the other's, and the risk of war is shared. Real encounters cannot be rerun or varied on purpose. A wargame lets us test strategies and force designs without real risk.</a:t>
-            </a:r>
-            <a:endParaRPr lang="en-US" sz="1500" dirty="0"/>
+              <a:t>Gray-zone games with probabilistic adjudication (Wasser 2019), randomized patrols (Shieh 2012), network interdiction (Washburn 1995), and escalation as a shared risk (Schelling 1966).</a:t>
+            </a:r>
+            <a:endParaRPr lang="en-US" sz="1600" dirty="0"/>
           </a:p>
         </p:txBody>
       </p:sp>
@@ -7298,18 +7431,18 @@
         </p:nvSpPr>
         <p:spPr>
           <a:xfrm>
-            <a:off x="6126480" y="1325880"/>
-            <a:ext cx="2560320" cy="73152"/>
+            <a:off x="7680960" y="4206240"/>
+            <a:ext cx="64008" cy="1298448"/>
           </a:xfrm>
           <a:prstGeom prst="rect">
             <a:avLst/>
           </a:prstGeom>
           <a:solidFill>
-            <a:schemeClr val="accent1"/>
+            <a:schemeClr val="accent3"/>
           </a:solidFill>
           <a:ln w="12700">
             <a:solidFill>
-              <a:schemeClr val="accent1"/>
+              <a:schemeClr val="accent3"/>
             </a:solidFill>
             <a:prstDash val="solid"/>
           </a:ln>
@@ -7323,8 +7456,8 @@
         </p:nvSpPr>
         <p:spPr>
           <a:xfrm>
-            <a:off x="6126480" y="1508760"/>
-            <a:ext cx="2560320" cy="411480"/>
+            <a:off x="7909560" y="4206240"/>
+            <a:ext cx="3703320" cy="1325880"/>
           </a:xfrm>
           <a:prstGeom prst="rect">
             <a:avLst/>
@@ -7333,160 +7466,41 @@
           <a:ln/>
         </p:spPr>
         <p:txBody>
-          <a:bodyPr wrap="square" lIns="0" tIns="0" rIns="0" bIns="0" rtlCol="0" anchor="ctr"/>
+          <a:bodyPr wrap="square" lIns="0" tIns="0" rIns="0" bIns="0" rtlCol="0" anchor="t"/>
           <a:lstStyle/>
           <a:p>
             <a:pPr indent="0" marL="0">
               <a:buNone/>
             </a:pPr>
             <a:r>
-              <a:rPr lang="en-US" sz="1800" b="1" dirty="0">
+              <a:rPr lang="en-US" sz="1500" b="1" dirty="0">
                 <a:solidFill>
                   <a:schemeClr val="tx2"/>
                 </a:solidFill>
               </a:rPr>
-              <a:t>What models exist</a:t>
-            </a:r>
-            <a:endParaRPr lang="en-US" sz="1800" dirty="0"/>
-          </a:p>
-        </p:txBody>
-      </p:sp>
-      <p:sp>
-        <p:nvSpPr>
-          <p:cNvPr id="11" name="t12"/>
-          <p:cNvSpPr txBox="1"/>
-          <p:nvPr/>
-        </p:nvSpPr>
-        <p:spPr>
-          <a:xfrm>
-            <a:off x="6126480" y="2011680"/>
-            <a:ext cx="2560320" cy="3383280"/>
-          </a:xfrm>
-          <a:prstGeom prst="rect">
-            <a:avLst/>
-          </a:prstGeom>
-          <a:noFill/>
-          <a:ln/>
-        </p:spPr>
-        <p:txBody>
-          <a:bodyPr wrap="square" lIns="0" tIns="0" rIns="0" bIns="0" rtlCol="0" anchor="t"/>
-          <a:lstStyle/>
+              <a:t>What we add</a:t>
+            </a:r>
+            <a:endParaRPr lang="en-US" sz="1600" dirty="0"/>
+          </a:p>
           <a:p>
             <a:pPr indent="0" marL="0">
               <a:buNone/>
             </a:pPr>
             <a:r>
-              <a:rPr lang="en-US" sz="1500" dirty="0">
+              <a:rPr lang="en-US" sz="1250" dirty="0">
                 <a:solidFill>
                   <a:schemeClr val="tx1"/>
                 </a:solidFill>
               </a:rPr>
-              <a:t>A structured gray-zone game with probabilistic adjudication (Wasser 2019). Randomized Coast Guard patrols (Shieh 2012). Zero-sum network interdiction (Washburn 1995). Escalation as a shared risk (Schelling 1966).</a:t>
-            </a:r>
-            <a:endParaRPr lang="en-US" sz="1500" dirty="0"/>
-          </a:p>
-        </p:txBody>
-      </p:sp>
-      <p:sp>
-        <p:nvSpPr>
-          <p:cNvPr id="12" name="wb13"/>
-          <p:cNvSpPr/>
-          <p:nvPr/>
-        </p:nvSpPr>
-        <p:spPr>
-          <a:xfrm>
-            <a:off x="8915400" y="1325880"/>
-            <a:ext cx="2560320" cy="73152"/>
-          </a:xfrm>
-          <a:prstGeom prst="rect">
-            <a:avLst/>
-          </a:prstGeom>
-          <a:solidFill>
-            <a:schemeClr val="accent2"/>
-          </a:solidFill>
-          <a:ln w="12700">
-            <a:solidFill>
-              <a:schemeClr val="accent2"/>
-            </a:solidFill>
-            <a:prstDash val="solid"/>
-          </a:ln>
-        </p:spPr>
-      </p:sp>
-      <p:sp>
-        <p:nvSpPr>
-          <p:cNvPr id="13" name="t14"/>
-          <p:cNvSpPr txBox="1"/>
-          <p:nvPr/>
-        </p:nvSpPr>
-        <p:spPr>
-          <a:xfrm>
-            <a:off x="8915400" y="1508760"/>
-            <a:ext cx="2560320" cy="411480"/>
-          </a:xfrm>
-          <a:prstGeom prst="rect">
-            <a:avLst/>
-          </a:prstGeom>
-          <a:noFill/>
-          <a:ln/>
-        </p:spPr>
-        <p:txBody>
-          <a:bodyPr wrap="square" lIns="0" tIns="0" rIns="0" bIns="0" rtlCol="0" anchor="ctr"/>
-          <a:lstStyle/>
-          <a:p>
-            <a:pPr indent="0" marL="0">
-              <a:buNone/>
-            </a:pPr>
-            <a:r>
-              <a:rPr lang="en-US" sz="1800" b="1" dirty="0">
-                <a:solidFill>
-                  <a:schemeClr val="tx2"/>
-                </a:solidFill>
-              </a:rPr>
-              <a:t>What we add</a:t>
-            </a:r>
-            <a:endParaRPr lang="en-US" sz="1800" dirty="0"/>
-          </a:p>
-        </p:txBody>
-      </p:sp>
-      <p:sp>
-        <p:nvSpPr>
-          <p:cNvPr id="14" name="t15"/>
-          <p:cNvSpPr txBox="1"/>
-          <p:nvPr/>
-        </p:nvSpPr>
-        <p:spPr>
-          <a:xfrm>
-            <a:off x="8915400" y="2011680"/>
-            <a:ext cx="2560320" cy="3383280"/>
-          </a:xfrm>
-          <a:prstGeom prst="rect">
-            <a:avLst/>
-          </a:prstGeom>
-          <a:noFill/>
-          <a:ln/>
-        </p:spPr>
-        <p:txBody>
-          <a:bodyPr wrap="square" lIns="0" tIns="0" rIns="0" bIns="0" rtlCol="0" anchor="t"/>
-          <a:lstStyle/>
-          <a:p>
-            <a:pPr indent="0" marL="0">
-              <a:buNone/>
-            </a:pPr>
-            <a:r>
-              <a:rPr lang="en-US" sz="1500" dirty="0">
-                <a:solidFill>
-                  <a:schemeClr val="tx1"/>
-                </a:solidFill>
-              </a:rPr>
-              <a:t>Maritime allocation, evolving control and shared escalation risk in one general-sum game. The rules are computational, so we can compare strategies and designs across thousands of games.</a:t>
-            </a:r>
-            <a:endParaRPr lang="en-US" sz="1500" dirty="0"/>
-          </a:p>
-        </p:txBody>
-      </p:sp>
-      <p:sp>
-        <p:nvSpPr>
-          <p:cNvPr id="15" name="tk16"/>
+              <a:t>Maritime allocation, evolving control and shared escalation risk in one general-sum game, with computational rules so we can compare strategies and designs across thousands of games.</a:t>
+            </a:r>
+            <a:endParaRPr lang="en-US" sz="1600" dirty="0"/>
+          </a:p>
+        </p:txBody>
+      </p:sp>
+      <p:sp>
+        <p:nvSpPr>
+          <p:cNvPr id="11" name="tk12"/>
           <p:cNvSpPr/>
           <p:nvPr/>
         </p:nvSpPr>
@@ -7513,7 +7527,7 @@
       </p:sp>
       <p:sp>
         <p:nvSpPr>
-          <p:cNvPr id="16" name="t17"/>
+          <p:cNvPr id="12" name="t13"/>
           <p:cNvSpPr txBox="1"/>
           <p:nvPr/>
         </p:nvSpPr>
@@ -7668,7 +7682,7 @@
       </p:sp>
       <p:pic>
         <p:nvPicPr>
-          <p:cNvPr id="3" name="img18" descr="/Users/seanbowman/Documents/MIT/Fall26/6.s974/repo/slides/../prototype/results/figures/network.png">    </p:cNvPr>
+          <p:cNvPr id="3" name="img14" descr="/Users/seanbowman/Documents/MIT/Fall26/6.s974/repo/slides/../prototype/results/figures/network.png">    </p:cNvPr>
           <p:cNvPicPr>
             <a:picLocks noChangeAspect="1"/>
           </p:cNvPicPr>
@@ -7692,7 +7706,7 @@
       </p:pic>
       <p:sp>
         <p:nvSpPr>
-          <p:cNvPr id="4" name="t19"/>
+          <p:cNvPr id="4" name="t15"/>
           <p:cNvSpPr txBox="1"/>
           <p:nvPr/>
         </p:nvSpPr>
@@ -7728,7 +7742,7 @@
       </p:sp>
       <p:sp>
         <p:nvSpPr>
-          <p:cNvPr id="5" name="t20"/>
+          <p:cNvPr id="5" name="t16"/>
           <p:cNvSpPr txBox="1"/>
           <p:nvPr/>
         </p:nvSpPr>
@@ -8003,7 +8017,7 @@
       </p:sp>
       <p:sp>
         <p:nvSpPr>
-          <p:cNvPr id="3" name="c21"/>
+          <p:cNvPr id="3" name="c17"/>
           <p:cNvSpPr/>
           <p:nvPr/>
         </p:nvSpPr>
@@ -8023,7 +8037,7 @@
       </p:sp>
       <p:sp>
         <p:nvSpPr>
-          <p:cNvPr id="4" name="t22"/>
+          <p:cNvPr id="4" name="t18"/>
           <p:cNvSpPr txBox="1"/>
           <p:nvPr/>
         </p:nvSpPr>
@@ -8059,7 +8073,7 @@
       </p:sp>
       <p:sp>
         <p:nvSpPr>
-          <p:cNvPr id="5" name="t23"/>
+          <p:cNvPr id="5" name="t19"/>
           <p:cNvSpPr txBox="1"/>
           <p:nvPr/>
         </p:nvSpPr>
@@ -8109,7 +8123,7 @@
       </p:sp>
       <p:sp>
         <p:nvSpPr>
-          <p:cNvPr id="6" name="c24"/>
+          <p:cNvPr id="6" name="c20"/>
           <p:cNvSpPr/>
           <p:nvPr/>
         </p:nvSpPr>
@@ -8129,7 +8143,7 @@
       </p:sp>
       <p:sp>
         <p:nvSpPr>
-          <p:cNvPr id="7" name="t25"/>
+          <p:cNvPr id="7" name="t21"/>
           <p:cNvSpPr txBox="1"/>
           <p:nvPr/>
         </p:nvSpPr>
@@ -8165,7 +8179,7 @@
       </p:sp>
       <p:sp>
         <p:nvSpPr>
-          <p:cNvPr id="8" name="t26"/>
+          <p:cNvPr id="8" name="t22"/>
           <p:cNvSpPr txBox="1"/>
           <p:nvPr/>
         </p:nvSpPr>
@@ -8215,7 +8229,7 @@
       </p:sp>
       <p:sp>
         <p:nvSpPr>
-          <p:cNvPr id="9" name="c27"/>
+          <p:cNvPr id="9" name="c23"/>
           <p:cNvSpPr/>
           <p:nvPr/>
         </p:nvSpPr>
@@ -8235,7 +8249,7 @@
       </p:sp>
       <p:sp>
         <p:nvSpPr>
-          <p:cNvPr id="10" name="t28"/>
+          <p:cNvPr id="10" name="t24"/>
           <p:cNvSpPr txBox="1"/>
           <p:nvPr/>
         </p:nvSpPr>
@@ -8271,7 +8285,7 @@
       </p:sp>
       <p:sp>
         <p:nvSpPr>
-          <p:cNvPr id="11" name="t29"/>
+          <p:cNvPr id="11" name="t25"/>
           <p:cNvSpPr txBox="1"/>
           <p:nvPr/>
         </p:nvSpPr>
@@ -9409,7 +9423,7 @@
       </p:sp>
       <p:sp>
         <p:nvSpPr>
-          <p:cNvPr id="3" name="st31"/>
+          <p:cNvPr id="3" name="st27"/>
           <p:cNvSpPr/>
           <p:nvPr/>
         </p:nvSpPr>
@@ -9429,7 +9443,7 @@
       </p:sp>
       <p:sp>
         <p:nvSpPr>
-          <p:cNvPr id="4" name="t32"/>
+          <p:cNvPr id="4" name="t28"/>
           <p:cNvSpPr txBox="1"/>
           <p:nvPr/>
         </p:nvSpPr>
@@ -9465,7 +9479,7 @@
       </p:sp>
       <p:sp>
         <p:nvSpPr>
-          <p:cNvPr id="5" name="t33"/>
+          <p:cNvPr id="5" name="t29"/>
           <p:cNvSpPr txBox="1"/>
           <p:nvPr/>
         </p:nvSpPr>
@@ -9501,7 +9515,7 @@
       </p:sp>
       <p:sp>
         <p:nvSpPr>
-          <p:cNvPr id="6" name="st34"/>
+          <p:cNvPr id="6" name="st30"/>
           <p:cNvSpPr/>
           <p:nvPr/>
         </p:nvSpPr>
@@ -9521,7 +9535,7 @@
       </p:sp>
       <p:sp>
         <p:nvSpPr>
-          <p:cNvPr id="7" name="t35"/>
+          <p:cNvPr id="7" name="t31"/>
           <p:cNvSpPr txBox="1"/>
           <p:nvPr/>
         </p:nvSpPr>
@@ -9557,7 +9571,7 @@
       </p:sp>
       <p:sp>
         <p:nvSpPr>
-          <p:cNvPr id="8" name="t36"/>
+          <p:cNvPr id="8" name="t32"/>
           <p:cNvSpPr txBox="1"/>
           <p:nvPr/>
         </p:nvSpPr>
@@ -9593,7 +9607,7 @@
       </p:sp>
       <p:sp>
         <p:nvSpPr>
-          <p:cNvPr id="9" name="st37"/>
+          <p:cNvPr id="9" name="st33"/>
           <p:cNvSpPr/>
           <p:nvPr/>
         </p:nvSpPr>
@@ -9613,7 +9627,7 @@
       </p:sp>
       <p:sp>
         <p:nvSpPr>
-          <p:cNvPr id="10" name="t38"/>
+          <p:cNvPr id="10" name="t34"/>
           <p:cNvSpPr txBox="1"/>
           <p:nvPr/>
         </p:nvSpPr>
@@ -9649,7 +9663,7 @@
       </p:sp>
       <p:sp>
         <p:nvSpPr>
-          <p:cNvPr id="11" name="t39"/>
+          <p:cNvPr id="11" name="t35"/>
           <p:cNvSpPr txBox="1"/>
           <p:nvPr/>
         </p:nvSpPr>
@@ -9685,7 +9699,7 @@
       </p:sp>
       <p:sp>
         <p:nvSpPr>
-          <p:cNvPr id="12" name="st40"/>
+          <p:cNvPr id="12" name="st36"/>
           <p:cNvSpPr/>
           <p:nvPr/>
         </p:nvSpPr>
@@ -9705,7 +9719,7 @@
       </p:sp>
       <p:sp>
         <p:nvSpPr>
-          <p:cNvPr id="13" name="t41"/>
+          <p:cNvPr id="13" name="t37"/>
           <p:cNvSpPr txBox="1"/>
           <p:nvPr/>
         </p:nvSpPr>
@@ -9741,7 +9755,7 @@
       </p:sp>
       <p:sp>
         <p:nvSpPr>
-          <p:cNvPr id="14" name="t42"/>
+          <p:cNvPr id="14" name="t38"/>
           <p:cNvSpPr txBox="1"/>
           <p:nvPr/>
         </p:nvSpPr>
@@ -9777,7 +9791,7 @@
       </p:sp>
       <p:sp>
         <p:nvSpPr>
-          <p:cNvPr id="15" name="st43"/>
+          <p:cNvPr id="15" name="st39"/>
           <p:cNvSpPr/>
           <p:nvPr/>
         </p:nvSpPr>
@@ -9797,7 +9811,7 @@
       </p:sp>
       <p:sp>
         <p:nvSpPr>
-          <p:cNvPr id="16" name="t44"/>
+          <p:cNvPr id="16" name="t40"/>
           <p:cNvSpPr txBox="1"/>
           <p:nvPr/>
         </p:nvSpPr>
@@ -9833,7 +9847,7 @@
       </p:sp>
       <p:sp>
         <p:nvSpPr>
-          <p:cNvPr id="17" name="t45"/>
+          <p:cNvPr id="17" name="t41"/>
           <p:cNvSpPr txBox="1"/>
           <p:nvPr/>
         </p:nvSpPr>
@@ -9869,7 +9883,7 @@
       </p:sp>
       <p:sp>
         <p:nvSpPr>
-          <p:cNvPr id="18" name="st46"/>
+          <p:cNvPr id="18" name="st42"/>
           <p:cNvSpPr/>
           <p:nvPr/>
         </p:nvSpPr>
@@ -9889,7 +9903,7 @@
       </p:sp>
       <p:sp>
         <p:nvSpPr>
-          <p:cNvPr id="19" name="t47"/>
+          <p:cNvPr id="19" name="t43"/>
           <p:cNvSpPr txBox="1"/>
           <p:nvPr/>
         </p:nvSpPr>
@@ -9925,7 +9939,7 @@
       </p:sp>
       <p:sp>
         <p:nvSpPr>
-          <p:cNvPr id="20" name="t48"/>
+          <p:cNvPr id="20" name="t44"/>
           <p:cNvSpPr txBox="1"/>
           <p:nvPr/>
         </p:nvSpPr>
@@ -9961,7 +9975,7 @@
       </p:sp>
       <p:sp>
         <p:nvSpPr>
-          <p:cNvPr id="21" name="st49"/>
+          <p:cNvPr id="21" name="st45"/>
           <p:cNvSpPr/>
           <p:nvPr/>
         </p:nvSpPr>
@@ -9981,7 +9995,7 @@
       </p:sp>
       <p:sp>
         <p:nvSpPr>
-          <p:cNvPr id="22" name="t50"/>
+          <p:cNvPr id="22" name="t46"/>
           <p:cNvSpPr txBox="1"/>
           <p:nvPr/>
         </p:nvSpPr>
@@ -10017,7 +10031,7 @@
       </p:sp>
       <p:sp>
         <p:nvSpPr>
-          <p:cNvPr id="23" name="t51"/>
+          <p:cNvPr id="23" name="t47"/>
           <p:cNvSpPr txBox="1"/>
           <p:nvPr/>
         </p:nvSpPr>
@@ -10080,7 +10094,7 @@
       </p:sp>
       <p:sp>
         <p:nvSpPr>
-          <p:cNvPr id="25" name="t53"/>
+          <p:cNvPr id="25" name="t49"/>
           <p:cNvSpPr txBox="1"/>
           <p:nvPr/>
         </p:nvSpPr>
@@ -10116,7 +10130,7 @@
       </p:sp>
       <p:pic>
         <p:nvPicPr>
-          <p:cNvPr id="26" name="eq54" descr="/Users/seanbowman/Documents/MIT/Fall26/6.s974/repo/slides/eqs/control.png">    </p:cNvPr>
+          <p:cNvPr id="26" name="eq50" descr="/Users/seanbowman/Documents/MIT/Fall26/6.s974/repo/slides/eqs/control.png">    </p:cNvPr>
           <p:cNvPicPr>
             <a:picLocks noChangeAspect="1"/>
           </p:cNvPicPr>
@@ -10140,7 +10154,7 @@
       </p:pic>
       <p:sp>
         <p:nvSpPr>
-          <p:cNvPr id="27" name="t55"/>
+          <p:cNvPr id="27" name="t51"/>
           <p:cNvSpPr txBox="1"/>
           <p:nvPr/>
         </p:nvSpPr>
@@ -10176,7 +10190,7 @@
       </p:sp>
       <p:sp>
         <p:nvSpPr>
-          <p:cNvPr id="28" name="t56"/>
+          <p:cNvPr id="28" name="t52"/>
           <p:cNvSpPr txBox="1"/>
           <p:nvPr/>
         </p:nvSpPr>
@@ -10212,7 +10226,7 @@
       </p:sp>
       <p:pic>
         <p:nvPicPr>
-          <p:cNvPr id="29" name="eq57" descr="/Users/seanbowman/Documents/MIT/Fall26/6.s974/repo/slides/eqs/hazard.png">    </p:cNvPr>
+          <p:cNvPr id="29" name="eq53" descr="/Users/seanbowman/Documents/MIT/Fall26/6.s974/repo/slides/eqs/hazard.png">    </p:cNvPr>
           <p:cNvPicPr>
             <a:picLocks noChangeAspect="1"/>
           </p:cNvPicPr>
@@ -10236,7 +10250,7 @@
       </p:pic>
       <p:sp>
         <p:nvSpPr>
-          <p:cNvPr id="30" name="t58"/>
+          <p:cNvPr id="30" name="t54"/>
           <p:cNvSpPr txBox="1"/>
           <p:nvPr/>
         </p:nvSpPr>
@@ -10272,7 +10286,7 @@
       </p:sp>
       <p:sp>
         <p:nvSpPr>
-          <p:cNvPr id="31" name="t59"/>
+          <p:cNvPr id="31" name="t55"/>
           <p:cNvSpPr txBox="1"/>
           <p:nvPr/>
         </p:nvSpPr>
@@ -10308,7 +10322,7 @@
       </p:sp>
       <p:pic>
         <p:nvPicPr>
-          <p:cNvPr id="32" name="eq60" descr="/Users/seanbowman/Documents/MIT/Fall26/6.s974/repo/slides/eqs/stage.png">    </p:cNvPr>
+          <p:cNvPr id="32" name="eq56" descr="/Users/seanbowman/Documents/MIT/Fall26/6.s974/repo/slides/eqs/stage.png">    </p:cNvPr>
           <p:cNvPicPr>
             <a:picLocks noChangeAspect="1"/>
           </p:cNvPicPr>
@@ -10332,7 +10346,7 @@
       </p:pic>
       <p:sp>
         <p:nvSpPr>
-          <p:cNvPr id="33" name="t61"/>
+          <p:cNvPr id="33" name="t57"/>
           <p:cNvSpPr txBox="1"/>
           <p:nvPr/>
         </p:nvSpPr>
@@ -10368,7 +10382,7 @@
       </p:sp>
       <p:sp>
         <p:nvSpPr>
-          <p:cNvPr id="34" name="tk62"/>
+          <p:cNvPr id="34" name="tk58"/>
           <p:cNvSpPr/>
           <p:nvPr/>
         </p:nvSpPr>
@@ -10395,7 +10409,7 @@
       </p:sp>
       <p:sp>
         <p:nvSpPr>
-          <p:cNvPr id="35" name="t63"/>
+          <p:cNvPr id="35" name="t59"/>
           <p:cNvSpPr txBox="1"/>
           <p:nvPr/>
         </p:nvSpPr>
@@ -10550,7 +10564,7 @@
       </p:sp>
       <p:sp>
         <p:nvSpPr>
-          <p:cNvPr id="3" name="t64"/>
+          <p:cNvPr id="3" name="t60"/>
           <p:cNvSpPr txBox="1"/>
           <p:nvPr/>
         </p:nvSpPr>
@@ -10600,7 +10614,7 @@
       </p:sp>
       <p:pic>
         <p:nvPicPr>
-          <p:cNvPr id="4" name="eq65" descr="/Users/seanbowman/Documents/MIT/Fall26/6.s974/repo/slides/eqs/state.png">    </p:cNvPr>
+          <p:cNvPr id="4" name="eq61" descr="/Users/seanbowman/Documents/MIT/Fall26/6.s974/repo/slides/eqs/state.png">    </p:cNvPr>
           <p:cNvPicPr>
             <a:picLocks noChangeAspect="1"/>
           </p:cNvPicPr>
@@ -10624,7 +10638,7 @@
       </p:pic>
       <p:sp>
         <p:nvSpPr>
-          <p:cNvPr id="5" name="fl66"/>
+          <p:cNvPr id="5" name="fl62"/>
           <p:cNvSpPr/>
           <p:nvPr/>
         </p:nvSpPr>
@@ -10647,7 +10661,7 @@
       </p:sp>
       <p:sp>
         <p:nvSpPr>
-          <p:cNvPr id="6" name="t67"/>
+          <p:cNvPr id="6" name="t63"/>
           <p:cNvSpPr txBox="1"/>
           <p:nvPr/>
         </p:nvSpPr>
@@ -10697,7 +10711,7 @@
       </p:sp>
       <p:pic>
         <p:nvPicPr>
-          <p:cNvPr id="7" name="eq68" descr="/Users/seanbowman/Documents/MIT/Fall26/6.s974/repo/slides/eqs/flow.png">    </p:cNvPr>
+          <p:cNvPr id="7" name="eq64" descr="/Users/seanbowman/Documents/MIT/Fall26/6.s974/repo/slides/eqs/flow.png">    </p:cNvPr>
           <p:cNvPicPr>
             <a:picLocks noChangeAspect="1"/>
           </p:cNvPicPr>
@@ -10721,7 +10735,7 @@
       </p:pic>
       <p:sp>
         <p:nvSpPr>
-          <p:cNvPr id="8" name="fl69"/>
+          <p:cNvPr id="8" name="fl65"/>
           <p:cNvSpPr/>
           <p:nvPr/>
         </p:nvSpPr>
@@ -10744,7 +10758,7 @@
       </p:sp>
       <p:sp>
         <p:nvSpPr>
-          <p:cNvPr id="9" name="t70"/>
+          <p:cNvPr id="9" name="t66"/>
           <p:cNvSpPr txBox="1"/>
           <p:nvPr/>
         </p:nvSpPr>
@@ -10794,7 +10808,7 @@
       </p:sp>
       <p:pic>
         <p:nvPicPr>
-          <p:cNvPr id="10" name="eq71" descr="/Users/seanbowman/Documents/MIT/Fall26/6.s974/repo/slides/eqs/budget.png">    </p:cNvPr>
+          <p:cNvPr id="10" name="eq67" descr="/Users/seanbowman/Documents/MIT/Fall26/6.s974/repo/slides/eqs/budget.png">    </p:cNvPr>
           <p:cNvPicPr>
             <a:picLocks noChangeAspect="1"/>
           </p:cNvPicPr>
@@ -10818,7 +10832,7 @@
       </p:pic>
       <p:sp>
         <p:nvSpPr>
-          <p:cNvPr id="11" name="fl72"/>
+          <p:cNvPr id="11" name="fl68"/>
           <p:cNvSpPr/>
           <p:nvPr/>
         </p:nvSpPr>
@@ -10841,7 +10855,7 @@
       </p:sp>
       <p:sp>
         <p:nvSpPr>
-          <p:cNvPr id="12" name="t73"/>
+          <p:cNvPr id="12" name="t69"/>
           <p:cNvSpPr txBox="1"/>
           <p:nvPr/>
         </p:nvSpPr>
@@ -10891,7 +10905,7 @@
       </p:sp>
       <p:pic>
         <p:nvPicPr>
-          <p:cNvPr id="13" name="eq74" descr="/Users/seanbowman/Documents/MIT/Fall26/6.s974/repo/slides/eqs/strength.png">    </p:cNvPr>
+          <p:cNvPr id="13" name="eq70" descr="/Users/seanbowman/Documents/MIT/Fall26/6.s974/repo/slides/eqs/strength.png">    </p:cNvPr>
           <p:cNvPicPr>
             <a:picLocks noChangeAspect="1"/>
           </p:cNvPicPr>
@@ -10915,7 +10929,7 @@
       </p:pic>
       <p:sp>
         <p:nvSpPr>
-          <p:cNvPr id="14" name="fl75"/>
+          <p:cNvPr id="14" name="fl71"/>
           <p:cNvSpPr/>
           <p:nvPr/>
         </p:nvSpPr>
@@ -10938,7 +10952,7 @@
       </p:sp>
       <p:sp>
         <p:nvSpPr>
-          <p:cNvPr id="15" name="t76"/>
+          <p:cNvPr id="15" name="t72"/>
           <p:cNvSpPr txBox="1"/>
           <p:nvPr/>
         </p:nvSpPr>
@@ -10988,7 +11002,7 @@
       </p:sp>
       <p:pic>
         <p:nvPicPr>
-          <p:cNvPr id="16" name="eq77" descr="/Users/seanbowman/Documents/MIT/Fall26/6.s974/repo/slides/eqs/escalation.png">    </p:cNvPr>
+          <p:cNvPr id="16" name="eq73" descr="/Users/seanbowman/Documents/MIT/Fall26/6.s974/repo/slides/eqs/escalation.png">    </p:cNvPr>
           <p:cNvPicPr>
             <a:picLocks noChangeAspect="1"/>
           </p:cNvPicPr>
@@ -11012,7 +11026,7 @@
       </p:pic>
       <p:sp>
         <p:nvSpPr>
-          <p:cNvPr id="17" name="fl78"/>
+          <p:cNvPr id="17" name="fl74"/>
           <p:cNvSpPr/>
           <p:nvPr/>
         </p:nvSpPr>
@@ -11035,7 +11049,7 @@
       </p:sp>
       <p:sp>
         <p:nvSpPr>
-          <p:cNvPr id="18" name="t79"/>
+          <p:cNvPr id="18" name="t75"/>
           <p:cNvSpPr txBox="1"/>
           <p:nvPr/>
         </p:nvSpPr>
@@ -11085,7 +11099,7 @@
       </p:sp>
       <p:pic>
         <p:nvPicPr>
-          <p:cNvPr id="19" name="eq80" descr="/Users/seanbowman/Documents/MIT/Fall26/6.s974/repo/slides/eqs/total.png">    </p:cNvPr>
+          <p:cNvPr id="19" name="eq76" descr="/Users/seanbowman/Documents/MIT/Fall26/6.s974/repo/slides/eqs/total.png">    </p:cNvPr>
           <p:cNvPicPr>
             <a:picLocks noChangeAspect="1"/>
           </p:cNvPicPr>
@@ -11109,7 +11123,7 @@
       </p:pic>
       <p:sp>
         <p:nvSpPr>
-          <p:cNvPr id="20" name="tk81"/>
+          <p:cNvPr id="20" name="tk77"/>
           <p:cNvSpPr/>
           <p:nvPr/>
         </p:nvSpPr>
@@ -11136,7 +11150,7 @@
       </p:sp>
       <p:sp>
         <p:nvSpPr>
-          <p:cNvPr id="21" name="t82"/>
+          <p:cNvPr id="21" name="t78"/>
           <p:cNvSpPr txBox="1"/>
           <p:nvPr/>
         </p:nvSpPr>
@@ -11291,7 +11305,7 @@
       </p:sp>
       <p:sp>
         <p:nvSpPr>
-          <p:cNvPr id="3" name="cd83"/>
+          <p:cNvPr id="3" name="cd79"/>
           <p:cNvSpPr/>
           <p:nvPr/>
         </p:nvSpPr>
@@ -11316,7 +11330,7 @@
       </p:sp>
       <p:sp>
         <p:nvSpPr>
-          <p:cNvPr id="4" name="cdh84"/>
+          <p:cNvPr id="4" name="cdh80"/>
           <p:cNvSpPr/>
           <p:nvPr/>
         </p:nvSpPr>
@@ -11341,7 +11355,7 @@
       </p:sp>
       <p:sp>
         <p:nvSpPr>
-          <p:cNvPr id="5" name="t85"/>
+          <p:cNvPr id="5" name="t81"/>
           <p:cNvSpPr txBox="1"/>
           <p:nvPr/>
         </p:nvSpPr>
@@ -11377,7 +11391,7 @@
       </p:sp>
       <p:sp>
         <p:nvSpPr>
-          <p:cNvPr id="6" name="t86"/>
+          <p:cNvPr id="6" name="t82"/>
           <p:cNvSpPr txBox="1"/>
           <p:nvPr/>
         </p:nvSpPr>
@@ -11433,7 +11447,7 @@
       </p:sp>
       <p:sp>
         <p:nvSpPr>
-          <p:cNvPr id="7" name="t87"/>
+          <p:cNvPr id="7" name="t83"/>
           <p:cNvSpPr txBox="1"/>
           <p:nvPr/>
         </p:nvSpPr>
@@ -11469,7 +11483,7 @@
       </p:sp>
       <p:sp>
         <p:nvSpPr>
-          <p:cNvPr id="8" name="cd88"/>
+          <p:cNvPr id="8" name="cd84"/>
           <p:cNvSpPr/>
           <p:nvPr/>
         </p:nvSpPr>
@@ -11494,7 +11508,7 @@
       </p:sp>
       <p:sp>
         <p:nvSpPr>
-          <p:cNvPr id="9" name="cdh89"/>
+          <p:cNvPr id="9" name="cdh85"/>
           <p:cNvSpPr/>
           <p:nvPr/>
         </p:nvSpPr>
@@ -11519,7 +11533,7 @@
       </p:sp>
       <p:sp>
         <p:nvSpPr>
-          <p:cNvPr id="10" name="t90"/>
+          <p:cNvPr id="10" name="t86"/>
           <p:cNvSpPr txBox="1"/>
           <p:nvPr/>
         </p:nvSpPr>
@@ -11555,7 +11569,7 @@
       </p:sp>
       <p:sp>
         <p:nvSpPr>
-          <p:cNvPr id="11" name="t91"/>
+          <p:cNvPr id="11" name="t87"/>
           <p:cNvSpPr txBox="1"/>
           <p:nvPr/>
         </p:nvSpPr>
@@ -11611,7 +11625,7 @@
       </p:sp>
       <p:sp>
         <p:nvSpPr>
-          <p:cNvPr id="12" name="t92"/>
+          <p:cNvPr id="12" name="t88"/>
           <p:cNvSpPr txBox="1"/>
           <p:nvPr/>
         </p:nvSpPr>
@@ -11647,7 +11661,7 @@
       </p:sp>
       <p:sp>
         <p:nvSpPr>
-          <p:cNvPr id="13" name="cd93"/>
+          <p:cNvPr id="13" name="cd89"/>
           <p:cNvSpPr/>
           <p:nvPr/>
         </p:nvSpPr>
@@ -11672,7 +11686,7 @@
       </p:sp>
       <p:sp>
         <p:nvSpPr>
-          <p:cNvPr id="14" name="cdh94"/>
+          <p:cNvPr id="14" name="cdh90"/>
           <p:cNvSpPr/>
           <p:nvPr/>
         </p:nvSpPr>
@@ -11697,7 +11711,7 @@
       </p:sp>
       <p:sp>
         <p:nvSpPr>
-          <p:cNvPr id="15" name="t95"/>
+          <p:cNvPr id="15" name="t91"/>
           <p:cNvSpPr txBox="1"/>
           <p:nvPr/>
         </p:nvSpPr>
@@ -11733,7 +11747,7 @@
       </p:sp>
       <p:sp>
         <p:nvSpPr>
-          <p:cNvPr id="16" name="t96"/>
+          <p:cNvPr id="16" name="t92"/>
           <p:cNvSpPr txBox="1"/>
           <p:nvPr/>
         </p:nvSpPr>
@@ -11839,7 +11853,7 @@
       </p:sp>
       <p:sp>
         <p:nvSpPr>
-          <p:cNvPr id="17" name="t97"/>
+          <p:cNvPr id="17" name="t93"/>
           <p:cNvSpPr txBox="1"/>
           <p:nvPr/>
         </p:nvSpPr>
@@ -11875,7 +11889,7 @@
       </p:sp>
       <p:sp>
         <p:nvSpPr>
-          <p:cNvPr id="18" name="tk98"/>
+          <p:cNvPr id="18" name="tk94"/>
           <p:cNvSpPr/>
           <p:nvPr/>
         </p:nvSpPr>
@@ -11902,7 +11916,7 @@
       </p:sp>
       <p:sp>
         <p:nvSpPr>
-          <p:cNvPr id="19" name="t99"/>
+          <p:cNvPr id="19" name="t95"/>
           <p:cNvSpPr txBox="1"/>
           <p:nvPr/>
         </p:nvSpPr>
@@ -12057,7 +12071,7 @@
       </p:sp>
       <p:pic>
         <p:nvPicPr>
-          <p:cNvPr id="3" name="eq100" descr="/Users/seanbowman/Documents/MIT/Fall26/6.s974/repo/slides/eqs/mip.png">    </p:cNvPr>
+          <p:cNvPr id="3" name="eq96" descr="/Users/seanbowman/Documents/MIT/Fall26/6.s974/repo/slides/eqs/mip.png">    </p:cNvPr>
           <p:cNvPicPr>
             <a:picLocks noChangeAspect="1"/>
           </p:cNvPicPr>
@@ -12081,7 +12095,7 @@
       </p:pic>
       <p:sp>
         <p:nvSpPr>
-          <p:cNvPr id="4" name="t101"/>
+          <p:cNvPr id="4" name="t97"/>
           <p:cNvSpPr txBox="1"/>
           <p:nvPr/>
         </p:nvSpPr>
@@ -12117,7 +12131,7 @@
       </p:sp>
       <p:pic>
         <p:nvPicPr>
-          <p:cNvPr id="5" name="eq102" descr="/Users/seanbowman/Documents/MIT/Fall26/6.s974/repo/slides/eqs/option.png">    </p:cNvPr>
+          <p:cNvPr id="5" name="eq98" descr="/Users/seanbowman/Documents/MIT/Fall26/6.s974/repo/slides/eqs/option.png">    </p:cNvPr>
           <p:cNvPicPr>
             <a:picLocks noChangeAspect="1"/>
           </p:cNvPicPr>
@@ -12141,7 +12155,7 @@
       </p:pic>
       <p:sp>
         <p:nvSpPr>
-          <p:cNvPr id="6" name="t103"/>
+          <p:cNvPr id="6" name="t99"/>
           <p:cNvSpPr txBox="1"/>
           <p:nvPr/>
         </p:nvSpPr>
@@ -12279,7 +12293,7 @@
       </p:sp>
       <p:sp>
         <p:nvSpPr>
-          <p:cNvPr id="7" name="tk104"/>
+          <p:cNvPr id="7" name="tk100"/>
           <p:cNvSpPr/>
           <p:nvPr/>
         </p:nvSpPr>
@@ -12306,7 +12320,7 @@
       </p:sp>
       <p:sp>
         <p:nvSpPr>
-          <p:cNvPr id="8" name="t105"/>
+          <p:cNvPr id="8" name="t101"/>
           <p:cNvSpPr txBox="1"/>
           <p:nvPr/>
         </p:nvSpPr>
@@ -13029,7 +13043,7 @@
       </p:graphicFrame>
       <p:sp>
         <p:nvSpPr>
-          <p:cNvPr id="4" name="t107"/>
+          <p:cNvPr id="4" name="t103"/>
           <p:cNvSpPr txBox="1"/>
           <p:nvPr/>
         </p:nvSpPr>
@@ -13065,7 +13079,7 @@
       </p:sp>
       <p:sp>
         <p:nvSpPr>
-          <p:cNvPr id="5" name="t108"/>
+          <p:cNvPr id="5" name="t104"/>
           <p:cNvSpPr txBox="1"/>
           <p:nvPr/>
         </p:nvSpPr>
@@ -13174,7 +13188,7 @@
       </p:sp>
       <p:sp>
         <p:nvSpPr>
-          <p:cNvPr id="6" name="tk109"/>
+          <p:cNvPr id="6" name="tk105"/>
           <p:cNvSpPr/>
           <p:nvPr/>
         </p:nvSpPr>
@@ -13201,7 +13215,7 @@
       </p:sp>
       <p:sp>
         <p:nvSpPr>
-          <p:cNvPr id="7" name="t110"/>
+          <p:cNvPr id="7" name="t106"/>
           <p:cNvSpPr txBox="1"/>
           <p:nvPr/>
         </p:nvSpPr>

</xml_diff>